<commit_message>
copy(submission/s2): mirror deck slide 2 foot update in PPT and PDF
Hand-edited the settled-economics close into slide 2 of the
submission PPT, then regenerated the PDF via
export_pptx_to_pdf.py so the submission artefacts now match the
HTML deck.

Co-Authored-By: Claude Opus 4.7 (1M context) <noreply@anthropic.com>
</commit_message>
<xml_diff>
--- a/submission/Resona.pptx
+++ b/submission/Resona.pptx
@@ -10984,7 +10984,7 @@
         </p:nvSpPr>
         <p:spPr>
           <a:xfrm>
-            <a:off x="685738" y="3299570"/>
+            <a:off x="685763" y="2194570"/>
             <a:ext cx="5669400" cy="769500"/>
           </a:xfrm>
           <a:prstGeom prst="rect">
@@ -11034,8 +11034,8 @@
         </p:nvSpPr>
         <p:spPr>
           <a:xfrm>
-            <a:off x="685800" y="4069080"/>
-            <a:ext cx="5669280" cy="411480"/>
+            <a:off x="685825" y="2964080"/>
+            <a:ext cx="5669400" cy="184800"/>
           </a:xfrm>
           <a:prstGeom prst="rect">
             <a:avLst/>
@@ -11084,8 +11084,8 @@
         </p:nvSpPr>
         <p:spPr>
           <a:xfrm>
-            <a:off x="685800" y="4434840"/>
-            <a:ext cx="5669280" cy="411480"/>
+            <a:off x="685825" y="3329840"/>
+            <a:ext cx="5669400" cy="307800"/>
           </a:xfrm>
           <a:prstGeom prst="rect">
             <a:avLst/>
@@ -11134,7 +11134,7 @@
         </p:nvSpPr>
         <p:spPr>
           <a:xfrm>
-            <a:off x="685675" y="4937755"/>
+            <a:off x="685700" y="3832755"/>
             <a:ext cx="5669400" cy="323100"/>
           </a:xfrm>
           <a:prstGeom prst="rect">
@@ -11184,7 +11184,7 @@
         </p:nvSpPr>
         <p:spPr>
           <a:xfrm>
-            <a:off x="685800" y="4937754"/>
+            <a:off x="685825" y="3832754"/>
             <a:ext cx="25500" cy="431100"/>
           </a:xfrm>
           <a:prstGeom prst="rect">
@@ -12848,7 +12848,7 @@
         <p:spPr>
           <a:xfrm>
             <a:off x="685788" y="1358813"/>
-            <a:ext cx="10820100" cy="1847100"/>
+            <a:ext cx="10820100" cy="2308800"/>
           </a:xfrm>
           <a:prstGeom prst="rect">
             <a:avLst/>
@@ -12888,31 +12888,8 @@
                 <a:cs typeface="Times New Roman"/>
                 <a:sym typeface="Times New Roman"/>
               </a:rPr>
-              <a:t>3.5M Britons have undiagnosed COPD </a:t>
+              <a:t>By supporting the </a:t>
             </a:r>
-            <a:r>
-              <a:rPr lang="en-US">
-                <a:solidFill>
-                  <a:srgbClr val="F4ECE1"/>
-                </a:solidFill>
-                <a:latin typeface="Times New Roman"/>
-                <a:ea typeface="Times New Roman"/>
-                <a:cs typeface="Times New Roman"/>
-                <a:sym typeface="Times New Roman"/>
-              </a:rPr>
-              <a:t>(a group of lung conditions that cause breathing difficulties )</a:t>
-            </a:r>
-            <a:br>
-              <a:rPr lang="en-US" sz="3000">
-                <a:solidFill>
-                  <a:srgbClr val="F4ECE1"/>
-                </a:solidFill>
-                <a:latin typeface="Times New Roman"/>
-                <a:ea typeface="Times New Roman"/>
-                <a:cs typeface="Times New Roman"/>
-                <a:sym typeface="Times New Roman"/>
-              </a:rPr>
-            </a:br>
             <a:r>
               <a:rPr lang="en-US" sz="3000">
                 <a:solidFill>
@@ -12923,19 +12900,8 @@
                 <a:cs typeface="Times New Roman"/>
                 <a:sym typeface="Times New Roman"/>
               </a:rPr>
-              <a:t>NHS spirometry wait is 3-12 months, Private spirometry £150. </a:t>
+              <a:t>improvement</a:t>
             </a:r>
-            <a:br>
-              <a:rPr lang="en-US" sz="3000">
-                <a:solidFill>
-                  <a:srgbClr val="F4ECE1"/>
-                </a:solidFill>
-                <a:latin typeface="Times New Roman"/>
-                <a:ea typeface="Times New Roman"/>
-                <a:cs typeface="Times New Roman"/>
-                <a:sym typeface="Times New Roman"/>
-              </a:rPr>
-            </a:br>
             <a:r>
               <a:rPr lang="en-US" sz="3000">
                 <a:solidFill>
@@ -12946,7 +12912,35 @@
                 <a:cs typeface="Times New Roman"/>
                 <a:sym typeface="Times New Roman"/>
               </a:rPr>
-              <a:t>Not everyone can get tested, Everyone has a phone</a:t>
+              <a:t> of employees’ health and wellness directly, businesses are able to be more productive,, less absent, and longer-tenured. The economics are settled. The delivery is not.</a:t>
+            </a:r>
+            <a:endParaRPr sz="3000">
+              <a:solidFill>
+                <a:srgbClr val="F4ECE1"/>
+              </a:solidFill>
+              <a:latin typeface="Times New Roman"/>
+              <a:ea typeface="Times New Roman"/>
+              <a:cs typeface="Times New Roman"/>
+              <a:sym typeface="Times New Roman"/>
+            </a:endParaRPr>
+          </a:p>
+          <a:p>
+            <a:pPr indent="0" lvl="0" marL="0" rtl="0" algn="ctr">
+              <a:spcBef>
+                <a:spcPts val="0"/>
+              </a:spcBef>
+              <a:spcAft>
+                <a:spcPts val="0"/>
+              </a:spcAft>
+              <a:buClr>
+                <a:schemeClr val="dk1"/>
+              </a:buClr>
+              <a:buSzPts val="1100"/>
+              <a:buFont typeface="Arial"/>
+              <a:buNone/>
+            </a:pPr>
+            <a:r>
+              <a:t/>
             </a:r>
             <a:endParaRPr sz="3000">
               <a:solidFill>
@@ -15791,7 +15785,7 @@
         <p:spPr>
           <a:xfrm>
             <a:off x="685800" y="1188720"/>
-            <a:ext cx="6400800" cy="365760"/>
+            <a:ext cx="6400800" cy="169200"/>
           </a:xfrm>
           <a:prstGeom prst="rect">
             <a:avLst/>
@@ -15826,7 +15820,15 @@
                 <a:cs typeface="Arial"/>
                 <a:sym typeface="Arial"/>
               </a:rPr>
-              <a:t>● LIVE · ON THE PROJECTOR BESIDE ME</a:t>
+              <a:t>● LIVE </a:t>
+            </a:r>
+            <a:r>
+              <a:rPr b="1" lang="en-US" sz="1100">
+                <a:solidFill>
+                  <a:srgbClr val="D18589"/>
+                </a:solidFill>
+              </a:rPr>
+              <a:t>DEMO</a:t>
             </a:r>
             <a:endParaRPr/>
           </a:p>
@@ -16288,7 +16290,7 @@
                 <a:cs typeface="Arial"/>
                 <a:sym typeface="Arial"/>
               </a:rPr>
-              <a:t>See your numbers, your GP letter, your team on the board.</a:t>
+              <a:t>See your analysis, your numbers, and your team on the board.</a:t>
             </a:r>
             <a:endParaRPr/>
           </a:p>
@@ -16697,6 +16699,285 @@
 </file>
 
 <file path=ppt/theme/theme1.xml><?xml version="1.0" encoding="utf-8"?>
+<a:theme xmlns:a="http://schemas.openxmlformats.org/drawingml/2006/main" xmlns:r="http://schemas.openxmlformats.org/officeDocument/2006/relationships">
+  <a:themeElements>
+    <a:clrScheme name="Default">
+      <a:dk1>
+        <a:srgbClr val="000000"/>
+      </a:dk1>
+      <a:lt1>
+        <a:srgbClr val="FFFFFF"/>
+      </a:lt1>
+      <a:dk2>
+        <a:srgbClr val="158158"/>
+      </a:dk2>
+      <a:lt2>
+        <a:srgbClr val="F3F3F3"/>
+      </a:lt2>
+      <a:accent1>
+        <a:srgbClr val="058DC7"/>
+      </a:accent1>
+      <a:accent2>
+        <a:srgbClr val="50B432"/>
+      </a:accent2>
+      <a:accent3>
+        <a:srgbClr val="ED561B"/>
+      </a:accent3>
+      <a:accent4>
+        <a:srgbClr val="EDEF00"/>
+      </a:accent4>
+      <a:accent5>
+        <a:srgbClr val="24CBE5"/>
+      </a:accent5>
+      <a:accent6>
+        <a:srgbClr val="64E572"/>
+      </a:accent6>
+      <a:hlink>
+        <a:srgbClr val="2200CC"/>
+      </a:hlink>
+      <a:folHlink>
+        <a:srgbClr val="551A8B"/>
+      </a:folHlink>
+    </a:clrScheme>
+    <a:fontScheme name="Office">
+      <a:majorFont>
+        <a:latin typeface="Arial"/>
+        <a:ea typeface=""/>
+        <a:cs typeface=""/>
+        <a:font script="Jpan" typeface="ＭＳ Ｐゴシック"/>
+        <a:font script="Hang" typeface="맑은 고딕"/>
+        <a:font script="Hans" typeface="宋体"/>
+        <a:font script="Hant" typeface="新細明體"/>
+        <a:font script="Arab" typeface="Times New Roman"/>
+        <a:font script="Hebr" typeface="Times New Roman"/>
+        <a:font script="Thai" typeface="Angsana New"/>
+        <a:font script="Ethi" typeface="Nyala"/>
+        <a:font script="Beng" typeface="Vrinda"/>
+        <a:font script="Gujr" typeface="Shruti"/>
+        <a:font script="Khmr" typeface="MoolBoran"/>
+        <a:font script="Knda" typeface="Tunga"/>
+        <a:font script="Guru" typeface="Raavi"/>
+        <a:font script="Cans" typeface="Euphemia"/>
+        <a:font script="Cher" typeface="Plantagenet Cherokee"/>
+        <a:font script="Yiii" typeface="Microsoft Yi Baiti"/>
+        <a:font script="Tibt" typeface="Microsoft Himalaya"/>
+        <a:font script="Thaa" typeface="MV Boli"/>
+        <a:font script="Deva" typeface="Mangal"/>
+        <a:font script="Telu" typeface="Gautami"/>
+        <a:font script="Taml" typeface="Latha"/>
+        <a:font script="Syrc" typeface="Estrangelo Edessa"/>
+        <a:font script="Orya" typeface="Kalinga"/>
+        <a:font script="Mlym" typeface="Kartika"/>
+        <a:font script="Laoo" typeface="DokChampa"/>
+        <a:font script="Sinh" typeface="Iskoola Pota"/>
+        <a:font script="Mong" typeface="Mongolian Baiti"/>
+        <a:font script="Viet" typeface="Times New Roman"/>
+        <a:font script="Uigh" typeface="Microsoft Uighur"/>
+        <a:font script="Geor" typeface="Sylfaen"/>
+      </a:majorFont>
+      <a:minorFont>
+        <a:latin typeface="Arial"/>
+        <a:ea typeface=""/>
+        <a:cs typeface=""/>
+        <a:font script="Jpan" typeface="ＭＳ Ｐゴシック"/>
+        <a:font script="Hang" typeface="맑은 고딕"/>
+        <a:font script="Hans" typeface="宋体"/>
+        <a:font script="Hant" typeface="新細明體"/>
+        <a:font script="Arab" typeface="Arial"/>
+        <a:font script="Hebr" typeface="Arial"/>
+        <a:font script="Thai" typeface="Cordia New"/>
+        <a:font script="Ethi" typeface="Nyala"/>
+        <a:font script="Beng" typeface="Vrinda"/>
+        <a:font script="Gujr" typeface="Shruti"/>
+        <a:font script="Khmr" typeface="DaunPenh"/>
+        <a:font script="Knda" typeface="Tunga"/>
+        <a:font script="Guru" typeface="Raavi"/>
+        <a:font script="Cans" typeface="Euphemia"/>
+        <a:font script="Cher" typeface="Plantagenet Cherokee"/>
+        <a:font script="Yiii" typeface="Microsoft Yi Baiti"/>
+        <a:font script="Tibt" typeface="Microsoft Himalaya"/>
+        <a:font script="Thaa" typeface="MV Boli"/>
+        <a:font script="Deva" typeface="Mangal"/>
+        <a:font script="Telu" typeface="Gautami"/>
+        <a:font script="Taml" typeface="Latha"/>
+        <a:font script="Syrc" typeface="Estrangelo Edessa"/>
+        <a:font script="Orya" typeface="Kalinga"/>
+        <a:font script="Mlym" typeface="Kartika"/>
+        <a:font script="Laoo" typeface="DokChampa"/>
+        <a:font script="Sinh" typeface="Iskoola Pota"/>
+        <a:font script="Mong" typeface="Mongolian Baiti"/>
+        <a:font script="Viet" typeface="Arial"/>
+        <a:font script="Uigh" typeface="Microsoft Uighur"/>
+        <a:font script="Geor" typeface="Sylfaen"/>
+      </a:minorFont>
+    </a:fontScheme>
+    <a:fmtScheme name="Office">
+      <a:fillStyleLst>
+        <a:solidFill>
+          <a:schemeClr val="phClr"/>
+        </a:solidFill>
+        <a:gradFill rotWithShape="1">
+          <a:gsLst>
+            <a:gs pos="0">
+              <a:schemeClr val="phClr">
+                <a:tint val="50000"/>
+                <a:satMod val="300000"/>
+              </a:schemeClr>
+            </a:gs>
+            <a:gs pos="35000">
+              <a:schemeClr val="phClr">
+                <a:tint val="37000"/>
+                <a:satMod val="300000"/>
+              </a:schemeClr>
+            </a:gs>
+            <a:gs pos="100000">
+              <a:schemeClr val="phClr">
+                <a:tint val="15000"/>
+                <a:satMod val="350000"/>
+              </a:schemeClr>
+            </a:gs>
+          </a:gsLst>
+          <a:lin ang="16200000" scaled="1"/>
+        </a:gradFill>
+        <a:gradFill rotWithShape="1">
+          <a:gsLst>
+            <a:gs pos="0">
+              <a:schemeClr val="phClr">
+                <a:tint val="100000"/>
+                <a:shade val="100000"/>
+                <a:satMod val="130000"/>
+              </a:schemeClr>
+            </a:gs>
+            <a:gs pos="100000">
+              <a:schemeClr val="phClr">
+                <a:tint val="50000"/>
+                <a:shade val="100000"/>
+                <a:satMod val="350000"/>
+              </a:schemeClr>
+            </a:gs>
+          </a:gsLst>
+          <a:lin ang="16200000" scaled="0"/>
+        </a:gradFill>
+      </a:fillStyleLst>
+      <a:lnStyleLst>
+        <a:ln w="9525" cap="flat" cmpd="sng" algn="ctr">
+          <a:solidFill>
+            <a:schemeClr val="phClr">
+              <a:shade val="95000"/>
+              <a:satMod val="105000"/>
+            </a:schemeClr>
+          </a:solidFill>
+          <a:prstDash val="solid"/>
+        </a:ln>
+        <a:ln w="25400" cap="flat" cmpd="sng" algn="ctr">
+          <a:solidFill>
+            <a:schemeClr val="phClr"/>
+          </a:solidFill>
+          <a:prstDash val="solid"/>
+        </a:ln>
+        <a:ln w="38100" cap="flat" cmpd="sng" algn="ctr">
+          <a:solidFill>
+            <a:schemeClr val="phClr"/>
+          </a:solidFill>
+          <a:prstDash val="solid"/>
+        </a:ln>
+      </a:lnStyleLst>
+      <a:effectStyleLst>
+        <a:effectStyle>
+          <a:effectLst>
+            <a:outerShdw blurRad="40000" dist="20000" dir="5400000" rotWithShape="0">
+              <a:srgbClr val="000000">
+                <a:alpha val="38000"/>
+              </a:srgbClr>
+            </a:outerShdw>
+          </a:effectLst>
+        </a:effectStyle>
+        <a:effectStyle>
+          <a:effectLst>
+            <a:outerShdw blurRad="40000" dist="23000" dir="5400000" rotWithShape="0">
+              <a:srgbClr val="000000">
+                <a:alpha val="35000"/>
+              </a:srgbClr>
+            </a:outerShdw>
+          </a:effectLst>
+        </a:effectStyle>
+        <a:effectStyle>
+          <a:effectLst>
+            <a:outerShdw blurRad="40000" dist="23000" dir="5400000" rotWithShape="0">
+              <a:srgbClr val="000000">
+                <a:alpha val="35000"/>
+              </a:srgbClr>
+            </a:outerShdw>
+          </a:effectLst>
+          <a:scene3d>
+            <a:camera prst="orthographicFront">
+              <a:rot lat="0" lon="0" rev="0"/>
+            </a:camera>
+            <a:lightRig rig="threePt" dir="t">
+              <a:rot lat="0" lon="0" rev="1200000"/>
+            </a:lightRig>
+          </a:scene3d>
+          <a:sp3d>
+            <a:bevelT w="63500" h="25400"/>
+          </a:sp3d>
+        </a:effectStyle>
+      </a:effectStyleLst>
+      <a:bgFillStyleLst>
+        <a:solidFill>
+          <a:schemeClr val="phClr"/>
+        </a:solidFill>
+        <a:gradFill rotWithShape="1">
+          <a:gsLst>
+            <a:gs pos="0">
+              <a:schemeClr val="phClr">
+                <a:tint val="40000"/>
+                <a:satMod val="350000"/>
+              </a:schemeClr>
+            </a:gs>
+            <a:gs pos="40000">
+              <a:schemeClr val="phClr">
+                <a:tint val="45000"/>
+                <a:shade val="99000"/>
+                <a:satMod val="350000"/>
+              </a:schemeClr>
+            </a:gs>
+            <a:gs pos="100000">
+              <a:schemeClr val="phClr">
+                <a:shade val="20000"/>
+                <a:satMod val="255000"/>
+              </a:schemeClr>
+            </a:gs>
+          </a:gsLst>
+          <a:path path="circle">
+            <a:fillToRect l="50000" t="-80000" r="50000" b="180000"/>
+          </a:path>
+        </a:gradFill>
+        <a:gradFill rotWithShape="1">
+          <a:gsLst>
+            <a:gs pos="0">
+              <a:schemeClr val="phClr">
+                <a:tint val="80000"/>
+                <a:satMod val="300000"/>
+              </a:schemeClr>
+            </a:gs>
+            <a:gs pos="100000">
+              <a:schemeClr val="phClr">
+                <a:shade val="30000"/>
+                <a:satMod val="200000"/>
+              </a:schemeClr>
+            </a:gs>
+          </a:gsLst>
+          <a:path path="circle">
+            <a:fillToRect l="50000" t="50000" r="50000" b="50000"/>
+          </a:path>
+        </a:gradFill>
+      </a:bgFillStyleLst>
+    </a:fmtScheme>
+  </a:themeElements>
+</a:theme>
+</file>
+
+<file path=ppt/theme/theme2.xml><?xml version="1.0" encoding="utf-8"?>
 <a:theme xmlns:a="http://schemas.openxmlformats.org/drawingml/2006/main" xmlns:r="http://schemas.openxmlformats.org/officeDocument/2006/relationships" name="Office Theme">
   <a:themeElements>
     <a:clrScheme name="Office">
@@ -16973,283 +17254,4 @@
     </a:fmtScheme>
   </a:themeElements>
 </a:theme>
-</file>
-
-<file path=ppt/theme/theme2.xml><?xml version="1.0" encoding="utf-8"?>
-<a:theme xmlns:a="http://schemas.openxmlformats.org/drawingml/2006/main" xmlns:r="http://schemas.openxmlformats.org/officeDocument/2006/relationships">
-  <a:themeElements>
-    <a:clrScheme name="Default">
-      <a:dk1>
-        <a:srgbClr val="000000"/>
-      </a:dk1>
-      <a:lt1>
-        <a:srgbClr val="FFFFFF"/>
-      </a:lt1>
-      <a:dk2>
-        <a:srgbClr val="158158"/>
-      </a:dk2>
-      <a:lt2>
-        <a:srgbClr val="F3F3F3"/>
-      </a:lt2>
-      <a:accent1>
-        <a:srgbClr val="058DC7"/>
-      </a:accent1>
-      <a:accent2>
-        <a:srgbClr val="50B432"/>
-      </a:accent2>
-      <a:accent3>
-        <a:srgbClr val="ED561B"/>
-      </a:accent3>
-      <a:accent4>
-        <a:srgbClr val="EDEF00"/>
-      </a:accent4>
-      <a:accent5>
-        <a:srgbClr val="24CBE5"/>
-      </a:accent5>
-      <a:accent6>
-        <a:srgbClr val="64E572"/>
-      </a:accent6>
-      <a:hlink>
-        <a:srgbClr val="2200CC"/>
-      </a:hlink>
-      <a:folHlink>
-        <a:srgbClr val="551A8B"/>
-      </a:folHlink>
-    </a:clrScheme>
-    <a:fontScheme name="Office">
-      <a:majorFont>
-        <a:latin typeface="Arial"/>
-        <a:ea typeface=""/>
-        <a:cs typeface=""/>
-        <a:font script="Jpan" typeface="ＭＳ Ｐゴシック"/>
-        <a:font script="Hang" typeface="맑은 고딕"/>
-        <a:font script="Hans" typeface="宋体"/>
-        <a:font script="Hant" typeface="新細明體"/>
-        <a:font script="Arab" typeface="Times New Roman"/>
-        <a:font script="Hebr" typeface="Times New Roman"/>
-        <a:font script="Thai" typeface="Angsana New"/>
-        <a:font script="Ethi" typeface="Nyala"/>
-        <a:font script="Beng" typeface="Vrinda"/>
-        <a:font script="Gujr" typeface="Shruti"/>
-        <a:font script="Khmr" typeface="MoolBoran"/>
-        <a:font script="Knda" typeface="Tunga"/>
-        <a:font script="Guru" typeface="Raavi"/>
-        <a:font script="Cans" typeface="Euphemia"/>
-        <a:font script="Cher" typeface="Plantagenet Cherokee"/>
-        <a:font script="Yiii" typeface="Microsoft Yi Baiti"/>
-        <a:font script="Tibt" typeface="Microsoft Himalaya"/>
-        <a:font script="Thaa" typeface="MV Boli"/>
-        <a:font script="Deva" typeface="Mangal"/>
-        <a:font script="Telu" typeface="Gautami"/>
-        <a:font script="Taml" typeface="Latha"/>
-        <a:font script="Syrc" typeface="Estrangelo Edessa"/>
-        <a:font script="Orya" typeface="Kalinga"/>
-        <a:font script="Mlym" typeface="Kartika"/>
-        <a:font script="Laoo" typeface="DokChampa"/>
-        <a:font script="Sinh" typeface="Iskoola Pota"/>
-        <a:font script="Mong" typeface="Mongolian Baiti"/>
-        <a:font script="Viet" typeface="Times New Roman"/>
-        <a:font script="Uigh" typeface="Microsoft Uighur"/>
-        <a:font script="Geor" typeface="Sylfaen"/>
-      </a:majorFont>
-      <a:minorFont>
-        <a:latin typeface="Arial"/>
-        <a:ea typeface=""/>
-        <a:cs typeface=""/>
-        <a:font script="Jpan" typeface="ＭＳ Ｐゴシック"/>
-        <a:font script="Hang" typeface="맑은 고딕"/>
-        <a:font script="Hans" typeface="宋体"/>
-        <a:font script="Hant" typeface="新細明體"/>
-        <a:font script="Arab" typeface="Arial"/>
-        <a:font script="Hebr" typeface="Arial"/>
-        <a:font script="Thai" typeface="Cordia New"/>
-        <a:font script="Ethi" typeface="Nyala"/>
-        <a:font script="Beng" typeface="Vrinda"/>
-        <a:font script="Gujr" typeface="Shruti"/>
-        <a:font script="Khmr" typeface="DaunPenh"/>
-        <a:font script="Knda" typeface="Tunga"/>
-        <a:font script="Guru" typeface="Raavi"/>
-        <a:font script="Cans" typeface="Euphemia"/>
-        <a:font script="Cher" typeface="Plantagenet Cherokee"/>
-        <a:font script="Yiii" typeface="Microsoft Yi Baiti"/>
-        <a:font script="Tibt" typeface="Microsoft Himalaya"/>
-        <a:font script="Thaa" typeface="MV Boli"/>
-        <a:font script="Deva" typeface="Mangal"/>
-        <a:font script="Telu" typeface="Gautami"/>
-        <a:font script="Taml" typeface="Latha"/>
-        <a:font script="Syrc" typeface="Estrangelo Edessa"/>
-        <a:font script="Orya" typeface="Kalinga"/>
-        <a:font script="Mlym" typeface="Kartika"/>
-        <a:font script="Laoo" typeface="DokChampa"/>
-        <a:font script="Sinh" typeface="Iskoola Pota"/>
-        <a:font script="Mong" typeface="Mongolian Baiti"/>
-        <a:font script="Viet" typeface="Arial"/>
-        <a:font script="Uigh" typeface="Microsoft Uighur"/>
-        <a:font script="Geor" typeface="Sylfaen"/>
-      </a:minorFont>
-    </a:fontScheme>
-    <a:fmtScheme name="Office">
-      <a:fillStyleLst>
-        <a:solidFill>
-          <a:schemeClr val="phClr"/>
-        </a:solidFill>
-        <a:gradFill rotWithShape="1">
-          <a:gsLst>
-            <a:gs pos="0">
-              <a:schemeClr val="phClr">
-                <a:tint val="50000"/>
-                <a:satMod val="300000"/>
-              </a:schemeClr>
-            </a:gs>
-            <a:gs pos="35000">
-              <a:schemeClr val="phClr">
-                <a:tint val="37000"/>
-                <a:satMod val="300000"/>
-              </a:schemeClr>
-            </a:gs>
-            <a:gs pos="100000">
-              <a:schemeClr val="phClr">
-                <a:tint val="15000"/>
-                <a:satMod val="350000"/>
-              </a:schemeClr>
-            </a:gs>
-          </a:gsLst>
-          <a:lin ang="16200000" scaled="1"/>
-        </a:gradFill>
-        <a:gradFill rotWithShape="1">
-          <a:gsLst>
-            <a:gs pos="0">
-              <a:schemeClr val="phClr">
-                <a:tint val="100000"/>
-                <a:shade val="100000"/>
-                <a:satMod val="130000"/>
-              </a:schemeClr>
-            </a:gs>
-            <a:gs pos="100000">
-              <a:schemeClr val="phClr">
-                <a:tint val="50000"/>
-                <a:shade val="100000"/>
-                <a:satMod val="350000"/>
-              </a:schemeClr>
-            </a:gs>
-          </a:gsLst>
-          <a:lin ang="16200000" scaled="0"/>
-        </a:gradFill>
-      </a:fillStyleLst>
-      <a:lnStyleLst>
-        <a:ln w="9525" cap="flat" cmpd="sng" algn="ctr">
-          <a:solidFill>
-            <a:schemeClr val="phClr">
-              <a:shade val="95000"/>
-              <a:satMod val="105000"/>
-            </a:schemeClr>
-          </a:solidFill>
-          <a:prstDash val="solid"/>
-        </a:ln>
-        <a:ln w="25400" cap="flat" cmpd="sng" algn="ctr">
-          <a:solidFill>
-            <a:schemeClr val="phClr"/>
-          </a:solidFill>
-          <a:prstDash val="solid"/>
-        </a:ln>
-        <a:ln w="38100" cap="flat" cmpd="sng" algn="ctr">
-          <a:solidFill>
-            <a:schemeClr val="phClr"/>
-          </a:solidFill>
-          <a:prstDash val="solid"/>
-        </a:ln>
-      </a:lnStyleLst>
-      <a:effectStyleLst>
-        <a:effectStyle>
-          <a:effectLst>
-            <a:outerShdw blurRad="40000" dist="20000" dir="5400000" rotWithShape="0">
-              <a:srgbClr val="000000">
-                <a:alpha val="38000"/>
-              </a:srgbClr>
-            </a:outerShdw>
-          </a:effectLst>
-        </a:effectStyle>
-        <a:effectStyle>
-          <a:effectLst>
-            <a:outerShdw blurRad="40000" dist="23000" dir="5400000" rotWithShape="0">
-              <a:srgbClr val="000000">
-                <a:alpha val="35000"/>
-              </a:srgbClr>
-            </a:outerShdw>
-          </a:effectLst>
-        </a:effectStyle>
-        <a:effectStyle>
-          <a:effectLst>
-            <a:outerShdw blurRad="40000" dist="23000" dir="5400000" rotWithShape="0">
-              <a:srgbClr val="000000">
-                <a:alpha val="35000"/>
-              </a:srgbClr>
-            </a:outerShdw>
-          </a:effectLst>
-          <a:scene3d>
-            <a:camera prst="orthographicFront">
-              <a:rot lat="0" lon="0" rev="0"/>
-            </a:camera>
-            <a:lightRig rig="threePt" dir="t">
-              <a:rot lat="0" lon="0" rev="1200000"/>
-            </a:lightRig>
-          </a:scene3d>
-          <a:sp3d>
-            <a:bevelT w="63500" h="25400"/>
-          </a:sp3d>
-        </a:effectStyle>
-      </a:effectStyleLst>
-      <a:bgFillStyleLst>
-        <a:solidFill>
-          <a:schemeClr val="phClr"/>
-        </a:solidFill>
-        <a:gradFill rotWithShape="1">
-          <a:gsLst>
-            <a:gs pos="0">
-              <a:schemeClr val="phClr">
-                <a:tint val="40000"/>
-                <a:satMod val="350000"/>
-              </a:schemeClr>
-            </a:gs>
-            <a:gs pos="40000">
-              <a:schemeClr val="phClr">
-                <a:tint val="45000"/>
-                <a:shade val="99000"/>
-                <a:satMod val="350000"/>
-              </a:schemeClr>
-            </a:gs>
-            <a:gs pos="100000">
-              <a:schemeClr val="phClr">
-                <a:shade val="20000"/>
-                <a:satMod val="255000"/>
-              </a:schemeClr>
-            </a:gs>
-          </a:gsLst>
-          <a:path path="circle">
-            <a:fillToRect l="50000" t="-80000" r="50000" b="180000"/>
-          </a:path>
-        </a:gradFill>
-        <a:gradFill rotWithShape="1">
-          <a:gsLst>
-            <a:gs pos="0">
-              <a:schemeClr val="phClr">
-                <a:tint val="80000"/>
-                <a:satMod val="300000"/>
-              </a:schemeClr>
-            </a:gs>
-            <a:gs pos="100000">
-              <a:schemeClr val="phClr">
-                <a:shade val="30000"/>
-                <a:satMod val="200000"/>
-              </a:schemeClr>
-            </a:gs>
-          </a:gsLst>
-          <a:path path="circle">
-            <a:fillToRect l="50000" t="50000" r="50000" b="50000"/>
-          </a:path>
-        </a:gradFill>
-      </a:bgFillStyleLst>
-    </a:fmtScheme>
-  </a:themeElements>
-</a:theme>
 </file>
</xml_diff>

<commit_message>
chore(submission): refresh hand-edited PPT and PDF export
Co-Authored-By: Claude Opus 4.7 (1M context) <noreply@anthropic.com>
</commit_message>
<xml_diff>
--- a/submission/Resona.pptx
+++ b/submission/Resona.pptx
@@ -2,16 +2,21 @@
 <file path=ppt/presentation.xml><?xml version="1.0" encoding="utf-8"?>
 <p:presentation xmlns:a="http://schemas.openxmlformats.org/drawingml/2006/main" xmlns:r="http://schemas.openxmlformats.org/officeDocument/2006/relationships" xmlns:mc="http://schemas.openxmlformats.org/markup-compatibility/2006" xmlns:mv="urn:schemas-microsoft-com:mac:vml" xmlns:p="http://schemas.openxmlformats.org/presentationml/2006/main" xmlns:c="http://schemas.openxmlformats.org/drawingml/2006/chart" xmlns:dgm="http://schemas.openxmlformats.org/drawingml/2006/diagram" xmlns:o="urn:schemas-microsoft-com:office:office" xmlns:v="urn:schemas-microsoft-com:vml" xmlns:pvml="urn:schemas-microsoft-com:office:powerpoint" xmlns:com="http://schemas.openxmlformats.org/drawingml/2006/compatibility" xmlns:p14="http://schemas.microsoft.com/office/powerpoint/2010/main" xmlns:p15="http://schemas.microsoft.com/office/powerpoint/2012/main" xmlns:ahyp="http://schemas.microsoft.com/office/drawing/2018/hyperlinkcolor" autoCompressPictures="0" strictFirstAndLastChars="0" saveSubsetFonts="1">
   <p:sldMasterIdLst>
-    <p:sldMasterId id="2147483659" r:id="rId4"/>
+    <p:sldMasterId id="2147483661" r:id="rId4"/>
+    <p:sldMasterId id="2147483662" r:id="rId5"/>
+    <p:sldMasterId id="2147483663" r:id="rId6"/>
   </p:sldMasterIdLst>
   <p:notesMasterIdLst>
-    <p:notesMasterId r:id="rId5"/>
+    <p:notesMasterId r:id="rId7"/>
   </p:notesMasterIdLst>
   <p:sldIdLst>
-    <p:sldId id="256" r:id="rId6"/>
-    <p:sldId id="257" r:id="rId7"/>
-    <p:sldId id="258" r:id="rId8"/>
-    <p:sldId id="259" r:id="rId9"/>
+    <p:sldId id="256" r:id="rId8"/>
+    <p:sldId id="257" r:id="rId9"/>
+    <p:sldId id="258" r:id="rId10"/>
+    <p:sldId id="259" r:id="rId11"/>
+    <p:sldId id="260" r:id="rId12"/>
+    <p:sldId id="261" r:id="rId13"/>
+    <p:sldId id="262" r:id="rId14"/>
   </p:sldIdLst>
   <p:sldSz cy="6858000" cx="12191675"/>
   <p:notesSz cx="6858000" cy="9144000"/>
@@ -694,7 +699,7 @@
   <p:cSld>
     <p:spTree>
       <p:nvGrpSpPr>
-        <p:cNvPr id="80" name="Shape 80"/>
+        <p:cNvPr id="85" name="Shape 85"/>
         <p:cNvGrpSpPr/>
         <p:nvPr/>
       </p:nvGrpSpPr>
@@ -708,7 +713,7 @@
       </p:grpSpPr>
       <p:sp>
         <p:nvSpPr>
-          <p:cNvPr id="81" name="Google Shape;81;p1:notes"/>
+          <p:cNvPr id="86" name="Google Shape;86;g3d7479ac37e_0_6:notes"/>
           <p:cNvSpPr txBox="1"/>
           <p:nvPr>
             <p:ph idx="1" type="body"/>
@@ -716,15 +721,15 @@
         </p:nvSpPr>
         <p:spPr>
           <a:xfrm>
-            <a:off x="685800" y="4343400"/>
-            <a:ext cx="5486400" cy="4114800"/>
+            <a:off x="686567" y="4401097"/>
+            <a:ext cx="5486400" cy="3599700"/>
           </a:xfrm>
           <a:prstGeom prst="rect">
             <a:avLst/>
           </a:prstGeom>
         </p:spPr>
         <p:txBody>
-          <a:bodyPr anchorCtr="0" anchor="t" bIns="91425" lIns="91425" spcFirstLastPara="1" rIns="91425" wrap="square" tIns="91425">
+          <a:bodyPr anchorCtr="0" anchor="t" bIns="86075" lIns="86075" spcFirstLastPara="1" rIns="86075" wrap="square" tIns="86075">
             <a:noAutofit/>
           </a:bodyPr>
           <a:lstStyle/>
@@ -747,7 +752,7 @@
       </p:sp>
       <p:sp>
         <p:nvSpPr>
-          <p:cNvPr id="82" name="Google Shape;82;p1:notes"/>
+          <p:cNvPr id="87" name="Google Shape;87;g3d7479ac37e_0_6:notes"/>
           <p:cNvSpPr/>
           <p:nvPr>
             <p:ph idx="2" type="sldImg"/>
@@ -755,8 +760,8 @@
         </p:nvSpPr>
         <p:spPr>
           <a:xfrm>
-            <a:off x="1143225" y="685800"/>
-            <a:ext cx="4572225" cy="3429000"/>
+            <a:off x="465964" y="1143179"/>
+            <a:ext cx="5927400" cy="3086400"/>
           </a:xfrm>
           <a:custGeom>
             <a:rect b="b" l="l" r="r" t="t"/>
@@ -793,7 +798,7 @@
   <p:cSld>
     <p:spTree>
       <p:nvGrpSpPr>
-        <p:cNvPr id="119" name="Shape 119"/>
+        <p:cNvPr id="89" name="Shape 89"/>
         <p:cNvGrpSpPr/>
         <p:nvPr/>
       </p:nvGrpSpPr>
@@ -807,46 +812,7 @@
       </p:grpSpPr>
       <p:sp>
         <p:nvSpPr>
-          <p:cNvPr id="120" name="Google Shape;120;p2:notes"/>
-          <p:cNvSpPr txBox="1"/>
-          <p:nvPr>
-            <p:ph idx="1" type="body"/>
-          </p:nvPr>
-        </p:nvSpPr>
-        <p:spPr>
-          <a:xfrm>
-            <a:off x="685800" y="4343400"/>
-            <a:ext cx="5486400" cy="4114800"/>
-          </a:xfrm>
-          <a:prstGeom prst="rect">
-            <a:avLst/>
-          </a:prstGeom>
-        </p:spPr>
-        <p:txBody>
-          <a:bodyPr anchorCtr="0" anchor="t" bIns="91425" lIns="91425" spcFirstLastPara="1" rIns="91425" wrap="square" tIns="91425">
-            <a:noAutofit/>
-          </a:bodyPr>
-          <a:lstStyle/>
-          <a:p>
-            <a:pPr indent="0" lvl="0" marL="0" rtl="0" algn="l">
-              <a:spcBef>
-                <a:spcPts val="0"/>
-              </a:spcBef>
-              <a:spcAft>
-                <a:spcPts val="0"/>
-              </a:spcAft>
-              <a:buNone/>
-            </a:pPr>
-            <a:r>
-              <a:t/>
-            </a:r>
-            <a:endParaRPr/>
-          </a:p>
-        </p:txBody>
-      </p:sp>
-      <p:sp>
-        <p:nvSpPr>
-          <p:cNvPr id="121" name="Google Shape;121;p2:notes"/>
+          <p:cNvPr id="90" name="Google Shape;90;g3d7479ac37e_0_95:notes"/>
           <p:cNvSpPr/>
           <p:nvPr>
             <p:ph idx="2" type="sldImg"/>
@@ -855,7 +821,7 @@
         <p:spPr>
           <a:xfrm>
             <a:off x="1143225" y="685800"/>
-            <a:ext cx="4572225" cy="3429000"/>
+            <a:ext cx="4572300" cy="3429000"/>
           </a:xfrm>
           <a:custGeom>
             <a:rect b="b" l="l" r="r" t="t"/>
@@ -879,34 +845,9 @@
           </a:custGeom>
         </p:spPr>
       </p:sp>
-    </p:spTree>
-  </p:cSld>
-  <p:clrMapOvr>
-    <a:masterClrMapping/>
-  </p:clrMapOvr>
-</p:notes>
-</file>
-
-<file path=ppt/notesSlides/notesSlide3.xml><?xml version="1.0" encoding="utf-8"?>
-<p:notes xmlns:a="http://schemas.openxmlformats.org/drawingml/2006/main" xmlns:r="http://schemas.openxmlformats.org/officeDocument/2006/relationships" xmlns:mc="http://schemas.openxmlformats.org/markup-compatibility/2006" xmlns:mv="urn:schemas-microsoft-com:mac:vml" xmlns:p="http://schemas.openxmlformats.org/presentationml/2006/main" xmlns:c="http://schemas.openxmlformats.org/drawingml/2006/chart" xmlns:dgm="http://schemas.openxmlformats.org/drawingml/2006/diagram" xmlns:o="urn:schemas-microsoft-com:office:office" xmlns:v="urn:schemas-microsoft-com:vml" xmlns:pvml="urn:schemas-microsoft-com:office:powerpoint" xmlns:com="http://schemas.openxmlformats.org/drawingml/2006/compatibility" xmlns:p14="http://schemas.microsoft.com/office/powerpoint/2010/main" xmlns:p15="http://schemas.microsoft.com/office/powerpoint/2012/main" xmlns:ahyp="http://schemas.microsoft.com/office/drawing/2018/hyperlinkcolor" showMasterPhAnim="0" showMasterSp="0">
-  <p:cSld>
-    <p:spTree>
-      <p:nvGrpSpPr>
-        <p:cNvPr id="146" name="Shape 146"/>
-        <p:cNvGrpSpPr/>
-        <p:nvPr/>
-      </p:nvGrpSpPr>
-      <p:grpSpPr>
-        <a:xfrm>
-          <a:off x="0" y="0"/>
-          <a:ext cx="0" cy="0"/>
-          <a:chOff x="0" y="0"/>
-          <a:chExt cx="0" cy="0"/>
-        </a:xfrm>
-      </p:grpSpPr>
       <p:sp>
         <p:nvSpPr>
-          <p:cNvPr id="147" name="Google Shape;147;p3:notes"/>
+          <p:cNvPr id="91" name="Google Shape;91;g3d7479ac37e_0_95:notes"/>
           <p:cNvSpPr txBox="1"/>
           <p:nvPr>
             <p:ph idx="1" type="body"/>
@@ -943,9 +884,73 @@
           </a:p>
         </p:txBody>
       </p:sp>
+    </p:spTree>
+  </p:cSld>
+  <p:clrMapOvr>
+    <a:masterClrMapping/>
+  </p:clrMapOvr>
+</p:notes>
+</file>
+
+<file path=ppt/notesSlides/notesSlide3.xml><?xml version="1.0" encoding="utf-8"?>
+<p:notes xmlns:a="http://schemas.openxmlformats.org/drawingml/2006/main" xmlns:r="http://schemas.openxmlformats.org/officeDocument/2006/relationships" xmlns:mc="http://schemas.openxmlformats.org/markup-compatibility/2006" xmlns:mv="urn:schemas-microsoft-com:mac:vml" xmlns:p="http://schemas.openxmlformats.org/presentationml/2006/main" xmlns:c="http://schemas.openxmlformats.org/drawingml/2006/chart" xmlns:dgm="http://schemas.openxmlformats.org/drawingml/2006/diagram" xmlns:o="urn:schemas-microsoft-com:office:office" xmlns:v="urn:schemas-microsoft-com:vml" xmlns:pvml="urn:schemas-microsoft-com:office:powerpoint" xmlns:com="http://schemas.openxmlformats.org/drawingml/2006/compatibility" xmlns:p14="http://schemas.microsoft.com/office/powerpoint/2010/main" xmlns:p15="http://schemas.microsoft.com/office/powerpoint/2012/main" xmlns:ahyp="http://schemas.microsoft.com/office/drawing/2018/hyperlinkcolor" showMasterPhAnim="0" showMasterSp="0">
+  <p:cSld>
+    <p:spTree>
+      <p:nvGrpSpPr>
+        <p:cNvPr id="94" name="Shape 94"/>
+        <p:cNvGrpSpPr/>
+        <p:nvPr/>
+      </p:nvGrpSpPr>
+      <p:grpSpPr>
+        <a:xfrm>
+          <a:off x="0" y="0"/>
+          <a:ext cx="0" cy="0"/>
+          <a:chOff x="0" y="0"/>
+          <a:chExt cx="0" cy="0"/>
+        </a:xfrm>
+      </p:grpSpPr>
       <p:sp>
         <p:nvSpPr>
-          <p:cNvPr id="148" name="Google Shape;148;p3:notes"/>
+          <p:cNvPr id="95" name="Google Shape;95;p1:notes"/>
+          <p:cNvSpPr txBox="1"/>
+          <p:nvPr>
+            <p:ph idx="1" type="body"/>
+          </p:nvPr>
+        </p:nvSpPr>
+        <p:spPr>
+          <a:xfrm>
+            <a:off x="685800" y="4343400"/>
+            <a:ext cx="5486400" cy="4114800"/>
+          </a:xfrm>
+          <a:prstGeom prst="rect">
+            <a:avLst/>
+          </a:prstGeom>
+        </p:spPr>
+        <p:txBody>
+          <a:bodyPr anchorCtr="0" anchor="t" bIns="91425" lIns="91425" spcFirstLastPara="1" rIns="91425" wrap="square" tIns="91425">
+            <a:noAutofit/>
+          </a:bodyPr>
+          <a:lstStyle/>
+          <a:p>
+            <a:pPr indent="0" lvl="0" marL="0" rtl="0" algn="l">
+              <a:spcBef>
+                <a:spcPts val="0"/>
+              </a:spcBef>
+              <a:spcAft>
+                <a:spcPts val="0"/>
+              </a:spcAft>
+              <a:buNone/>
+            </a:pPr>
+            <a:r>
+              <a:t/>
+            </a:r>
+            <a:endParaRPr/>
+          </a:p>
+        </p:txBody>
+      </p:sp>
+      <p:sp>
+        <p:nvSpPr>
+          <p:cNvPr id="96" name="Google Shape;96;p1:notes"/>
           <p:cNvSpPr/>
           <p:nvPr>
             <p:ph idx="2" type="sldImg"/>
@@ -991,7 +996,7 @@
   <p:cSld>
     <p:spTree>
       <p:nvGrpSpPr>
-        <p:cNvPr id="180" name="Shape 180"/>
+        <p:cNvPr id="133" name="Shape 133"/>
         <p:cNvGrpSpPr/>
         <p:nvPr/>
       </p:nvGrpSpPr>
@@ -1005,7 +1010,7 @@
       </p:grpSpPr>
       <p:sp>
         <p:nvSpPr>
-          <p:cNvPr id="181" name="Google Shape;181;p4:notes"/>
+          <p:cNvPr id="134" name="Google Shape;134;p2:notes"/>
           <p:cNvSpPr txBox="1"/>
           <p:nvPr>
             <p:ph idx="1" type="body"/>
@@ -1044,7 +1049,7 @@
       </p:sp>
       <p:sp>
         <p:nvSpPr>
-          <p:cNvPr id="182" name="Google Shape;182;p4:notes"/>
+          <p:cNvPr id="135" name="Google Shape;135;p2:notes"/>
           <p:cNvSpPr/>
           <p:nvPr>
             <p:ph idx="2" type="sldImg"/>
@@ -1054,6 +1059,303 @@
           <a:xfrm>
             <a:off x="1143225" y="685800"/>
             <a:ext cx="4572225" cy="3429000"/>
+          </a:xfrm>
+          <a:custGeom>
+            <a:rect b="b" l="l" r="r" t="t"/>
+            <a:pathLst>
+              <a:path extrusionOk="0" h="120000" w="120000">
+                <a:moveTo>
+                  <a:pt x="0" y="0"/>
+                </a:moveTo>
+                <a:lnTo>
+                  <a:pt x="120000" y="0"/>
+                </a:lnTo>
+                <a:lnTo>
+                  <a:pt x="120000" y="120000"/>
+                </a:lnTo>
+                <a:lnTo>
+                  <a:pt x="0" y="120000"/>
+                </a:lnTo>
+                <a:close/>
+              </a:path>
+            </a:pathLst>
+          </a:custGeom>
+        </p:spPr>
+      </p:sp>
+    </p:spTree>
+  </p:cSld>
+  <p:clrMapOvr>
+    <a:masterClrMapping/>
+  </p:clrMapOvr>
+</p:notes>
+</file>
+
+<file path=ppt/notesSlides/notesSlide5.xml><?xml version="1.0" encoding="utf-8"?>
+<p:notes xmlns:a="http://schemas.openxmlformats.org/drawingml/2006/main" xmlns:r="http://schemas.openxmlformats.org/officeDocument/2006/relationships" xmlns:mc="http://schemas.openxmlformats.org/markup-compatibility/2006" xmlns:mv="urn:schemas-microsoft-com:mac:vml" xmlns:p="http://schemas.openxmlformats.org/presentationml/2006/main" xmlns:c="http://schemas.openxmlformats.org/drawingml/2006/chart" xmlns:dgm="http://schemas.openxmlformats.org/drawingml/2006/diagram" xmlns:o="urn:schemas-microsoft-com:office:office" xmlns:v="urn:schemas-microsoft-com:vml" xmlns:pvml="urn:schemas-microsoft-com:office:powerpoint" xmlns:com="http://schemas.openxmlformats.org/drawingml/2006/compatibility" xmlns:p14="http://schemas.microsoft.com/office/powerpoint/2010/main" xmlns:p15="http://schemas.microsoft.com/office/powerpoint/2012/main" xmlns:ahyp="http://schemas.microsoft.com/office/drawing/2018/hyperlinkcolor" showMasterPhAnim="0" showMasterSp="0">
+  <p:cSld>
+    <p:spTree>
+      <p:nvGrpSpPr>
+        <p:cNvPr id="160" name="Shape 160"/>
+        <p:cNvGrpSpPr/>
+        <p:nvPr/>
+      </p:nvGrpSpPr>
+      <p:grpSpPr>
+        <a:xfrm>
+          <a:off x="0" y="0"/>
+          <a:ext cx="0" cy="0"/>
+          <a:chOff x="0" y="0"/>
+          <a:chExt cx="0" cy="0"/>
+        </a:xfrm>
+      </p:grpSpPr>
+      <p:sp>
+        <p:nvSpPr>
+          <p:cNvPr id="161" name="Google Shape;161;p3:notes"/>
+          <p:cNvSpPr txBox="1"/>
+          <p:nvPr>
+            <p:ph idx="1" type="body"/>
+          </p:nvPr>
+        </p:nvSpPr>
+        <p:spPr>
+          <a:xfrm>
+            <a:off x="685800" y="4343400"/>
+            <a:ext cx="5486400" cy="4114800"/>
+          </a:xfrm>
+          <a:prstGeom prst="rect">
+            <a:avLst/>
+          </a:prstGeom>
+        </p:spPr>
+        <p:txBody>
+          <a:bodyPr anchorCtr="0" anchor="t" bIns="91425" lIns="91425" spcFirstLastPara="1" rIns="91425" wrap="square" tIns="91425">
+            <a:noAutofit/>
+          </a:bodyPr>
+          <a:lstStyle/>
+          <a:p>
+            <a:pPr indent="0" lvl="0" marL="0" rtl="0" algn="l">
+              <a:spcBef>
+                <a:spcPts val="0"/>
+              </a:spcBef>
+              <a:spcAft>
+                <a:spcPts val="0"/>
+              </a:spcAft>
+              <a:buNone/>
+            </a:pPr>
+            <a:r>
+              <a:t/>
+            </a:r>
+            <a:endParaRPr/>
+          </a:p>
+        </p:txBody>
+      </p:sp>
+      <p:sp>
+        <p:nvSpPr>
+          <p:cNvPr id="162" name="Google Shape;162;p3:notes"/>
+          <p:cNvSpPr/>
+          <p:nvPr>
+            <p:ph idx="2" type="sldImg"/>
+          </p:nvPr>
+        </p:nvSpPr>
+        <p:spPr>
+          <a:xfrm>
+            <a:off x="1143225" y="685800"/>
+            <a:ext cx="4572225" cy="3429000"/>
+          </a:xfrm>
+          <a:custGeom>
+            <a:rect b="b" l="l" r="r" t="t"/>
+            <a:pathLst>
+              <a:path extrusionOk="0" h="120000" w="120000">
+                <a:moveTo>
+                  <a:pt x="0" y="0"/>
+                </a:moveTo>
+                <a:lnTo>
+                  <a:pt x="120000" y="0"/>
+                </a:lnTo>
+                <a:lnTo>
+                  <a:pt x="120000" y="120000"/>
+                </a:lnTo>
+                <a:lnTo>
+                  <a:pt x="0" y="120000"/>
+                </a:lnTo>
+                <a:close/>
+              </a:path>
+            </a:pathLst>
+          </a:custGeom>
+        </p:spPr>
+      </p:sp>
+    </p:spTree>
+  </p:cSld>
+  <p:clrMapOvr>
+    <a:masterClrMapping/>
+  </p:clrMapOvr>
+</p:notes>
+</file>
+
+<file path=ppt/notesSlides/notesSlide6.xml><?xml version="1.0" encoding="utf-8"?>
+<p:notes xmlns:a="http://schemas.openxmlformats.org/drawingml/2006/main" xmlns:r="http://schemas.openxmlformats.org/officeDocument/2006/relationships" xmlns:mc="http://schemas.openxmlformats.org/markup-compatibility/2006" xmlns:mv="urn:schemas-microsoft-com:mac:vml" xmlns:p="http://schemas.openxmlformats.org/presentationml/2006/main" xmlns:c="http://schemas.openxmlformats.org/drawingml/2006/chart" xmlns:dgm="http://schemas.openxmlformats.org/drawingml/2006/diagram" xmlns:o="urn:schemas-microsoft-com:office:office" xmlns:v="urn:schemas-microsoft-com:vml" xmlns:pvml="urn:schemas-microsoft-com:office:powerpoint" xmlns:com="http://schemas.openxmlformats.org/drawingml/2006/compatibility" xmlns:p14="http://schemas.microsoft.com/office/powerpoint/2010/main" xmlns:p15="http://schemas.microsoft.com/office/powerpoint/2012/main" xmlns:ahyp="http://schemas.microsoft.com/office/drawing/2018/hyperlinkcolor" showMasterPhAnim="0" showMasterSp="0">
+  <p:cSld>
+    <p:spTree>
+      <p:nvGrpSpPr>
+        <p:cNvPr id="194" name="Shape 194"/>
+        <p:cNvGrpSpPr/>
+        <p:nvPr/>
+      </p:nvGrpSpPr>
+      <p:grpSpPr>
+        <a:xfrm>
+          <a:off x="0" y="0"/>
+          <a:ext cx="0" cy="0"/>
+          <a:chOff x="0" y="0"/>
+          <a:chExt cx="0" cy="0"/>
+        </a:xfrm>
+      </p:grpSpPr>
+      <p:sp>
+        <p:nvSpPr>
+          <p:cNvPr id="195" name="Google Shape;195;p4:notes"/>
+          <p:cNvSpPr txBox="1"/>
+          <p:nvPr>
+            <p:ph idx="1" type="body"/>
+          </p:nvPr>
+        </p:nvSpPr>
+        <p:spPr>
+          <a:xfrm>
+            <a:off x="685800" y="4343400"/>
+            <a:ext cx="5486400" cy="4114800"/>
+          </a:xfrm>
+          <a:prstGeom prst="rect">
+            <a:avLst/>
+          </a:prstGeom>
+        </p:spPr>
+        <p:txBody>
+          <a:bodyPr anchorCtr="0" anchor="t" bIns="91425" lIns="91425" spcFirstLastPara="1" rIns="91425" wrap="square" tIns="91425">
+            <a:noAutofit/>
+          </a:bodyPr>
+          <a:lstStyle/>
+          <a:p>
+            <a:pPr indent="0" lvl="0" marL="0" rtl="0" algn="l">
+              <a:spcBef>
+                <a:spcPts val="0"/>
+              </a:spcBef>
+              <a:spcAft>
+                <a:spcPts val="0"/>
+              </a:spcAft>
+              <a:buNone/>
+            </a:pPr>
+            <a:r>
+              <a:t/>
+            </a:r>
+            <a:endParaRPr/>
+          </a:p>
+        </p:txBody>
+      </p:sp>
+      <p:sp>
+        <p:nvSpPr>
+          <p:cNvPr id="196" name="Google Shape;196;p4:notes"/>
+          <p:cNvSpPr/>
+          <p:nvPr>
+            <p:ph idx="2" type="sldImg"/>
+          </p:nvPr>
+        </p:nvSpPr>
+        <p:spPr>
+          <a:xfrm>
+            <a:off x="1143225" y="685800"/>
+            <a:ext cx="4572225" cy="3429000"/>
+          </a:xfrm>
+          <a:custGeom>
+            <a:rect b="b" l="l" r="r" t="t"/>
+            <a:pathLst>
+              <a:path extrusionOk="0" h="120000" w="120000">
+                <a:moveTo>
+                  <a:pt x="0" y="0"/>
+                </a:moveTo>
+                <a:lnTo>
+                  <a:pt x="120000" y="0"/>
+                </a:lnTo>
+                <a:lnTo>
+                  <a:pt x="120000" y="120000"/>
+                </a:lnTo>
+                <a:lnTo>
+                  <a:pt x="0" y="120000"/>
+                </a:lnTo>
+                <a:close/>
+              </a:path>
+            </a:pathLst>
+          </a:custGeom>
+        </p:spPr>
+      </p:sp>
+    </p:spTree>
+  </p:cSld>
+  <p:clrMapOvr>
+    <a:masterClrMapping/>
+  </p:clrMapOvr>
+</p:notes>
+</file>
+
+<file path=ppt/notesSlides/notesSlide7.xml><?xml version="1.0" encoding="utf-8"?>
+<p:notes xmlns:a="http://schemas.openxmlformats.org/drawingml/2006/main" xmlns:r="http://schemas.openxmlformats.org/officeDocument/2006/relationships" xmlns:mc="http://schemas.openxmlformats.org/markup-compatibility/2006" xmlns:mv="urn:schemas-microsoft-com:mac:vml" xmlns:p="http://schemas.openxmlformats.org/presentationml/2006/main" xmlns:c="http://schemas.openxmlformats.org/drawingml/2006/chart" xmlns:dgm="http://schemas.openxmlformats.org/drawingml/2006/diagram" xmlns:o="urn:schemas-microsoft-com:office:office" xmlns:v="urn:schemas-microsoft-com:vml" xmlns:pvml="urn:schemas-microsoft-com:office:powerpoint" xmlns:com="http://schemas.openxmlformats.org/drawingml/2006/compatibility" xmlns:p14="http://schemas.microsoft.com/office/powerpoint/2010/main" xmlns:p15="http://schemas.microsoft.com/office/powerpoint/2012/main" xmlns:ahyp="http://schemas.microsoft.com/office/drawing/2018/hyperlinkcolor" showMasterPhAnim="0" showMasterSp="0">
+  <p:cSld>
+    <p:spTree>
+      <p:nvGrpSpPr>
+        <p:cNvPr id="219" name="Shape 219"/>
+        <p:cNvGrpSpPr/>
+        <p:nvPr/>
+      </p:nvGrpSpPr>
+      <p:grpSpPr>
+        <a:xfrm>
+          <a:off x="0" y="0"/>
+          <a:ext cx="0" cy="0"/>
+          <a:chOff x="0" y="0"/>
+          <a:chExt cx="0" cy="0"/>
+        </a:xfrm>
+      </p:grpSpPr>
+      <p:sp>
+        <p:nvSpPr>
+          <p:cNvPr id="220" name="Google Shape;220;g3d7479ac37e_0_17:notes"/>
+          <p:cNvSpPr txBox="1"/>
+          <p:nvPr>
+            <p:ph idx="1" type="body"/>
+          </p:nvPr>
+        </p:nvSpPr>
+        <p:spPr>
+          <a:xfrm>
+            <a:off x="686567" y="4401097"/>
+            <a:ext cx="5486400" cy="3599700"/>
+          </a:xfrm>
+          <a:prstGeom prst="rect">
+            <a:avLst/>
+          </a:prstGeom>
+        </p:spPr>
+        <p:txBody>
+          <a:bodyPr anchorCtr="0" anchor="t" bIns="86075" lIns="86075" spcFirstLastPara="1" rIns="86075" wrap="square" tIns="86075">
+            <a:noAutofit/>
+          </a:bodyPr>
+          <a:lstStyle/>
+          <a:p>
+            <a:pPr indent="0" lvl="0" marL="0" rtl="0" algn="l">
+              <a:spcBef>
+                <a:spcPts val="0"/>
+              </a:spcBef>
+              <a:spcAft>
+                <a:spcPts val="0"/>
+              </a:spcAft>
+              <a:buNone/>
+            </a:pPr>
+            <a:r>
+              <a:t/>
+            </a:r>
+            <a:endParaRPr/>
+          </a:p>
+        </p:txBody>
+      </p:sp>
+      <p:sp>
+        <p:nvSpPr>
+          <p:cNvPr id="221" name="Google Shape;221;g3d7479ac37e_0_17:notes"/>
+          <p:cNvSpPr/>
+          <p:nvPr>
+            <p:ph idx="2" type="sldImg"/>
+          </p:nvPr>
+        </p:nvSpPr>
+        <p:spPr>
+          <a:xfrm>
+            <a:off x="465964" y="1143179"/>
+            <a:ext cx="5927400" cy="3086400"/>
           </a:xfrm>
           <a:custGeom>
             <a:rect b="b" l="l" r="r" t="t"/>
@@ -2824,6 +3126,200 @@
             </a:fld>
             <a:endParaRPr/>
           </a:p>
+        </p:txBody>
+      </p:sp>
+    </p:spTree>
+  </p:cSld>
+  <p:clrMapOvr>
+    <a:masterClrMapping/>
+  </p:clrMapOvr>
+</p:sldLayout>
+</file>
+
+<file path=ppt/slideLayouts/slideLayout12.xml><?xml version="1.0" encoding="utf-8"?>
+<p:sldLayout xmlns:a="http://schemas.openxmlformats.org/drawingml/2006/main" xmlns:r="http://schemas.openxmlformats.org/officeDocument/2006/relationships" xmlns:mc="http://schemas.openxmlformats.org/markup-compatibility/2006" xmlns:mv="urn:schemas-microsoft-com:mac:vml" xmlns:p="http://schemas.openxmlformats.org/presentationml/2006/main" xmlns:c="http://schemas.openxmlformats.org/drawingml/2006/chart" xmlns:dgm="http://schemas.openxmlformats.org/drawingml/2006/diagram" xmlns:o="urn:schemas-microsoft-com:office:office" xmlns:v="urn:schemas-microsoft-com:vml" xmlns:pvml="urn:schemas-microsoft-com:office:powerpoint" xmlns:com="http://schemas.openxmlformats.org/drawingml/2006/compatibility" xmlns:p14="http://schemas.microsoft.com/office/powerpoint/2010/main" xmlns:p15="http://schemas.microsoft.com/office/powerpoint/2012/main" xmlns:ahyp="http://schemas.microsoft.com/office/drawing/2018/hyperlinkcolor" matchingName="自定义版式">
+  <p:cSld name="自定义版式">
+    <p:spTree>
+      <p:nvGrpSpPr>
+        <p:cNvPr id="81" name="Shape 81"/>
+        <p:cNvGrpSpPr/>
+        <p:nvPr/>
+      </p:nvGrpSpPr>
+      <p:grpSpPr>
+        <a:xfrm>
+          <a:off x="0" y="0"/>
+          <a:ext cx="0" cy="0"/>
+          <a:chOff x="0" y="0"/>
+          <a:chExt cx="0" cy="0"/>
+        </a:xfrm>
+      </p:grpSpPr>
+    </p:spTree>
+  </p:cSld>
+  <p:clrMapOvr>
+    <a:masterClrMapping/>
+  </p:clrMapOvr>
+</p:sldLayout>
+</file>
+
+<file path=ppt/slideLayouts/slideLayout13.xml><?xml version="1.0" encoding="utf-8"?>
+<p:sldLayout xmlns:a="http://schemas.openxmlformats.org/drawingml/2006/main" xmlns:r="http://schemas.openxmlformats.org/officeDocument/2006/relationships" xmlns:mc="http://schemas.openxmlformats.org/markup-compatibility/2006" xmlns:mv="urn:schemas-microsoft-com:mac:vml" xmlns:p="http://schemas.openxmlformats.org/presentationml/2006/main" xmlns:c="http://schemas.openxmlformats.org/drawingml/2006/chart" xmlns:dgm="http://schemas.openxmlformats.org/drawingml/2006/diagram" xmlns:o="urn:schemas-microsoft-com:office:office" xmlns:v="urn:schemas-microsoft-com:vml" xmlns:pvml="urn:schemas-microsoft-com:office:powerpoint" xmlns:com="http://schemas.openxmlformats.org/drawingml/2006/compatibility" xmlns:p14="http://schemas.microsoft.com/office/powerpoint/2010/main" xmlns:p15="http://schemas.microsoft.com/office/powerpoint/2012/main" xmlns:ahyp="http://schemas.microsoft.com/office/drawing/2018/hyperlinkcolor" matchingName="自定义版式">
+  <p:cSld name="自定义版式">
+    <p:spTree>
+      <p:nvGrpSpPr>
+        <p:cNvPr id="83" name="Shape 83"/>
+        <p:cNvGrpSpPr/>
+        <p:nvPr/>
+      </p:nvGrpSpPr>
+      <p:grpSpPr>
+        <a:xfrm>
+          <a:off x="0" y="0"/>
+          <a:ext cx="0" cy="0"/>
+          <a:chOff x="0" y="0"/>
+          <a:chExt cx="0" cy="0"/>
+        </a:xfrm>
+      </p:grpSpPr>
+      <p:sp>
+        <p:nvSpPr>
+          <p:cNvPr id="84" name="Google Shape;84;p16"/>
+          <p:cNvSpPr txBox="1"/>
+          <p:nvPr>
+            <p:ph type="title"/>
+          </p:nvPr>
+        </p:nvSpPr>
+        <p:spPr>
+          <a:xfrm>
+            <a:off x="707553" y="652508"/>
+            <a:ext cx="10515300" cy="797700"/>
+          </a:xfrm>
+          <a:prstGeom prst="rect">
+            <a:avLst/>
+          </a:prstGeom>
+          <a:noFill/>
+          <a:ln>
+            <a:noFill/>
+          </a:ln>
+        </p:spPr>
+        <p:txBody>
+          <a:bodyPr anchorCtr="0" anchor="t" bIns="45700" lIns="91425" spcFirstLastPara="1" rIns="91425" wrap="square" tIns="45700">
+            <a:noAutofit/>
+          </a:bodyPr>
+          <a:lstStyle>
+            <a:lvl1pPr lvl="0" marR="0" algn="l">
+              <a:lnSpc>
+                <a:spcPct val="90000"/>
+              </a:lnSpc>
+              <a:spcBef>
+                <a:spcPts val="0"/>
+              </a:spcBef>
+              <a:spcAft>
+                <a:spcPts val="0"/>
+              </a:spcAft>
+              <a:buClr>
+                <a:schemeClr val="dk1"/>
+              </a:buClr>
+              <a:buSzPts val="4400"/>
+              <a:buFont typeface="Arial"/>
+              <a:buNone/>
+              <a:defRPr b="0" i="0" sz="4400" u="none" cap="none" strike="noStrike">
+                <a:solidFill>
+                  <a:schemeClr val="dk1"/>
+                </a:solidFill>
+                <a:latin typeface="Arial"/>
+                <a:ea typeface="Arial"/>
+                <a:cs typeface="Arial"/>
+                <a:sym typeface="Arial"/>
+              </a:defRPr>
+            </a:lvl1pPr>
+            <a:lvl2pPr lvl="1">
+              <a:spcBef>
+                <a:spcPts val="0"/>
+              </a:spcBef>
+              <a:spcAft>
+                <a:spcPts val="0"/>
+              </a:spcAft>
+              <a:buSzPts val="1500"/>
+              <a:buNone/>
+              <a:defRPr sz="1900"/>
+            </a:lvl2pPr>
+            <a:lvl3pPr lvl="2">
+              <a:spcBef>
+                <a:spcPts val="0"/>
+              </a:spcBef>
+              <a:spcAft>
+                <a:spcPts val="0"/>
+              </a:spcAft>
+              <a:buSzPts val="1500"/>
+              <a:buNone/>
+              <a:defRPr sz="1900"/>
+            </a:lvl3pPr>
+            <a:lvl4pPr lvl="3">
+              <a:spcBef>
+                <a:spcPts val="0"/>
+              </a:spcBef>
+              <a:spcAft>
+                <a:spcPts val="0"/>
+              </a:spcAft>
+              <a:buSzPts val="1500"/>
+              <a:buNone/>
+              <a:defRPr sz="1900"/>
+            </a:lvl4pPr>
+            <a:lvl5pPr lvl="4">
+              <a:spcBef>
+                <a:spcPts val="0"/>
+              </a:spcBef>
+              <a:spcAft>
+                <a:spcPts val="0"/>
+              </a:spcAft>
+              <a:buSzPts val="1500"/>
+              <a:buNone/>
+              <a:defRPr sz="1900"/>
+            </a:lvl5pPr>
+            <a:lvl6pPr lvl="5">
+              <a:spcBef>
+                <a:spcPts val="0"/>
+              </a:spcBef>
+              <a:spcAft>
+                <a:spcPts val="0"/>
+              </a:spcAft>
+              <a:buSzPts val="1500"/>
+              <a:buNone/>
+              <a:defRPr sz="1900"/>
+            </a:lvl6pPr>
+            <a:lvl7pPr lvl="6">
+              <a:spcBef>
+                <a:spcPts val="0"/>
+              </a:spcBef>
+              <a:spcAft>
+                <a:spcPts val="0"/>
+              </a:spcAft>
+              <a:buSzPts val="1500"/>
+              <a:buNone/>
+              <a:defRPr sz="1900"/>
+            </a:lvl7pPr>
+            <a:lvl8pPr lvl="7">
+              <a:spcBef>
+                <a:spcPts val="0"/>
+              </a:spcBef>
+              <a:spcAft>
+                <a:spcPts val="0"/>
+              </a:spcAft>
+              <a:buSzPts val="1500"/>
+              <a:buNone/>
+              <a:defRPr sz="1900"/>
+            </a:lvl8pPr>
+            <a:lvl9pPr lvl="8">
+              <a:spcBef>
+                <a:spcPts val="0"/>
+              </a:spcBef>
+              <a:spcAft>
+                <a:spcPts val="0"/>
+              </a:spcAft>
+              <a:buSzPts val="1500"/>
+              <a:buNone/>
+              <a:defRPr sz="1900"/>
+            </a:lvl9pPr>
+          </a:lstStyle>
+          <a:p/>
         </p:txBody>
       </p:sp>
     </p:spTree>
@@ -10681,19 +11177,1493 @@
 </p:sldMaster>
 </file>
 
-<file path=ppt/slides/slide1.xml><?xml version="1.0" encoding="utf-8"?>
-<p:sld xmlns:a="http://schemas.openxmlformats.org/drawingml/2006/main" xmlns:r="http://schemas.openxmlformats.org/officeDocument/2006/relationships" xmlns:mc="http://schemas.openxmlformats.org/markup-compatibility/2006" xmlns:mv="urn:schemas-microsoft-com:mac:vml" xmlns:p="http://schemas.openxmlformats.org/presentationml/2006/main" xmlns:c="http://schemas.openxmlformats.org/drawingml/2006/chart" xmlns:dgm="http://schemas.openxmlformats.org/drawingml/2006/diagram" xmlns:o="urn:schemas-microsoft-com:office:office" xmlns:v="urn:schemas-microsoft-com:vml" xmlns:pvml="urn:schemas-microsoft-com:office:powerpoint" xmlns:com="http://schemas.openxmlformats.org/drawingml/2006/compatibility" xmlns:p14="http://schemas.microsoft.com/office/powerpoint/2010/main" xmlns:p15="http://schemas.microsoft.com/office/powerpoint/2012/main" xmlns:ahyp="http://schemas.microsoft.com/office/drawing/2018/hyperlinkcolor">
+<file path=ppt/slideMasters/slideMaster2.xml><?xml version="1.0" encoding="utf-8"?>
+<p:sldMaster xmlns:a="http://schemas.openxmlformats.org/drawingml/2006/main" xmlns:r="http://schemas.openxmlformats.org/officeDocument/2006/relationships" xmlns:mc="http://schemas.openxmlformats.org/markup-compatibility/2006" xmlns:mv="urn:schemas-microsoft-com:mac:vml" xmlns:p="http://schemas.openxmlformats.org/presentationml/2006/main" xmlns:c="http://schemas.openxmlformats.org/drawingml/2006/chart" xmlns:dgm="http://schemas.openxmlformats.org/drawingml/2006/diagram" xmlns:o="urn:schemas-microsoft-com:office:office" xmlns:v="urn:schemas-microsoft-com:vml" xmlns:pvml="urn:schemas-microsoft-com:office:powerpoint" xmlns:com="http://schemas.openxmlformats.org/drawingml/2006/compatibility" xmlns:p14="http://schemas.microsoft.com/office/powerpoint/2010/main" xmlns:p15="http://schemas.microsoft.com/office/powerpoint/2012/main" xmlns:ahyp="http://schemas.microsoft.com/office/drawing/2018/hyperlinkcolor">
   <p:cSld>
     <p:bg>
       <p:bgPr>
-        <a:solidFill>
-          <a:srgbClr val="12131A"/>
-        </a:solidFill>
+        <a:blipFill>
+          <a:blip r:embed="rId1">
+            <a:alphaModFix/>
+          </a:blip>
+          <a:stretch>
+            <a:fillRect/>
+          </a:stretch>
+        </a:blipFill>
       </p:bgPr>
     </p:bg>
     <p:spTree>
       <p:nvGrpSpPr>
-        <p:cNvPr id="83" name="Shape 83"/>
+        <p:cNvPr id="80" name="Shape 80"/>
+        <p:cNvGrpSpPr/>
+        <p:nvPr/>
+      </p:nvGrpSpPr>
+      <p:grpSpPr>
+        <a:xfrm>
+          <a:off x="0" y="0"/>
+          <a:ext cx="0" cy="0"/>
+          <a:chOff x="0" y="0"/>
+          <a:chExt cx="0" cy="0"/>
+        </a:xfrm>
+      </p:grpSpPr>
+    </p:spTree>
+  </p:cSld>
+  <p:clrMap accent1="accent1" accent2="accent2" accent3="accent3" accent4="accent4" accent5="accent5" accent6="accent6" bg1="lt1" bg2="dk2" tx1="dk1" tx2="lt2" folHlink="folHlink" hlink="hlink"/>
+  <p:sldLayoutIdLst>
+    <p:sldLayoutId id="2147483659" r:id="rId2"/>
+  </p:sldLayoutIdLst>
+  <p:hf dt="0" ftr="0" hdr="0" sldNum="0"/>
+  <p:txStyles>
+    <p:titleStyle>
+      <a:defPPr lvl="0" marR="0" rtl="0" algn="l">
+        <a:lnSpc>
+          <a:spcPct val="100000"/>
+        </a:lnSpc>
+        <a:spcBef>
+          <a:spcPts val="0"/>
+        </a:spcBef>
+        <a:spcAft>
+          <a:spcPts val="0"/>
+        </a:spcAft>
+      </a:defPPr>
+      <a:lvl1pPr lvl="0" marR="0" rtl="0" algn="l">
+        <a:lnSpc>
+          <a:spcPct val="100000"/>
+        </a:lnSpc>
+        <a:spcBef>
+          <a:spcPts val="0"/>
+        </a:spcBef>
+        <a:spcAft>
+          <a:spcPts val="0"/>
+        </a:spcAft>
+        <a:buClr>
+          <a:srgbClr val="000000"/>
+        </a:buClr>
+        <a:buFont typeface="Arial"/>
+        <a:defRPr b="0" i="0" sz="1400" u="none" cap="none" strike="noStrike">
+          <a:solidFill>
+            <a:srgbClr val="000000"/>
+          </a:solidFill>
+          <a:latin typeface="Arial"/>
+          <a:ea typeface="Arial"/>
+          <a:cs typeface="Arial"/>
+          <a:sym typeface="Arial"/>
+        </a:defRPr>
+      </a:lvl1pPr>
+      <a:lvl2pPr lvl="1" marR="0" rtl="0" algn="l">
+        <a:lnSpc>
+          <a:spcPct val="100000"/>
+        </a:lnSpc>
+        <a:spcBef>
+          <a:spcPts val="0"/>
+        </a:spcBef>
+        <a:spcAft>
+          <a:spcPts val="0"/>
+        </a:spcAft>
+        <a:buClr>
+          <a:srgbClr val="000000"/>
+        </a:buClr>
+        <a:buFont typeface="Arial"/>
+        <a:defRPr b="0" i="0" sz="1400" u="none" cap="none" strike="noStrike">
+          <a:solidFill>
+            <a:srgbClr val="000000"/>
+          </a:solidFill>
+          <a:latin typeface="Arial"/>
+          <a:ea typeface="Arial"/>
+          <a:cs typeface="Arial"/>
+          <a:sym typeface="Arial"/>
+        </a:defRPr>
+      </a:lvl2pPr>
+      <a:lvl3pPr lvl="2" marR="0" rtl="0" algn="l">
+        <a:lnSpc>
+          <a:spcPct val="100000"/>
+        </a:lnSpc>
+        <a:spcBef>
+          <a:spcPts val="0"/>
+        </a:spcBef>
+        <a:spcAft>
+          <a:spcPts val="0"/>
+        </a:spcAft>
+        <a:buClr>
+          <a:srgbClr val="000000"/>
+        </a:buClr>
+        <a:buFont typeface="Arial"/>
+        <a:defRPr b="0" i="0" sz="1400" u="none" cap="none" strike="noStrike">
+          <a:solidFill>
+            <a:srgbClr val="000000"/>
+          </a:solidFill>
+          <a:latin typeface="Arial"/>
+          <a:ea typeface="Arial"/>
+          <a:cs typeface="Arial"/>
+          <a:sym typeface="Arial"/>
+        </a:defRPr>
+      </a:lvl3pPr>
+      <a:lvl4pPr lvl="3" marR="0" rtl="0" algn="l">
+        <a:lnSpc>
+          <a:spcPct val="100000"/>
+        </a:lnSpc>
+        <a:spcBef>
+          <a:spcPts val="0"/>
+        </a:spcBef>
+        <a:spcAft>
+          <a:spcPts val="0"/>
+        </a:spcAft>
+        <a:buClr>
+          <a:srgbClr val="000000"/>
+        </a:buClr>
+        <a:buFont typeface="Arial"/>
+        <a:defRPr b="0" i="0" sz="1400" u="none" cap="none" strike="noStrike">
+          <a:solidFill>
+            <a:srgbClr val="000000"/>
+          </a:solidFill>
+          <a:latin typeface="Arial"/>
+          <a:ea typeface="Arial"/>
+          <a:cs typeface="Arial"/>
+          <a:sym typeface="Arial"/>
+        </a:defRPr>
+      </a:lvl4pPr>
+      <a:lvl5pPr lvl="4" marR="0" rtl="0" algn="l">
+        <a:lnSpc>
+          <a:spcPct val="100000"/>
+        </a:lnSpc>
+        <a:spcBef>
+          <a:spcPts val="0"/>
+        </a:spcBef>
+        <a:spcAft>
+          <a:spcPts val="0"/>
+        </a:spcAft>
+        <a:buClr>
+          <a:srgbClr val="000000"/>
+        </a:buClr>
+        <a:buFont typeface="Arial"/>
+        <a:defRPr b="0" i="0" sz="1400" u="none" cap="none" strike="noStrike">
+          <a:solidFill>
+            <a:srgbClr val="000000"/>
+          </a:solidFill>
+          <a:latin typeface="Arial"/>
+          <a:ea typeface="Arial"/>
+          <a:cs typeface="Arial"/>
+          <a:sym typeface="Arial"/>
+        </a:defRPr>
+      </a:lvl5pPr>
+      <a:lvl6pPr lvl="5" marR="0" rtl="0" algn="l">
+        <a:lnSpc>
+          <a:spcPct val="100000"/>
+        </a:lnSpc>
+        <a:spcBef>
+          <a:spcPts val="0"/>
+        </a:spcBef>
+        <a:spcAft>
+          <a:spcPts val="0"/>
+        </a:spcAft>
+        <a:buClr>
+          <a:srgbClr val="000000"/>
+        </a:buClr>
+        <a:buFont typeface="Arial"/>
+        <a:defRPr b="0" i="0" sz="1400" u="none" cap="none" strike="noStrike">
+          <a:solidFill>
+            <a:srgbClr val="000000"/>
+          </a:solidFill>
+          <a:latin typeface="Arial"/>
+          <a:ea typeface="Arial"/>
+          <a:cs typeface="Arial"/>
+          <a:sym typeface="Arial"/>
+        </a:defRPr>
+      </a:lvl6pPr>
+      <a:lvl7pPr lvl="6" marR="0" rtl="0" algn="l">
+        <a:lnSpc>
+          <a:spcPct val="100000"/>
+        </a:lnSpc>
+        <a:spcBef>
+          <a:spcPts val="0"/>
+        </a:spcBef>
+        <a:spcAft>
+          <a:spcPts val="0"/>
+        </a:spcAft>
+        <a:buClr>
+          <a:srgbClr val="000000"/>
+        </a:buClr>
+        <a:buFont typeface="Arial"/>
+        <a:defRPr b="0" i="0" sz="1400" u="none" cap="none" strike="noStrike">
+          <a:solidFill>
+            <a:srgbClr val="000000"/>
+          </a:solidFill>
+          <a:latin typeface="Arial"/>
+          <a:ea typeface="Arial"/>
+          <a:cs typeface="Arial"/>
+          <a:sym typeface="Arial"/>
+        </a:defRPr>
+      </a:lvl7pPr>
+      <a:lvl8pPr lvl="7" marR="0" rtl="0" algn="l">
+        <a:lnSpc>
+          <a:spcPct val="100000"/>
+        </a:lnSpc>
+        <a:spcBef>
+          <a:spcPts val="0"/>
+        </a:spcBef>
+        <a:spcAft>
+          <a:spcPts val="0"/>
+        </a:spcAft>
+        <a:buClr>
+          <a:srgbClr val="000000"/>
+        </a:buClr>
+        <a:buFont typeface="Arial"/>
+        <a:defRPr b="0" i="0" sz="1400" u="none" cap="none" strike="noStrike">
+          <a:solidFill>
+            <a:srgbClr val="000000"/>
+          </a:solidFill>
+          <a:latin typeface="Arial"/>
+          <a:ea typeface="Arial"/>
+          <a:cs typeface="Arial"/>
+          <a:sym typeface="Arial"/>
+        </a:defRPr>
+      </a:lvl8pPr>
+      <a:lvl9pPr lvl="8" marR="0" rtl="0" algn="l">
+        <a:lnSpc>
+          <a:spcPct val="100000"/>
+        </a:lnSpc>
+        <a:spcBef>
+          <a:spcPts val="0"/>
+        </a:spcBef>
+        <a:spcAft>
+          <a:spcPts val="0"/>
+        </a:spcAft>
+        <a:buClr>
+          <a:srgbClr val="000000"/>
+        </a:buClr>
+        <a:buFont typeface="Arial"/>
+        <a:defRPr b="0" i="0" sz="1400" u="none" cap="none" strike="noStrike">
+          <a:solidFill>
+            <a:srgbClr val="000000"/>
+          </a:solidFill>
+          <a:latin typeface="Arial"/>
+          <a:ea typeface="Arial"/>
+          <a:cs typeface="Arial"/>
+          <a:sym typeface="Arial"/>
+        </a:defRPr>
+      </a:lvl9pPr>
+    </p:titleStyle>
+    <p:bodyStyle>
+      <a:defPPr lvl="0" marR="0" rtl="0" algn="l">
+        <a:lnSpc>
+          <a:spcPct val="100000"/>
+        </a:lnSpc>
+        <a:spcBef>
+          <a:spcPts val="0"/>
+        </a:spcBef>
+        <a:spcAft>
+          <a:spcPts val="0"/>
+        </a:spcAft>
+      </a:defPPr>
+      <a:lvl1pPr lvl="0" marR="0" rtl="0" algn="l">
+        <a:lnSpc>
+          <a:spcPct val="100000"/>
+        </a:lnSpc>
+        <a:spcBef>
+          <a:spcPts val="0"/>
+        </a:spcBef>
+        <a:spcAft>
+          <a:spcPts val="0"/>
+        </a:spcAft>
+        <a:buClr>
+          <a:srgbClr val="000000"/>
+        </a:buClr>
+        <a:buFont typeface="Arial"/>
+        <a:defRPr b="0" i="0" sz="1400" u="none" cap="none" strike="noStrike">
+          <a:solidFill>
+            <a:srgbClr val="000000"/>
+          </a:solidFill>
+          <a:latin typeface="Arial"/>
+          <a:ea typeface="Arial"/>
+          <a:cs typeface="Arial"/>
+          <a:sym typeface="Arial"/>
+        </a:defRPr>
+      </a:lvl1pPr>
+      <a:lvl2pPr lvl="1" marR="0" rtl="0" algn="l">
+        <a:lnSpc>
+          <a:spcPct val="100000"/>
+        </a:lnSpc>
+        <a:spcBef>
+          <a:spcPts val="0"/>
+        </a:spcBef>
+        <a:spcAft>
+          <a:spcPts val="0"/>
+        </a:spcAft>
+        <a:buClr>
+          <a:srgbClr val="000000"/>
+        </a:buClr>
+        <a:buFont typeface="Arial"/>
+        <a:defRPr b="0" i="0" sz="1400" u="none" cap="none" strike="noStrike">
+          <a:solidFill>
+            <a:srgbClr val="000000"/>
+          </a:solidFill>
+          <a:latin typeface="Arial"/>
+          <a:ea typeface="Arial"/>
+          <a:cs typeface="Arial"/>
+          <a:sym typeface="Arial"/>
+        </a:defRPr>
+      </a:lvl2pPr>
+      <a:lvl3pPr lvl="2" marR="0" rtl="0" algn="l">
+        <a:lnSpc>
+          <a:spcPct val="100000"/>
+        </a:lnSpc>
+        <a:spcBef>
+          <a:spcPts val="0"/>
+        </a:spcBef>
+        <a:spcAft>
+          <a:spcPts val="0"/>
+        </a:spcAft>
+        <a:buClr>
+          <a:srgbClr val="000000"/>
+        </a:buClr>
+        <a:buFont typeface="Arial"/>
+        <a:defRPr b="0" i="0" sz="1400" u="none" cap="none" strike="noStrike">
+          <a:solidFill>
+            <a:srgbClr val="000000"/>
+          </a:solidFill>
+          <a:latin typeface="Arial"/>
+          <a:ea typeface="Arial"/>
+          <a:cs typeface="Arial"/>
+          <a:sym typeface="Arial"/>
+        </a:defRPr>
+      </a:lvl3pPr>
+      <a:lvl4pPr lvl="3" marR="0" rtl="0" algn="l">
+        <a:lnSpc>
+          <a:spcPct val="100000"/>
+        </a:lnSpc>
+        <a:spcBef>
+          <a:spcPts val="0"/>
+        </a:spcBef>
+        <a:spcAft>
+          <a:spcPts val="0"/>
+        </a:spcAft>
+        <a:buClr>
+          <a:srgbClr val="000000"/>
+        </a:buClr>
+        <a:buFont typeface="Arial"/>
+        <a:defRPr b="0" i="0" sz="1400" u="none" cap="none" strike="noStrike">
+          <a:solidFill>
+            <a:srgbClr val="000000"/>
+          </a:solidFill>
+          <a:latin typeface="Arial"/>
+          <a:ea typeface="Arial"/>
+          <a:cs typeface="Arial"/>
+          <a:sym typeface="Arial"/>
+        </a:defRPr>
+      </a:lvl4pPr>
+      <a:lvl5pPr lvl="4" marR="0" rtl="0" algn="l">
+        <a:lnSpc>
+          <a:spcPct val="100000"/>
+        </a:lnSpc>
+        <a:spcBef>
+          <a:spcPts val="0"/>
+        </a:spcBef>
+        <a:spcAft>
+          <a:spcPts val="0"/>
+        </a:spcAft>
+        <a:buClr>
+          <a:srgbClr val="000000"/>
+        </a:buClr>
+        <a:buFont typeface="Arial"/>
+        <a:defRPr b="0" i="0" sz="1400" u="none" cap="none" strike="noStrike">
+          <a:solidFill>
+            <a:srgbClr val="000000"/>
+          </a:solidFill>
+          <a:latin typeface="Arial"/>
+          <a:ea typeface="Arial"/>
+          <a:cs typeface="Arial"/>
+          <a:sym typeface="Arial"/>
+        </a:defRPr>
+      </a:lvl5pPr>
+      <a:lvl6pPr lvl="5" marR="0" rtl="0" algn="l">
+        <a:lnSpc>
+          <a:spcPct val="100000"/>
+        </a:lnSpc>
+        <a:spcBef>
+          <a:spcPts val="0"/>
+        </a:spcBef>
+        <a:spcAft>
+          <a:spcPts val="0"/>
+        </a:spcAft>
+        <a:buClr>
+          <a:srgbClr val="000000"/>
+        </a:buClr>
+        <a:buFont typeface="Arial"/>
+        <a:defRPr b="0" i="0" sz="1400" u="none" cap="none" strike="noStrike">
+          <a:solidFill>
+            <a:srgbClr val="000000"/>
+          </a:solidFill>
+          <a:latin typeface="Arial"/>
+          <a:ea typeface="Arial"/>
+          <a:cs typeface="Arial"/>
+          <a:sym typeface="Arial"/>
+        </a:defRPr>
+      </a:lvl6pPr>
+      <a:lvl7pPr lvl="6" marR="0" rtl="0" algn="l">
+        <a:lnSpc>
+          <a:spcPct val="100000"/>
+        </a:lnSpc>
+        <a:spcBef>
+          <a:spcPts val="0"/>
+        </a:spcBef>
+        <a:spcAft>
+          <a:spcPts val="0"/>
+        </a:spcAft>
+        <a:buClr>
+          <a:srgbClr val="000000"/>
+        </a:buClr>
+        <a:buFont typeface="Arial"/>
+        <a:defRPr b="0" i="0" sz="1400" u="none" cap="none" strike="noStrike">
+          <a:solidFill>
+            <a:srgbClr val="000000"/>
+          </a:solidFill>
+          <a:latin typeface="Arial"/>
+          <a:ea typeface="Arial"/>
+          <a:cs typeface="Arial"/>
+          <a:sym typeface="Arial"/>
+        </a:defRPr>
+      </a:lvl7pPr>
+      <a:lvl8pPr lvl="7" marR="0" rtl="0" algn="l">
+        <a:lnSpc>
+          <a:spcPct val="100000"/>
+        </a:lnSpc>
+        <a:spcBef>
+          <a:spcPts val="0"/>
+        </a:spcBef>
+        <a:spcAft>
+          <a:spcPts val="0"/>
+        </a:spcAft>
+        <a:buClr>
+          <a:srgbClr val="000000"/>
+        </a:buClr>
+        <a:buFont typeface="Arial"/>
+        <a:defRPr b="0" i="0" sz="1400" u="none" cap="none" strike="noStrike">
+          <a:solidFill>
+            <a:srgbClr val="000000"/>
+          </a:solidFill>
+          <a:latin typeface="Arial"/>
+          <a:ea typeface="Arial"/>
+          <a:cs typeface="Arial"/>
+          <a:sym typeface="Arial"/>
+        </a:defRPr>
+      </a:lvl8pPr>
+      <a:lvl9pPr lvl="8" marR="0" rtl="0" algn="l">
+        <a:lnSpc>
+          <a:spcPct val="100000"/>
+        </a:lnSpc>
+        <a:spcBef>
+          <a:spcPts val="0"/>
+        </a:spcBef>
+        <a:spcAft>
+          <a:spcPts val="0"/>
+        </a:spcAft>
+        <a:buClr>
+          <a:srgbClr val="000000"/>
+        </a:buClr>
+        <a:buFont typeface="Arial"/>
+        <a:defRPr b="0" i="0" sz="1400" u="none" cap="none" strike="noStrike">
+          <a:solidFill>
+            <a:srgbClr val="000000"/>
+          </a:solidFill>
+          <a:latin typeface="Arial"/>
+          <a:ea typeface="Arial"/>
+          <a:cs typeface="Arial"/>
+          <a:sym typeface="Arial"/>
+        </a:defRPr>
+      </a:lvl9pPr>
+    </p:bodyStyle>
+    <p:otherStyle>
+      <a:defPPr lvl="0" marR="0" rtl="0" algn="l">
+        <a:lnSpc>
+          <a:spcPct val="100000"/>
+        </a:lnSpc>
+        <a:spcBef>
+          <a:spcPts val="0"/>
+        </a:spcBef>
+        <a:spcAft>
+          <a:spcPts val="0"/>
+        </a:spcAft>
+      </a:defPPr>
+      <a:lvl1pPr lvl="0" marR="0" rtl="0" algn="l">
+        <a:lnSpc>
+          <a:spcPct val="100000"/>
+        </a:lnSpc>
+        <a:spcBef>
+          <a:spcPts val="0"/>
+        </a:spcBef>
+        <a:spcAft>
+          <a:spcPts val="0"/>
+        </a:spcAft>
+        <a:buClr>
+          <a:srgbClr val="000000"/>
+        </a:buClr>
+        <a:buFont typeface="Arial"/>
+        <a:defRPr b="0" i="0" sz="1400" u="none" cap="none" strike="noStrike">
+          <a:solidFill>
+            <a:srgbClr val="000000"/>
+          </a:solidFill>
+          <a:latin typeface="Arial"/>
+          <a:ea typeface="Arial"/>
+          <a:cs typeface="Arial"/>
+          <a:sym typeface="Arial"/>
+        </a:defRPr>
+      </a:lvl1pPr>
+      <a:lvl2pPr lvl="1" marR="0" rtl="0" algn="l">
+        <a:lnSpc>
+          <a:spcPct val="100000"/>
+        </a:lnSpc>
+        <a:spcBef>
+          <a:spcPts val="0"/>
+        </a:spcBef>
+        <a:spcAft>
+          <a:spcPts val="0"/>
+        </a:spcAft>
+        <a:buClr>
+          <a:srgbClr val="000000"/>
+        </a:buClr>
+        <a:buFont typeface="Arial"/>
+        <a:defRPr b="0" i="0" sz="1400" u="none" cap="none" strike="noStrike">
+          <a:solidFill>
+            <a:srgbClr val="000000"/>
+          </a:solidFill>
+          <a:latin typeface="Arial"/>
+          <a:ea typeface="Arial"/>
+          <a:cs typeface="Arial"/>
+          <a:sym typeface="Arial"/>
+        </a:defRPr>
+      </a:lvl2pPr>
+      <a:lvl3pPr lvl="2" marR="0" rtl="0" algn="l">
+        <a:lnSpc>
+          <a:spcPct val="100000"/>
+        </a:lnSpc>
+        <a:spcBef>
+          <a:spcPts val="0"/>
+        </a:spcBef>
+        <a:spcAft>
+          <a:spcPts val="0"/>
+        </a:spcAft>
+        <a:buClr>
+          <a:srgbClr val="000000"/>
+        </a:buClr>
+        <a:buFont typeface="Arial"/>
+        <a:defRPr b="0" i="0" sz="1400" u="none" cap="none" strike="noStrike">
+          <a:solidFill>
+            <a:srgbClr val="000000"/>
+          </a:solidFill>
+          <a:latin typeface="Arial"/>
+          <a:ea typeface="Arial"/>
+          <a:cs typeface="Arial"/>
+          <a:sym typeface="Arial"/>
+        </a:defRPr>
+      </a:lvl3pPr>
+      <a:lvl4pPr lvl="3" marR="0" rtl="0" algn="l">
+        <a:lnSpc>
+          <a:spcPct val="100000"/>
+        </a:lnSpc>
+        <a:spcBef>
+          <a:spcPts val="0"/>
+        </a:spcBef>
+        <a:spcAft>
+          <a:spcPts val="0"/>
+        </a:spcAft>
+        <a:buClr>
+          <a:srgbClr val="000000"/>
+        </a:buClr>
+        <a:buFont typeface="Arial"/>
+        <a:defRPr b="0" i="0" sz="1400" u="none" cap="none" strike="noStrike">
+          <a:solidFill>
+            <a:srgbClr val="000000"/>
+          </a:solidFill>
+          <a:latin typeface="Arial"/>
+          <a:ea typeface="Arial"/>
+          <a:cs typeface="Arial"/>
+          <a:sym typeface="Arial"/>
+        </a:defRPr>
+      </a:lvl4pPr>
+      <a:lvl5pPr lvl="4" marR="0" rtl="0" algn="l">
+        <a:lnSpc>
+          <a:spcPct val="100000"/>
+        </a:lnSpc>
+        <a:spcBef>
+          <a:spcPts val="0"/>
+        </a:spcBef>
+        <a:spcAft>
+          <a:spcPts val="0"/>
+        </a:spcAft>
+        <a:buClr>
+          <a:srgbClr val="000000"/>
+        </a:buClr>
+        <a:buFont typeface="Arial"/>
+        <a:defRPr b="0" i="0" sz="1400" u="none" cap="none" strike="noStrike">
+          <a:solidFill>
+            <a:srgbClr val="000000"/>
+          </a:solidFill>
+          <a:latin typeface="Arial"/>
+          <a:ea typeface="Arial"/>
+          <a:cs typeface="Arial"/>
+          <a:sym typeface="Arial"/>
+        </a:defRPr>
+      </a:lvl5pPr>
+      <a:lvl6pPr lvl="5" marR="0" rtl="0" algn="l">
+        <a:lnSpc>
+          <a:spcPct val="100000"/>
+        </a:lnSpc>
+        <a:spcBef>
+          <a:spcPts val="0"/>
+        </a:spcBef>
+        <a:spcAft>
+          <a:spcPts val="0"/>
+        </a:spcAft>
+        <a:buClr>
+          <a:srgbClr val="000000"/>
+        </a:buClr>
+        <a:buFont typeface="Arial"/>
+        <a:defRPr b="0" i="0" sz="1400" u="none" cap="none" strike="noStrike">
+          <a:solidFill>
+            <a:srgbClr val="000000"/>
+          </a:solidFill>
+          <a:latin typeface="Arial"/>
+          <a:ea typeface="Arial"/>
+          <a:cs typeface="Arial"/>
+          <a:sym typeface="Arial"/>
+        </a:defRPr>
+      </a:lvl6pPr>
+      <a:lvl7pPr lvl="6" marR="0" rtl="0" algn="l">
+        <a:lnSpc>
+          <a:spcPct val="100000"/>
+        </a:lnSpc>
+        <a:spcBef>
+          <a:spcPts val="0"/>
+        </a:spcBef>
+        <a:spcAft>
+          <a:spcPts val="0"/>
+        </a:spcAft>
+        <a:buClr>
+          <a:srgbClr val="000000"/>
+        </a:buClr>
+        <a:buFont typeface="Arial"/>
+        <a:defRPr b="0" i="0" sz="1400" u="none" cap="none" strike="noStrike">
+          <a:solidFill>
+            <a:srgbClr val="000000"/>
+          </a:solidFill>
+          <a:latin typeface="Arial"/>
+          <a:ea typeface="Arial"/>
+          <a:cs typeface="Arial"/>
+          <a:sym typeface="Arial"/>
+        </a:defRPr>
+      </a:lvl7pPr>
+      <a:lvl8pPr lvl="7" marR="0" rtl="0" algn="l">
+        <a:lnSpc>
+          <a:spcPct val="100000"/>
+        </a:lnSpc>
+        <a:spcBef>
+          <a:spcPts val="0"/>
+        </a:spcBef>
+        <a:spcAft>
+          <a:spcPts val="0"/>
+        </a:spcAft>
+        <a:buClr>
+          <a:srgbClr val="000000"/>
+        </a:buClr>
+        <a:buFont typeface="Arial"/>
+        <a:defRPr b="0" i="0" sz="1400" u="none" cap="none" strike="noStrike">
+          <a:solidFill>
+            <a:srgbClr val="000000"/>
+          </a:solidFill>
+          <a:latin typeface="Arial"/>
+          <a:ea typeface="Arial"/>
+          <a:cs typeface="Arial"/>
+          <a:sym typeface="Arial"/>
+        </a:defRPr>
+      </a:lvl8pPr>
+      <a:lvl9pPr lvl="8" marR="0" rtl="0" algn="l">
+        <a:lnSpc>
+          <a:spcPct val="100000"/>
+        </a:lnSpc>
+        <a:spcBef>
+          <a:spcPts val="0"/>
+        </a:spcBef>
+        <a:spcAft>
+          <a:spcPts val="0"/>
+        </a:spcAft>
+        <a:buClr>
+          <a:srgbClr val="000000"/>
+        </a:buClr>
+        <a:buFont typeface="Arial"/>
+        <a:defRPr b="0" i="0" sz="1400" u="none" cap="none" strike="noStrike">
+          <a:solidFill>
+            <a:srgbClr val="000000"/>
+          </a:solidFill>
+          <a:latin typeface="Arial"/>
+          <a:ea typeface="Arial"/>
+          <a:cs typeface="Arial"/>
+          <a:sym typeface="Arial"/>
+        </a:defRPr>
+      </a:lvl9pPr>
+    </p:otherStyle>
+  </p:txStyles>
+</p:sldMaster>
+</file>
+
+<file path=ppt/slideMasters/slideMaster3.xml><?xml version="1.0" encoding="utf-8"?>
+<p:sldMaster xmlns:a="http://schemas.openxmlformats.org/drawingml/2006/main" xmlns:r="http://schemas.openxmlformats.org/officeDocument/2006/relationships" xmlns:mc="http://schemas.openxmlformats.org/markup-compatibility/2006" xmlns:mv="urn:schemas-microsoft-com:mac:vml" xmlns:p="http://schemas.openxmlformats.org/presentationml/2006/main" xmlns:c="http://schemas.openxmlformats.org/drawingml/2006/chart" xmlns:dgm="http://schemas.openxmlformats.org/drawingml/2006/diagram" xmlns:o="urn:schemas-microsoft-com:office:office" xmlns:v="urn:schemas-microsoft-com:vml" xmlns:pvml="urn:schemas-microsoft-com:office:powerpoint" xmlns:com="http://schemas.openxmlformats.org/drawingml/2006/compatibility" xmlns:p14="http://schemas.microsoft.com/office/powerpoint/2010/main" xmlns:p15="http://schemas.microsoft.com/office/powerpoint/2012/main" xmlns:ahyp="http://schemas.microsoft.com/office/drawing/2018/hyperlinkcolor">
+  <p:cSld>
+    <p:bg>
+      <p:bgPr>
+        <a:blipFill>
+          <a:blip r:embed="rId1">
+            <a:alphaModFix/>
+          </a:blip>
+          <a:stretch>
+            <a:fillRect/>
+          </a:stretch>
+        </a:blipFill>
+      </p:bgPr>
+    </p:bg>
+    <p:spTree>
+      <p:nvGrpSpPr>
+        <p:cNvPr id="82" name="Shape 82"/>
+        <p:cNvGrpSpPr/>
+        <p:nvPr/>
+      </p:nvGrpSpPr>
+      <p:grpSpPr>
+        <a:xfrm>
+          <a:off x="0" y="0"/>
+          <a:ext cx="0" cy="0"/>
+          <a:chOff x="0" y="0"/>
+          <a:chExt cx="0" cy="0"/>
+        </a:xfrm>
+      </p:grpSpPr>
+    </p:spTree>
+  </p:cSld>
+  <p:clrMap accent1="accent1" accent2="accent2" accent3="accent3" accent4="accent4" accent5="accent5" accent6="accent6" bg1="lt1" bg2="dk2" tx1="dk1" tx2="lt2" folHlink="folHlink" hlink="hlink"/>
+  <p:sldLayoutIdLst>
+    <p:sldLayoutId id="2147483660" r:id="rId2"/>
+  </p:sldLayoutIdLst>
+  <p:hf dt="0" ftr="0" hdr="0" sldNum="0"/>
+  <p:txStyles>
+    <p:titleStyle>
+      <a:defPPr lvl="0" marR="0" rtl="0" algn="l">
+        <a:lnSpc>
+          <a:spcPct val="100000"/>
+        </a:lnSpc>
+        <a:spcBef>
+          <a:spcPts val="0"/>
+        </a:spcBef>
+        <a:spcAft>
+          <a:spcPts val="0"/>
+        </a:spcAft>
+      </a:defPPr>
+      <a:lvl1pPr lvl="0" marR="0" rtl="0" algn="l">
+        <a:lnSpc>
+          <a:spcPct val="100000"/>
+        </a:lnSpc>
+        <a:spcBef>
+          <a:spcPts val="0"/>
+        </a:spcBef>
+        <a:spcAft>
+          <a:spcPts val="0"/>
+        </a:spcAft>
+        <a:buClr>
+          <a:srgbClr val="000000"/>
+        </a:buClr>
+        <a:buFont typeface="Arial"/>
+        <a:defRPr b="0" i="0" sz="1400" u="none" cap="none" strike="noStrike">
+          <a:solidFill>
+            <a:srgbClr val="000000"/>
+          </a:solidFill>
+          <a:latin typeface="Arial"/>
+          <a:ea typeface="Arial"/>
+          <a:cs typeface="Arial"/>
+          <a:sym typeface="Arial"/>
+        </a:defRPr>
+      </a:lvl1pPr>
+      <a:lvl2pPr lvl="1" marR="0" rtl="0" algn="l">
+        <a:lnSpc>
+          <a:spcPct val="100000"/>
+        </a:lnSpc>
+        <a:spcBef>
+          <a:spcPts val="0"/>
+        </a:spcBef>
+        <a:spcAft>
+          <a:spcPts val="0"/>
+        </a:spcAft>
+        <a:buClr>
+          <a:srgbClr val="000000"/>
+        </a:buClr>
+        <a:buFont typeface="Arial"/>
+        <a:defRPr b="0" i="0" sz="1400" u="none" cap="none" strike="noStrike">
+          <a:solidFill>
+            <a:srgbClr val="000000"/>
+          </a:solidFill>
+          <a:latin typeface="Arial"/>
+          <a:ea typeface="Arial"/>
+          <a:cs typeface="Arial"/>
+          <a:sym typeface="Arial"/>
+        </a:defRPr>
+      </a:lvl2pPr>
+      <a:lvl3pPr lvl="2" marR="0" rtl="0" algn="l">
+        <a:lnSpc>
+          <a:spcPct val="100000"/>
+        </a:lnSpc>
+        <a:spcBef>
+          <a:spcPts val="0"/>
+        </a:spcBef>
+        <a:spcAft>
+          <a:spcPts val="0"/>
+        </a:spcAft>
+        <a:buClr>
+          <a:srgbClr val="000000"/>
+        </a:buClr>
+        <a:buFont typeface="Arial"/>
+        <a:defRPr b="0" i="0" sz="1400" u="none" cap="none" strike="noStrike">
+          <a:solidFill>
+            <a:srgbClr val="000000"/>
+          </a:solidFill>
+          <a:latin typeface="Arial"/>
+          <a:ea typeface="Arial"/>
+          <a:cs typeface="Arial"/>
+          <a:sym typeface="Arial"/>
+        </a:defRPr>
+      </a:lvl3pPr>
+      <a:lvl4pPr lvl="3" marR="0" rtl="0" algn="l">
+        <a:lnSpc>
+          <a:spcPct val="100000"/>
+        </a:lnSpc>
+        <a:spcBef>
+          <a:spcPts val="0"/>
+        </a:spcBef>
+        <a:spcAft>
+          <a:spcPts val="0"/>
+        </a:spcAft>
+        <a:buClr>
+          <a:srgbClr val="000000"/>
+        </a:buClr>
+        <a:buFont typeface="Arial"/>
+        <a:defRPr b="0" i="0" sz="1400" u="none" cap="none" strike="noStrike">
+          <a:solidFill>
+            <a:srgbClr val="000000"/>
+          </a:solidFill>
+          <a:latin typeface="Arial"/>
+          <a:ea typeface="Arial"/>
+          <a:cs typeface="Arial"/>
+          <a:sym typeface="Arial"/>
+        </a:defRPr>
+      </a:lvl4pPr>
+      <a:lvl5pPr lvl="4" marR="0" rtl="0" algn="l">
+        <a:lnSpc>
+          <a:spcPct val="100000"/>
+        </a:lnSpc>
+        <a:spcBef>
+          <a:spcPts val="0"/>
+        </a:spcBef>
+        <a:spcAft>
+          <a:spcPts val="0"/>
+        </a:spcAft>
+        <a:buClr>
+          <a:srgbClr val="000000"/>
+        </a:buClr>
+        <a:buFont typeface="Arial"/>
+        <a:defRPr b="0" i="0" sz="1400" u="none" cap="none" strike="noStrike">
+          <a:solidFill>
+            <a:srgbClr val="000000"/>
+          </a:solidFill>
+          <a:latin typeface="Arial"/>
+          <a:ea typeface="Arial"/>
+          <a:cs typeface="Arial"/>
+          <a:sym typeface="Arial"/>
+        </a:defRPr>
+      </a:lvl5pPr>
+      <a:lvl6pPr lvl="5" marR="0" rtl="0" algn="l">
+        <a:lnSpc>
+          <a:spcPct val="100000"/>
+        </a:lnSpc>
+        <a:spcBef>
+          <a:spcPts val="0"/>
+        </a:spcBef>
+        <a:spcAft>
+          <a:spcPts val="0"/>
+        </a:spcAft>
+        <a:buClr>
+          <a:srgbClr val="000000"/>
+        </a:buClr>
+        <a:buFont typeface="Arial"/>
+        <a:defRPr b="0" i="0" sz="1400" u="none" cap="none" strike="noStrike">
+          <a:solidFill>
+            <a:srgbClr val="000000"/>
+          </a:solidFill>
+          <a:latin typeface="Arial"/>
+          <a:ea typeface="Arial"/>
+          <a:cs typeface="Arial"/>
+          <a:sym typeface="Arial"/>
+        </a:defRPr>
+      </a:lvl6pPr>
+      <a:lvl7pPr lvl="6" marR="0" rtl="0" algn="l">
+        <a:lnSpc>
+          <a:spcPct val="100000"/>
+        </a:lnSpc>
+        <a:spcBef>
+          <a:spcPts val="0"/>
+        </a:spcBef>
+        <a:spcAft>
+          <a:spcPts val="0"/>
+        </a:spcAft>
+        <a:buClr>
+          <a:srgbClr val="000000"/>
+        </a:buClr>
+        <a:buFont typeface="Arial"/>
+        <a:defRPr b="0" i="0" sz="1400" u="none" cap="none" strike="noStrike">
+          <a:solidFill>
+            <a:srgbClr val="000000"/>
+          </a:solidFill>
+          <a:latin typeface="Arial"/>
+          <a:ea typeface="Arial"/>
+          <a:cs typeface="Arial"/>
+          <a:sym typeface="Arial"/>
+        </a:defRPr>
+      </a:lvl7pPr>
+      <a:lvl8pPr lvl="7" marR="0" rtl="0" algn="l">
+        <a:lnSpc>
+          <a:spcPct val="100000"/>
+        </a:lnSpc>
+        <a:spcBef>
+          <a:spcPts val="0"/>
+        </a:spcBef>
+        <a:spcAft>
+          <a:spcPts val="0"/>
+        </a:spcAft>
+        <a:buClr>
+          <a:srgbClr val="000000"/>
+        </a:buClr>
+        <a:buFont typeface="Arial"/>
+        <a:defRPr b="0" i="0" sz="1400" u="none" cap="none" strike="noStrike">
+          <a:solidFill>
+            <a:srgbClr val="000000"/>
+          </a:solidFill>
+          <a:latin typeface="Arial"/>
+          <a:ea typeface="Arial"/>
+          <a:cs typeface="Arial"/>
+          <a:sym typeface="Arial"/>
+        </a:defRPr>
+      </a:lvl8pPr>
+      <a:lvl9pPr lvl="8" marR="0" rtl="0" algn="l">
+        <a:lnSpc>
+          <a:spcPct val="100000"/>
+        </a:lnSpc>
+        <a:spcBef>
+          <a:spcPts val="0"/>
+        </a:spcBef>
+        <a:spcAft>
+          <a:spcPts val="0"/>
+        </a:spcAft>
+        <a:buClr>
+          <a:srgbClr val="000000"/>
+        </a:buClr>
+        <a:buFont typeface="Arial"/>
+        <a:defRPr b="0" i="0" sz="1400" u="none" cap="none" strike="noStrike">
+          <a:solidFill>
+            <a:srgbClr val="000000"/>
+          </a:solidFill>
+          <a:latin typeface="Arial"/>
+          <a:ea typeface="Arial"/>
+          <a:cs typeface="Arial"/>
+          <a:sym typeface="Arial"/>
+        </a:defRPr>
+      </a:lvl9pPr>
+    </p:titleStyle>
+    <p:bodyStyle>
+      <a:defPPr lvl="0" marR="0" rtl="0" algn="l">
+        <a:lnSpc>
+          <a:spcPct val="100000"/>
+        </a:lnSpc>
+        <a:spcBef>
+          <a:spcPts val="0"/>
+        </a:spcBef>
+        <a:spcAft>
+          <a:spcPts val="0"/>
+        </a:spcAft>
+      </a:defPPr>
+      <a:lvl1pPr lvl="0" marR="0" rtl="0" algn="l">
+        <a:lnSpc>
+          <a:spcPct val="100000"/>
+        </a:lnSpc>
+        <a:spcBef>
+          <a:spcPts val="0"/>
+        </a:spcBef>
+        <a:spcAft>
+          <a:spcPts val="0"/>
+        </a:spcAft>
+        <a:buClr>
+          <a:srgbClr val="000000"/>
+        </a:buClr>
+        <a:buFont typeface="Arial"/>
+        <a:defRPr b="0" i="0" sz="1400" u="none" cap="none" strike="noStrike">
+          <a:solidFill>
+            <a:srgbClr val="000000"/>
+          </a:solidFill>
+          <a:latin typeface="Arial"/>
+          <a:ea typeface="Arial"/>
+          <a:cs typeface="Arial"/>
+          <a:sym typeface="Arial"/>
+        </a:defRPr>
+      </a:lvl1pPr>
+      <a:lvl2pPr lvl="1" marR="0" rtl="0" algn="l">
+        <a:lnSpc>
+          <a:spcPct val="100000"/>
+        </a:lnSpc>
+        <a:spcBef>
+          <a:spcPts val="0"/>
+        </a:spcBef>
+        <a:spcAft>
+          <a:spcPts val="0"/>
+        </a:spcAft>
+        <a:buClr>
+          <a:srgbClr val="000000"/>
+        </a:buClr>
+        <a:buFont typeface="Arial"/>
+        <a:defRPr b="0" i="0" sz="1400" u="none" cap="none" strike="noStrike">
+          <a:solidFill>
+            <a:srgbClr val="000000"/>
+          </a:solidFill>
+          <a:latin typeface="Arial"/>
+          <a:ea typeface="Arial"/>
+          <a:cs typeface="Arial"/>
+          <a:sym typeface="Arial"/>
+        </a:defRPr>
+      </a:lvl2pPr>
+      <a:lvl3pPr lvl="2" marR="0" rtl="0" algn="l">
+        <a:lnSpc>
+          <a:spcPct val="100000"/>
+        </a:lnSpc>
+        <a:spcBef>
+          <a:spcPts val="0"/>
+        </a:spcBef>
+        <a:spcAft>
+          <a:spcPts val="0"/>
+        </a:spcAft>
+        <a:buClr>
+          <a:srgbClr val="000000"/>
+        </a:buClr>
+        <a:buFont typeface="Arial"/>
+        <a:defRPr b="0" i="0" sz="1400" u="none" cap="none" strike="noStrike">
+          <a:solidFill>
+            <a:srgbClr val="000000"/>
+          </a:solidFill>
+          <a:latin typeface="Arial"/>
+          <a:ea typeface="Arial"/>
+          <a:cs typeface="Arial"/>
+          <a:sym typeface="Arial"/>
+        </a:defRPr>
+      </a:lvl3pPr>
+      <a:lvl4pPr lvl="3" marR="0" rtl="0" algn="l">
+        <a:lnSpc>
+          <a:spcPct val="100000"/>
+        </a:lnSpc>
+        <a:spcBef>
+          <a:spcPts val="0"/>
+        </a:spcBef>
+        <a:spcAft>
+          <a:spcPts val="0"/>
+        </a:spcAft>
+        <a:buClr>
+          <a:srgbClr val="000000"/>
+        </a:buClr>
+        <a:buFont typeface="Arial"/>
+        <a:defRPr b="0" i="0" sz="1400" u="none" cap="none" strike="noStrike">
+          <a:solidFill>
+            <a:srgbClr val="000000"/>
+          </a:solidFill>
+          <a:latin typeface="Arial"/>
+          <a:ea typeface="Arial"/>
+          <a:cs typeface="Arial"/>
+          <a:sym typeface="Arial"/>
+        </a:defRPr>
+      </a:lvl4pPr>
+      <a:lvl5pPr lvl="4" marR="0" rtl="0" algn="l">
+        <a:lnSpc>
+          <a:spcPct val="100000"/>
+        </a:lnSpc>
+        <a:spcBef>
+          <a:spcPts val="0"/>
+        </a:spcBef>
+        <a:spcAft>
+          <a:spcPts val="0"/>
+        </a:spcAft>
+        <a:buClr>
+          <a:srgbClr val="000000"/>
+        </a:buClr>
+        <a:buFont typeface="Arial"/>
+        <a:defRPr b="0" i="0" sz="1400" u="none" cap="none" strike="noStrike">
+          <a:solidFill>
+            <a:srgbClr val="000000"/>
+          </a:solidFill>
+          <a:latin typeface="Arial"/>
+          <a:ea typeface="Arial"/>
+          <a:cs typeface="Arial"/>
+          <a:sym typeface="Arial"/>
+        </a:defRPr>
+      </a:lvl5pPr>
+      <a:lvl6pPr lvl="5" marR="0" rtl="0" algn="l">
+        <a:lnSpc>
+          <a:spcPct val="100000"/>
+        </a:lnSpc>
+        <a:spcBef>
+          <a:spcPts val="0"/>
+        </a:spcBef>
+        <a:spcAft>
+          <a:spcPts val="0"/>
+        </a:spcAft>
+        <a:buClr>
+          <a:srgbClr val="000000"/>
+        </a:buClr>
+        <a:buFont typeface="Arial"/>
+        <a:defRPr b="0" i="0" sz="1400" u="none" cap="none" strike="noStrike">
+          <a:solidFill>
+            <a:srgbClr val="000000"/>
+          </a:solidFill>
+          <a:latin typeface="Arial"/>
+          <a:ea typeface="Arial"/>
+          <a:cs typeface="Arial"/>
+          <a:sym typeface="Arial"/>
+        </a:defRPr>
+      </a:lvl6pPr>
+      <a:lvl7pPr lvl="6" marR="0" rtl="0" algn="l">
+        <a:lnSpc>
+          <a:spcPct val="100000"/>
+        </a:lnSpc>
+        <a:spcBef>
+          <a:spcPts val="0"/>
+        </a:spcBef>
+        <a:spcAft>
+          <a:spcPts val="0"/>
+        </a:spcAft>
+        <a:buClr>
+          <a:srgbClr val="000000"/>
+        </a:buClr>
+        <a:buFont typeface="Arial"/>
+        <a:defRPr b="0" i="0" sz="1400" u="none" cap="none" strike="noStrike">
+          <a:solidFill>
+            <a:srgbClr val="000000"/>
+          </a:solidFill>
+          <a:latin typeface="Arial"/>
+          <a:ea typeface="Arial"/>
+          <a:cs typeface="Arial"/>
+          <a:sym typeface="Arial"/>
+        </a:defRPr>
+      </a:lvl7pPr>
+      <a:lvl8pPr lvl="7" marR="0" rtl="0" algn="l">
+        <a:lnSpc>
+          <a:spcPct val="100000"/>
+        </a:lnSpc>
+        <a:spcBef>
+          <a:spcPts val="0"/>
+        </a:spcBef>
+        <a:spcAft>
+          <a:spcPts val="0"/>
+        </a:spcAft>
+        <a:buClr>
+          <a:srgbClr val="000000"/>
+        </a:buClr>
+        <a:buFont typeface="Arial"/>
+        <a:defRPr b="0" i="0" sz="1400" u="none" cap="none" strike="noStrike">
+          <a:solidFill>
+            <a:srgbClr val="000000"/>
+          </a:solidFill>
+          <a:latin typeface="Arial"/>
+          <a:ea typeface="Arial"/>
+          <a:cs typeface="Arial"/>
+          <a:sym typeface="Arial"/>
+        </a:defRPr>
+      </a:lvl8pPr>
+      <a:lvl9pPr lvl="8" marR="0" rtl="0" algn="l">
+        <a:lnSpc>
+          <a:spcPct val="100000"/>
+        </a:lnSpc>
+        <a:spcBef>
+          <a:spcPts val="0"/>
+        </a:spcBef>
+        <a:spcAft>
+          <a:spcPts val="0"/>
+        </a:spcAft>
+        <a:buClr>
+          <a:srgbClr val="000000"/>
+        </a:buClr>
+        <a:buFont typeface="Arial"/>
+        <a:defRPr b="0" i="0" sz="1400" u="none" cap="none" strike="noStrike">
+          <a:solidFill>
+            <a:srgbClr val="000000"/>
+          </a:solidFill>
+          <a:latin typeface="Arial"/>
+          <a:ea typeface="Arial"/>
+          <a:cs typeface="Arial"/>
+          <a:sym typeface="Arial"/>
+        </a:defRPr>
+      </a:lvl9pPr>
+    </p:bodyStyle>
+    <p:otherStyle>
+      <a:defPPr lvl="0" marR="0" rtl="0" algn="l">
+        <a:lnSpc>
+          <a:spcPct val="100000"/>
+        </a:lnSpc>
+        <a:spcBef>
+          <a:spcPts val="0"/>
+        </a:spcBef>
+        <a:spcAft>
+          <a:spcPts val="0"/>
+        </a:spcAft>
+      </a:defPPr>
+      <a:lvl1pPr lvl="0" marR="0" rtl="0" algn="l">
+        <a:lnSpc>
+          <a:spcPct val="100000"/>
+        </a:lnSpc>
+        <a:spcBef>
+          <a:spcPts val="0"/>
+        </a:spcBef>
+        <a:spcAft>
+          <a:spcPts val="0"/>
+        </a:spcAft>
+        <a:buClr>
+          <a:srgbClr val="000000"/>
+        </a:buClr>
+        <a:buFont typeface="Arial"/>
+        <a:defRPr b="0" i="0" sz="1400" u="none" cap="none" strike="noStrike">
+          <a:solidFill>
+            <a:srgbClr val="000000"/>
+          </a:solidFill>
+          <a:latin typeface="Arial"/>
+          <a:ea typeface="Arial"/>
+          <a:cs typeface="Arial"/>
+          <a:sym typeface="Arial"/>
+        </a:defRPr>
+      </a:lvl1pPr>
+      <a:lvl2pPr lvl="1" marR="0" rtl="0" algn="l">
+        <a:lnSpc>
+          <a:spcPct val="100000"/>
+        </a:lnSpc>
+        <a:spcBef>
+          <a:spcPts val="0"/>
+        </a:spcBef>
+        <a:spcAft>
+          <a:spcPts val="0"/>
+        </a:spcAft>
+        <a:buClr>
+          <a:srgbClr val="000000"/>
+        </a:buClr>
+        <a:buFont typeface="Arial"/>
+        <a:defRPr b="0" i="0" sz="1400" u="none" cap="none" strike="noStrike">
+          <a:solidFill>
+            <a:srgbClr val="000000"/>
+          </a:solidFill>
+          <a:latin typeface="Arial"/>
+          <a:ea typeface="Arial"/>
+          <a:cs typeface="Arial"/>
+          <a:sym typeface="Arial"/>
+        </a:defRPr>
+      </a:lvl2pPr>
+      <a:lvl3pPr lvl="2" marR="0" rtl="0" algn="l">
+        <a:lnSpc>
+          <a:spcPct val="100000"/>
+        </a:lnSpc>
+        <a:spcBef>
+          <a:spcPts val="0"/>
+        </a:spcBef>
+        <a:spcAft>
+          <a:spcPts val="0"/>
+        </a:spcAft>
+        <a:buClr>
+          <a:srgbClr val="000000"/>
+        </a:buClr>
+        <a:buFont typeface="Arial"/>
+        <a:defRPr b="0" i="0" sz="1400" u="none" cap="none" strike="noStrike">
+          <a:solidFill>
+            <a:srgbClr val="000000"/>
+          </a:solidFill>
+          <a:latin typeface="Arial"/>
+          <a:ea typeface="Arial"/>
+          <a:cs typeface="Arial"/>
+          <a:sym typeface="Arial"/>
+        </a:defRPr>
+      </a:lvl3pPr>
+      <a:lvl4pPr lvl="3" marR="0" rtl="0" algn="l">
+        <a:lnSpc>
+          <a:spcPct val="100000"/>
+        </a:lnSpc>
+        <a:spcBef>
+          <a:spcPts val="0"/>
+        </a:spcBef>
+        <a:spcAft>
+          <a:spcPts val="0"/>
+        </a:spcAft>
+        <a:buClr>
+          <a:srgbClr val="000000"/>
+        </a:buClr>
+        <a:buFont typeface="Arial"/>
+        <a:defRPr b="0" i="0" sz="1400" u="none" cap="none" strike="noStrike">
+          <a:solidFill>
+            <a:srgbClr val="000000"/>
+          </a:solidFill>
+          <a:latin typeface="Arial"/>
+          <a:ea typeface="Arial"/>
+          <a:cs typeface="Arial"/>
+          <a:sym typeface="Arial"/>
+        </a:defRPr>
+      </a:lvl4pPr>
+      <a:lvl5pPr lvl="4" marR="0" rtl="0" algn="l">
+        <a:lnSpc>
+          <a:spcPct val="100000"/>
+        </a:lnSpc>
+        <a:spcBef>
+          <a:spcPts val="0"/>
+        </a:spcBef>
+        <a:spcAft>
+          <a:spcPts val="0"/>
+        </a:spcAft>
+        <a:buClr>
+          <a:srgbClr val="000000"/>
+        </a:buClr>
+        <a:buFont typeface="Arial"/>
+        <a:defRPr b="0" i="0" sz="1400" u="none" cap="none" strike="noStrike">
+          <a:solidFill>
+            <a:srgbClr val="000000"/>
+          </a:solidFill>
+          <a:latin typeface="Arial"/>
+          <a:ea typeface="Arial"/>
+          <a:cs typeface="Arial"/>
+          <a:sym typeface="Arial"/>
+        </a:defRPr>
+      </a:lvl5pPr>
+      <a:lvl6pPr lvl="5" marR="0" rtl="0" algn="l">
+        <a:lnSpc>
+          <a:spcPct val="100000"/>
+        </a:lnSpc>
+        <a:spcBef>
+          <a:spcPts val="0"/>
+        </a:spcBef>
+        <a:spcAft>
+          <a:spcPts val="0"/>
+        </a:spcAft>
+        <a:buClr>
+          <a:srgbClr val="000000"/>
+        </a:buClr>
+        <a:buFont typeface="Arial"/>
+        <a:defRPr b="0" i="0" sz="1400" u="none" cap="none" strike="noStrike">
+          <a:solidFill>
+            <a:srgbClr val="000000"/>
+          </a:solidFill>
+          <a:latin typeface="Arial"/>
+          <a:ea typeface="Arial"/>
+          <a:cs typeface="Arial"/>
+          <a:sym typeface="Arial"/>
+        </a:defRPr>
+      </a:lvl6pPr>
+      <a:lvl7pPr lvl="6" marR="0" rtl="0" algn="l">
+        <a:lnSpc>
+          <a:spcPct val="100000"/>
+        </a:lnSpc>
+        <a:spcBef>
+          <a:spcPts val="0"/>
+        </a:spcBef>
+        <a:spcAft>
+          <a:spcPts val="0"/>
+        </a:spcAft>
+        <a:buClr>
+          <a:srgbClr val="000000"/>
+        </a:buClr>
+        <a:buFont typeface="Arial"/>
+        <a:defRPr b="0" i="0" sz="1400" u="none" cap="none" strike="noStrike">
+          <a:solidFill>
+            <a:srgbClr val="000000"/>
+          </a:solidFill>
+          <a:latin typeface="Arial"/>
+          <a:ea typeface="Arial"/>
+          <a:cs typeface="Arial"/>
+          <a:sym typeface="Arial"/>
+        </a:defRPr>
+      </a:lvl7pPr>
+      <a:lvl8pPr lvl="7" marR="0" rtl="0" algn="l">
+        <a:lnSpc>
+          <a:spcPct val="100000"/>
+        </a:lnSpc>
+        <a:spcBef>
+          <a:spcPts val="0"/>
+        </a:spcBef>
+        <a:spcAft>
+          <a:spcPts val="0"/>
+        </a:spcAft>
+        <a:buClr>
+          <a:srgbClr val="000000"/>
+        </a:buClr>
+        <a:buFont typeface="Arial"/>
+        <a:defRPr b="0" i="0" sz="1400" u="none" cap="none" strike="noStrike">
+          <a:solidFill>
+            <a:srgbClr val="000000"/>
+          </a:solidFill>
+          <a:latin typeface="Arial"/>
+          <a:ea typeface="Arial"/>
+          <a:cs typeface="Arial"/>
+          <a:sym typeface="Arial"/>
+        </a:defRPr>
+      </a:lvl8pPr>
+      <a:lvl9pPr lvl="8" marR="0" rtl="0" algn="l">
+        <a:lnSpc>
+          <a:spcPct val="100000"/>
+        </a:lnSpc>
+        <a:spcBef>
+          <a:spcPts val="0"/>
+        </a:spcBef>
+        <a:spcAft>
+          <a:spcPts val="0"/>
+        </a:spcAft>
+        <a:buClr>
+          <a:srgbClr val="000000"/>
+        </a:buClr>
+        <a:buFont typeface="Arial"/>
+        <a:defRPr b="0" i="0" sz="1400" u="none" cap="none" strike="noStrike">
+          <a:solidFill>
+            <a:srgbClr val="000000"/>
+          </a:solidFill>
+          <a:latin typeface="Arial"/>
+          <a:ea typeface="Arial"/>
+          <a:cs typeface="Arial"/>
+          <a:sym typeface="Arial"/>
+        </a:defRPr>
+      </a:lvl9pPr>
+    </p:otherStyle>
+  </p:txStyles>
+</p:sldMaster>
+</file>
+
+<file path=ppt/slides/slide1.xml><?xml version="1.0" encoding="utf-8"?>
+<p:sld xmlns:a="http://schemas.openxmlformats.org/drawingml/2006/main" xmlns:r="http://schemas.openxmlformats.org/officeDocument/2006/relationships" xmlns:mc="http://schemas.openxmlformats.org/markup-compatibility/2006" xmlns:mv="urn:schemas-microsoft-com:mac:vml" xmlns:p="http://schemas.openxmlformats.org/presentationml/2006/main" xmlns:c="http://schemas.openxmlformats.org/drawingml/2006/chart" xmlns:dgm="http://schemas.openxmlformats.org/drawingml/2006/diagram" xmlns:o="urn:schemas-microsoft-com:office:office" xmlns:v="urn:schemas-microsoft-com:vml" xmlns:pvml="urn:schemas-microsoft-com:office:powerpoint" xmlns:com="http://schemas.openxmlformats.org/drawingml/2006/compatibility" xmlns:p14="http://schemas.microsoft.com/office/powerpoint/2010/main" xmlns:p15="http://schemas.microsoft.com/office/powerpoint/2012/main" xmlns:ahyp="http://schemas.microsoft.com/office/drawing/2018/hyperlinkcolor">
+  <p:cSld>
+    <p:spTree>
+      <p:nvGrpSpPr>
+        <p:cNvPr id="88" name="Shape 88"/>
+        <p:cNvGrpSpPr/>
+        <p:nvPr/>
+      </p:nvGrpSpPr>
+      <p:grpSpPr>
+        <a:xfrm>
+          <a:off x="0" y="0"/>
+          <a:ext cx="0" cy="0"/>
+          <a:chOff x="0" y="0"/>
+          <a:chExt cx="0" cy="0"/>
+        </a:xfrm>
+      </p:grpSpPr>
+    </p:spTree>
+  </p:cSld>
+  <p:clrMapOvr>
+    <a:masterClrMapping/>
+  </p:clrMapOvr>
+</p:sld>
+</file>
+
+<file path=ppt/slides/slide2.xml><?xml version="1.0" encoding="utf-8"?>
+<p:sld xmlns:a="http://schemas.openxmlformats.org/drawingml/2006/main" xmlns:r="http://schemas.openxmlformats.org/officeDocument/2006/relationships" xmlns:mc="http://schemas.openxmlformats.org/markup-compatibility/2006" xmlns:mv="urn:schemas-microsoft-com:mac:vml" xmlns:p="http://schemas.openxmlformats.org/presentationml/2006/main" xmlns:c="http://schemas.openxmlformats.org/drawingml/2006/chart" xmlns:dgm="http://schemas.openxmlformats.org/drawingml/2006/diagram" xmlns:o="urn:schemas-microsoft-com:office:office" xmlns:v="urn:schemas-microsoft-com:vml" xmlns:pvml="urn:schemas-microsoft-com:office:powerpoint" xmlns:com="http://schemas.openxmlformats.org/drawingml/2006/compatibility" xmlns:p14="http://schemas.microsoft.com/office/powerpoint/2010/main" xmlns:p15="http://schemas.microsoft.com/office/powerpoint/2012/main" xmlns:ahyp="http://schemas.microsoft.com/office/drawing/2018/hyperlinkcolor">
+  <p:cSld>
+    <p:spTree>
+      <p:nvGrpSpPr>
+        <p:cNvPr id="92" name="Shape 92"/>
         <p:cNvGrpSpPr/>
         <p:nvPr/>
       </p:nvGrpSpPr>
@@ -10707,7 +12677,190 @@
       </p:grpSpPr>
       <p:sp>
         <p:nvSpPr>
-          <p:cNvPr id="84" name="Google Shape;84;p13"/>
+          <p:cNvPr id="93" name="Google Shape;93;p18"/>
+          <p:cNvSpPr txBox="1"/>
+          <p:nvPr>
+            <p:ph type="title"/>
+          </p:nvPr>
+        </p:nvSpPr>
+        <p:spPr>
+          <a:xfrm>
+            <a:off x="707550" y="1116700"/>
+            <a:ext cx="10515300" cy="3836100"/>
+          </a:xfrm>
+          <a:prstGeom prst="rect">
+            <a:avLst/>
+          </a:prstGeom>
+        </p:spPr>
+        <p:txBody>
+          <a:bodyPr anchorCtr="0" anchor="t" bIns="45700" lIns="91425" spcFirstLastPara="1" rIns="91425" wrap="square" tIns="45700">
+            <a:noAutofit/>
+          </a:bodyPr>
+          <a:lstStyle/>
+          <a:p>
+            <a:pPr indent="0" lvl="0" marL="0" rtl="0" algn="l">
+              <a:spcBef>
+                <a:spcPts val="0"/>
+              </a:spcBef>
+              <a:spcAft>
+                <a:spcPts val="0"/>
+              </a:spcAft>
+              <a:buNone/>
+            </a:pPr>
+            <a:r>
+              <a:rPr lang="en-US">
+                <a:latin typeface="Times New Roman"/>
+                <a:ea typeface="Times New Roman"/>
+                <a:cs typeface="Times New Roman"/>
+                <a:sym typeface="Times New Roman"/>
+              </a:rPr>
+              <a:t>20 + Team Solomid</a:t>
+            </a:r>
+            <a:endParaRPr>
+              <a:latin typeface="Times New Roman"/>
+              <a:ea typeface="Times New Roman"/>
+              <a:cs typeface="Times New Roman"/>
+              <a:sym typeface="Times New Roman"/>
+            </a:endParaRPr>
+          </a:p>
+          <a:p>
+            <a:pPr indent="0" lvl="0" marL="0" rtl="0" algn="l">
+              <a:spcBef>
+                <a:spcPts val="0"/>
+              </a:spcBef>
+              <a:spcAft>
+                <a:spcPts val="0"/>
+              </a:spcAft>
+              <a:buNone/>
+            </a:pPr>
+            <a:r>
+              <a:t/>
+            </a:r>
+            <a:endParaRPr>
+              <a:latin typeface="Times New Roman"/>
+              <a:ea typeface="Times New Roman"/>
+              <a:cs typeface="Times New Roman"/>
+              <a:sym typeface="Times New Roman"/>
+            </a:endParaRPr>
+          </a:p>
+          <a:p>
+            <a:pPr indent="0" lvl="0" marL="0" rtl="0" algn="l">
+              <a:spcBef>
+                <a:spcPts val="0"/>
+              </a:spcBef>
+              <a:spcAft>
+                <a:spcPts val="0"/>
+              </a:spcAft>
+              <a:buNone/>
+            </a:pPr>
+            <a:r>
+              <a:rPr lang="en-US">
+                <a:latin typeface="Times New Roman"/>
+                <a:ea typeface="Times New Roman"/>
+                <a:cs typeface="Times New Roman"/>
+                <a:sym typeface="Times New Roman"/>
+              </a:rPr>
+              <a:t>Keith So</a:t>
+            </a:r>
+            <a:endParaRPr>
+              <a:latin typeface="Times New Roman"/>
+              <a:ea typeface="Times New Roman"/>
+              <a:cs typeface="Times New Roman"/>
+              <a:sym typeface="Times New Roman"/>
+            </a:endParaRPr>
+          </a:p>
+          <a:p>
+            <a:pPr indent="0" lvl="0" marL="0" rtl="0" algn="l">
+              <a:spcBef>
+                <a:spcPts val="0"/>
+              </a:spcBef>
+              <a:spcAft>
+                <a:spcPts val="0"/>
+              </a:spcAft>
+              <a:buNone/>
+            </a:pPr>
+            <a:r>
+              <a:t/>
+            </a:r>
+            <a:endParaRPr>
+              <a:latin typeface="Times New Roman"/>
+              <a:ea typeface="Times New Roman"/>
+              <a:cs typeface="Times New Roman"/>
+              <a:sym typeface="Times New Roman"/>
+            </a:endParaRPr>
+          </a:p>
+          <a:p>
+            <a:pPr indent="0" lvl="0" marL="0" rtl="0" algn="l">
+              <a:spcBef>
+                <a:spcPts val="0"/>
+              </a:spcBef>
+              <a:spcAft>
+                <a:spcPts val="0"/>
+              </a:spcAft>
+              <a:buNone/>
+            </a:pPr>
+            <a:r>
+              <a:rPr lang="en-US">
+                <a:latin typeface="Times New Roman"/>
+                <a:ea typeface="Times New Roman"/>
+                <a:cs typeface="Times New Roman"/>
+                <a:sym typeface="Times New Roman"/>
+              </a:rPr>
+              <a:t>Resona - </a:t>
+            </a:r>
+            <a:r>
+              <a:rPr lang="en-US">
+                <a:latin typeface="Times New Roman"/>
+                <a:ea typeface="Times New Roman"/>
+                <a:cs typeface="Times New Roman"/>
+                <a:sym typeface="Times New Roman"/>
+              </a:rPr>
+              <a:t>A phone-based, two-minute wellness check-in for teams at work.</a:t>
+            </a:r>
+            <a:endParaRPr>
+              <a:latin typeface="Times New Roman"/>
+              <a:ea typeface="Times New Roman"/>
+              <a:cs typeface="Times New Roman"/>
+              <a:sym typeface="Times New Roman"/>
+            </a:endParaRPr>
+          </a:p>
+        </p:txBody>
+      </p:sp>
+    </p:spTree>
+  </p:cSld>
+  <p:clrMapOvr>
+    <a:masterClrMapping/>
+  </p:clrMapOvr>
+</p:sld>
+</file>
+
+<file path=ppt/slides/slide3.xml><?xml version="1.0" encoding="utf-8"?>
+<p:sld xmlns:a="http://schemas.openxmlformats.org/drawingml/2006/main" xmlns:r="http://schemas.openxmlformats.org/officeDocument/2006/relationships" xmlns:mc="http://schemas.openxmlformats.org/markup-compatibility/2006" xmlns:mv="urn:schemas-microsoft-com:mac:vml" xmlns:p="http://schemas.openxmlformats.org/presentationml/2006/main" xmlns:c="http://schemas.openxmlformats.org/drawingml/2006/chart" xmlns:dgm="http://schemas.openxmlformats.org/drawingml/2006/diagram" xmlns:o="urn:schemas-microsoft-com:office:office" xmlns:v="urn:schemas-microsoft-com:vml" xmlns:pvml="urn:schemas-microsoft-com:office:powerpoint" xmlns:com="http://schemas.openxmlformats.org/drawingml/2006/compatibility" xmlns:p14="http://schemas.microsoft.com/office/powerpoint/2010/main" xmlns:p15="http://schemas.microsoft.com/office/powerpoint/2012/main" xmlns:ahyp="http://schemas.microsoft.com/office/drawing/2018/hyperlinkcolor">
+  <p:cSld>
+    <p:bg>
+      <p:bgPr>
+        <a:solidFill>
+          <a:srgbClr val="12131A"/>
+        </a:solidFill>
+      </p:bgPr>
+    </p:bg>
+    <p:spTree>
+      <p:nvGrpSpPr>
+        <p:cNvPr id="97" name="Shape 97"/>
+        <p:cNvGrpSpPr/>
+        <p:nvPr/>
+      </p:nvGrpSpPr>
+      <p:grpSpPr>
+        <a:xfrm>
+          <a:off x="0" y="0"/>
+          <a:ext cx="0" cy="0"/>
+          <a:chOff x="0" y="0"/>
+          <a:chExt cx="0" cy="0"/>
+        </a:xfrm>
+      </p:grpSpPr>
+      <p:sp>
+        <p:nvSpPr>
+          <p:cNvPr id="98" name="Google Shape;98;p19"/>
           <p:cNvSpPr txBox="1"/>
           <p:nvPr/>
         </p:nvSpPr>
@@ -10757,7 +12910,7 @@
       </p:sp>
       <p:sp>
         <p:nvSpPr>
-          <p:cNvPr id="85" name="Google Shape;85;p13"/>
+          <p:cNvPr id="99" name="Google Shape;99;p19"/>
           <p:cNvSpPr txBox="1"/>
           <p:nvPr/>
         </p:nvSpPr>
@@ -10827,7 +12980,7 @@
       </p:sp>
       <p:sp>
         <p:nvSpPr>
-          <p:cNvPr id="86" name="Google Shape;86;p13"/>
+          <p:cNvPr id="100" name="Google Shape;100;p19"/>
           <p:cNvSpPr/>
           <p:nvPr/>
         </p:nvSpPr>
@@ -10878,7 +13031,7 @@
       </p:sp>
       <p:sp>
         <p:nvSpPr>
-          <p:cNvPr id="87" name="Google Shape;87;p13"/>
+          <p:cNvPr id="101" name="Google Shape;101;p19"/>
           <p:cNvSpPr txBox="1"/>
           <p:nvPr/>
         </p:nvSpPr>
@@ -10928,7 +13081,7 @@
       </p:sp>
       <p:sp>
         <p:nvSpPr>
-          <p:cNvPr id="88" name="Google Shape;88;p13"/>
+          <p:cNvPr id="102" name="Google Shape;102;p19"/>
           <p:cNvSpPr txBox="1"/>
           <p:nvPr/>
         </p:nvSpPr>
@@ -10978,7 +13131,7 @@
       </p:sp>
       <p:sp>
         <p:nvSpPr>
-          <p:cNvPr id="89" name="Google Shape;89;p13"/>
+          <p:cNvPr id="103" name="Google Shape;103;p19"/>
           <p:cNvSpPr txBox="1"/>
           <p:nvPr/>
         </p:nvSpPr>
@@ -11028,7 +13181,7 @@
       </p:sp>
       <p:sp>
         <p:nvSpPr>
-          <p:cNvPr id="90" name="Google Shape;90;p13"/>
+          <p:cNvPr id="104" name="Google Shape;104;p19"/>
           <p:cNvSpPr txBox="1"/>
           <p:nvPr/>
         </p:nvSpPr>
@@ -11078,7 +13231,7 @@
       </p:sp>
       <p:sp>
         <p:nvSpPr>
-          <p:cNvPr id="91" name="Google Shape;91;p13"/>
+          <p:cNvPr id="105" name="Google Shape;105;p19"/>
           <p:cNvSpPr txBox="1"/>
           <p:nvPr/>
         </p:nvSpPr>
@@ -11128,7 +13281,7 @@
       </p:sp>
       <p:sp>
         <p:nvSpPr>
-          <p:cNvPr id="92" name="Google Shape;92;p13"/>
+          <p:cNvPr id="106" name="Google Shape;106;p19"/>
           <p:cNvSpPr txBox="1"/>
           <p:nvPr/>
         </p:nvSpPr>
@@ -11178,7 +13331,7 @@
       </p:sp>
       <p:sp>
         <p:nvSpPr>
-          <p:cNvPr id="93" name="Google Shape;93;p13"/>
+          <p:cNvPr id="107" name="Google Shape;107;p19"/>
           <p:cNvSpPr/>
           <p:nvPr/>
         </p:nvSpPr>
@@ -11229,7 +13382,7 @@
       </p:sp>
       <p:sp>
         <p:nvSpPr>
-          <p:cNvPr id="94" name="Google Shape;94;p13"/>
+          <p:cNvPr id="108" name="Google Shape;108;p19"/>
           <p:cNvSpPr txBox="1"/>
           <p:nvPr/>
         </p:nvSpPr>
@@ -11279,7 +13432,7 @@
       </p:sp>
       <p:sp>
         <p:nvSpPr>
-          <p:cNvPr id="95" name="Google Shape;95;p13"/>
+          <p:cNvPr id="109" name="Google Shape;109;p19"/>
           <p:cNvSpPr/>
           <p:nvPr/>
         </p:nvSpPr>
@@ -11336,7 +13489,7 @@
       </p:sp>
       <p:sp>
         <p:nvSpPr>
-          <p:cNvPr id="96" name="Google Shape;96;p13"/>
+          <p:cNvPr id="110" name="Google Shape;110;p19"/>
           <p:cNvSpPr txBox="1"/>
           <p:nvPr/>
         </p:nvSpPr>
@@ -11386,7 +13539,7 @@
       </p:sp>
       <p:sp>
         <p:nvSpPr>
-          <p:cNvPr id="97" name="Google Shape;97;p13"/>
+          <p:cNvPr id="111" name="Google Shape;111;p19"/>
           <p:cNvSpPr/>
           <p:nvPr/>
         </p:nvSpPr>
@@ -11443,7 +13596,7 @@
       </p:sp>
       <p:sp>
         <p:nvSpPr>
-          <p:cNvPr id="98" name="Google Shape;98;p13"/>
+          <p:cNvPr id="112" name="Google Shape;112;p19"/>
           <p:cNvSpPr txBox="1"/>
           <p:nvPr/>
         </p:nvSpPr>
@@ -11493,7 +13646,7 @@
       </p:sp>
       <p:sp>
         <p:nvSpPr>
-          <p:cNvPr id="99" name="Google Shape;99;p13"/>
+          <p:cNvPr id="113" name="Google Shape;113;p19"/>
           <p:cNvSpPr/>
           <p:nvPr/>
         </p:nvSpPr>
@@ -11550,7 +13703,7 @@
       </p:sp>
       <p:sp>
         <p:nvSpPr>
-          <p:cNvPr id="100" name="Google Shape;100;p13"/>
+          <p:cNvPr id="114" name="Google Shape;114;p19"/>
           <p:cNvSpPr txBox="1"/>
           <p:nvPr/>
         </p:nvSpPr>
@@ -11600,7 +13753,7 @@
       </p:sp>
       <p:sp>
         <p:nvSpPr>
-          <p:cNvPr id="101" name="Google Shape;101;p13"/>
+          <p:cNvPr id="115" name="Google Shape;115;p19"/>
           <p:cNvSpPr/>
           <p:nvPr/>
         </p:nvSpPr>
@@ -11657,7 +13810,7 @@
       </p:sp>
       <p:sp>
         <p:nvSpPr>
-          <p:cNvPr id="102" name="Google Shape;102;p13"/>
+          <p:cNvPr id="116" name="Google Shape;116;p19"/>
           <p:cNvSpPr txBox="1"/>
           <p:nvPr/>
         </p:nvSpPr>
@@ -11707,7 +13860,7 @@
       </p:sp>
       <p:sp>
         <p:nvSpPr>
-          <p:cNvPr id="103" name="Google Shape;103;p13"/>
+          <p:cNvPr id="117" name="Google Shape;117;p19"/>
           <p:cNvSpPr txBox="1"/>
           <p:nvPr/>
         </p:nvSpPr>
@@ -11769,7 +13922,7 @@
       </p:sp>
       <p:sp>
         <p:nvSpPr>
-          <p:cNvPr id="104" name="Google Shape;104;p13"/>
+          <p:cNvPr id="118" name="Google Shape;118;p19"/>
           <p:cNvSpPr/>
           <p:nvPr/>
         </p:nvSpPr>
@@ -11826,7 +13979,7 @@
       </p:sp>
       <p:sp>
         <p:nvSpPr>
-          <p:cNvPr id="105" name="Google Shape;105;p13"/>
+          <p:cNvPr id="119" name="Google Shape;119;p19"/>
           <p:cNvSpPr/>
           <p:nvPr/>
         </p:nvSpPr>
@@ -11877,7 +14030,7 @@
       </p:sp>
       <p:sp>
         <p:nvSpPr>
-          <p:cNvPr id="106" name="Google Shape;106;p13"/>
+          <p:cNvPr id="120" name="Google Shape;120;p19"/>
           <p:cNvSpPr txBox="1"/>
           <p:nvPr/>
         </p:nvSpPr>
@@ -11927,7 +14080,7 @@
       </p:sp>
       <p:sp>
         <p:nvSpPr>
-          <p:cNvPr id="107" name="Google Shape;107;p13"/>
+          <p:cNvPr id="121" name="Google Shape;121;p19"/>
           <p:cNvSpPr txBox="1"/>
           <p:nvPr/>
         </p:nvSpPr>
@@ -12001,7 +14154,7 @@
       </p:sp>
       <p:sp>
         <p:nvSpPr>
-          <p:cNvPr id="108" name="Google Shape;108;p13"/>
+          <p:cNvPr id="122" name="Google Shape;122;p19"/>
           <p:cNvSpPr txBox="1"/>
           <p:nvPr/>
         </p:nvSpPr>
@@ -12051,7 +14204,7 @@
       </p:sp>
       <p:sp>
         <p:nvSpPr>
-          <p:cNvPr id="109" name="Google Shape;109;p13"/>
+          <p:cNvPr id="123" name="Google Shape;123;p19"/>
           <p:cNvSpPr txBox="1"/>
           <p:nvPr/>
         </p:nvSpPr>
@@ -12101,7 +14254,7 @@
       </p:sp>
       <p:sp>
         <p:nvSpPr>
-          <p:cNvPr id="110" name="Google Shape;110;p13"/>
+          <p:cNvPr id="124" name="Google Shape;124;p19"/>
           <p:cNvSpPr txBox="1"/>
           <p:nvPr/>
         </p:nvSpPr>
@@ -12175,7 +14328,7 @@
       </p:sp>
       <p:sp>
         <p:nvSpPr>
-          <p:cNvPr id="111" name="Google Shape;111;p13"/>
+          <p:cNvPr id="125" name="Google Shape;125;p19"/>
           <p:cNvSpPr txBox="1"/>
           <p:nvPr/>
         </p:nvSpPr>
@@ -12225,7 +14378,7 @@
       </p:sp>
       <p:sp>
         <p:nvSpPr>
-          <p:cNvPr id="112" name="Google Shape;112;p13"/>
+          <p:cNvPr id="126" name="Google Shape;126;p19"/>
           <p:cNvSpPr txBox="1"/>
           <p:nvPr/>
         </p:nvSpPr>
@@ -12275,7 +14428,7 @@
       </p:sp>
       <p:sp>
         <p:nvSpPr>
-          <p:cNvPr id="113" name="Google Shape;113;p13"/>
+          <p:cNvPr id="127" name="Google Shape;127;p19"/>
           <p:cNvSpPr txBox="1"/>
           <p:nvPr/>
         </p:nvSpPr>
@@ -12337,7 +14490,7 @@
       </p:sp>
       <p:sp>
         <p:nvSpPr>
-          <p:cNvPr id="114" name="Google Shape;114;p13"/>
+          <p:cNvPr id="128" name="Google Shape;128;p19"/>
           <p:cNvSpPr txBox="1"/>
           <p:nvPr/>
         </p:nvSpPr>
@@ -12387,7 +14540,7 @@
       </p:sp>
       <p:sp>
         <p:nvSpPr>
-          <p:cNvPr id="115" name="Google Shape;115;p13"/>
+          <p:cNvPr id="129" name="Google Shape;129;p19"/>
           <p:cNvSpPr txBox="1"/>
           <p:nvPr/>
         </p:nvSpPr>
@@ -12437,7 +14590,7 @@
       </p:sp>
       <p:sp>
         <p:nvSpPr>
-          <p:cNvPr id="116" name="Google Shape;116;p13"/>
+          <p:cNvPr id="130" name="Google Shape;130;p19"/>
           <p:cNvSpPr/>
           <p:nvPr/>
         </p:nvSpPr>
@@ -12488,7 +14641,7 @@
       </p:sp>
       <p:sp>
         <p:nvSpPr>
-          <p:cNvPr id="117" name="Google Shape;117;p13"/>
+          <p:cNvPr id="131" name="Google Shape;131;p19"/>
           <p:cNvSpPr txBox="1"/>
           <p:nvPr/>
         </p:nvSpPr>
@@ -12538,7 +14691,7 @@
       </p:sp>
       <p:sp>
         <p:nvSpPr>
-          <p:cNvPr id="118" name="Google Shape;118;p13"/>
+          <p:cNvPr id="132" name="Google Shape;132;p19"/>
           <p:cNvSpPr txBox="1"/>
           <p:nvPr/>
         </p:nvSpPr>
@@ -12594,7 +14747,7 @@
 </p:sld>
 </file>
 
-<file path=ppt/slides/slide2.xml><?xml version="1.0" encoding="utf-8"?>
+<file path=ppt/slides/slide4.xml><?xml version="1.0" encoding="utf-8"?>
 <p:sld xmlns:a="http://schemas.openxmlformats.org/drawingml/2006/main" xmlns:r="http://schemas.openxmlformats.org/officeDocument/2006/relationships" xmlns:mc="http://schemas.openxmlformats.org/markup-compatibility/2006" xmlns:mv="urn:schemas-microsoft-com:mac:vml" xmlns:p="http://schemas.openxmlformats.org/presentationml/2006/main" xmlns:c="http://schemas.openxmlformats.org/drawingml/2006/chart" xmlns:dgm="http://schemas.openxmlformats.org/drawingml/2006/diagram" xmlns:o="urn:schemas-microsoft-com:office:office" xmlns:v="urn:schemas-microsoft-com:vml" xmlns:pvml="urn:schemas-microsoft-com:office:powerpoint" xmlns:com="http://schemas.openxmlformats.org/drawingml/2006/compatibility" xmlns:p14="http://schemas.microsoft.com/office/powerpoint/2010/main" xmlns:p15="http://schemas.microsoft.com/office/powerpoint/2012/main" xmlns:ahyp="http://schemas.microsoft.com/office/drawing/2018/hyperlinkcolor">
   <p:cSld>
     <p:bg>
@@ -12606,7 +14759,7 @@
     </p:bg>
     <p:spTree>
       <p:nvGrpSpPr>
-        <p:cNvPr id="122" name="Shape 122"/>
+        <p:cNvPr id="136" name="Shape 136"/>
         <p:cNvGrpSpPr/>
         <p:nvPr/>
       </p:nvGrpSpPr>
@@ -12620,7 +14773,7 @@
       </p:grpSpPr>
       <p:sp>
         <p:nvSpPr>
-          <p:cNvPr id="123" name="Google Shape;123;p14"/>
+          <p:cNvPr id="137" name="Google Shape;137;p20"/>
           <p:cNvSpPr txBox="1"/>
           <p:nvPr/>
         </p:nvSpPr>
@@ -12670,7 +14823,7 @@
       </p:sp>
       <p:sp>
         <p:nvSpPr>
-          <p:cNvPr id="124" name="Google Shape;124;p14"/>
+          <p:cNvPr id="138" name="Google Shape;138;p20"/>
           <p:cNvSpPr txBox="1"/>
           <p:nvPr/>
         </p:nvSpPr>
@@ -12740,7 +14893,7 @@
       </p:sp>
       <p:sp>
         <p:nvSpPr>
-          <p:cNvPr id="125" name="Google Shape;125;p14"/>
+          <p:cNvPr id="139" name="Google Shape;139;p20"/>
           <p:cNvSpPr/>
           <p:nvPr/>
         </p:nvSpPr>
@@ -12791,7 +14944,7 @@
       </p:sp>
       <p:sp>
         <p:nvSpPr>
-          <p:cNvPr id="126" name="Google Shape;126;p14"/>
+          <p:cNvPr id="140" name="Google Shape;140;p20"/>
           <p:cNvSpPr txBox="1"/>
           <p:nvPr/>
         </p:nvSpPr>
@@ -12841,7 +14994,7 @@
       </p:sp>
       <p:sp>
         <p:nvSpPr>
-          <p:cNvPr id="127" name="Google Shape;127;p14"/>
+          <p:cNvPr id="141" name="Google Shape;141;p20"/>
           <p:cNvSpPr txBox="1"/>
           <p:nvPr/>
         </p:nvSpPr>
@@ -12912,7 +15065,7 @@
                 <a:cs typeface="Times New Roman"/>
                 <a:sym typeface="Times New Roman"/>
               </a:rPr>
-              <a:t> of employees’ health and wellness directly, businesses are able to be more productive,, less absent, and longer-tenured. The economics are settled. The delivery is not.</a:t>
+              <a:t> of employees’ health and wellness directly, businesses are able to be more productive, less absent, and longer-tenured. The economics are settled. The delivery is not.</a:t>
             </a:r>
             <a:endParaRPr sz="3000">
               <a:solidFill>
@@ -12979,7 +15132,7 @@
       </p:sp>
       <p:sp>
         <p:nvSpPr>
-          <p:cNvPr id="128" name="Google Shape;128;p14"/>
+          <p:cNvPr id="142" name="Google Shape;142;p20"/>
           <p:cNvSpPr/>
           <p:nvPr/>
         </p:nvSpPr>
@@ -13036,7 +15189,7 @@
       </p:sp>
       <p:sp>
         <p:nvSpPr>
-          <p:cNvPr id="129" name="Google Shape;129;p14"/>
+          <p:cNvPr id="143" name="Google Shape;143;p20"/>
           <p:cNvSpPr/>
           <p:nvPr/>
         </p:nvSpPr>
@@ -13087,7 +15240,7 @@
       </p:sp>
       <p:sp>
         <p:nvSpPr>
-          <p:cNvPr id="130" name="Google Shape;130;p14"/>
+          <p:cNvPr id="144" name="Google Shape;144;p20"/>
           <p:cNvSpPr txBox="1"/>
           <p:nvPr/>
         </p:nvSpPr>
@@ -13149,7 +15302,7 @@
       </p:sp>
       <p:sp>
         <p:nvSpPr>
-          <p:cNvPr id="131" name="Google Shape;131;p14"/>
+          <p:cNvPr id="145" name="Google Shape;145;p20"/>
           <p:cNvSpPr txBox="1"/>
           <p:nvPr/>
         </p:nvSpPr>
@@ -13199,7 +15352,7 @@
       </p:sp>
       <p:sp>
         <p:nvSpPr>
-          <p:cNvPr id="132" name="Google Shape;132;p14"/>
+          <p:cNvPr id="146" name="Google Shape;146;p20"/>
           <p:cNvSpPr txBox="1"/>
           <p:nvPr/>
         </p:nvSpPr>
@@ -13273,7 +15426,7 @@
       </p:sp>
       <p:sp>
         <p:nvSpPr>
-          <p:cNvPr id="133" name="Google Shape;133;p14"/>
+          <p:cNvPr id="147" name="Google Shape;147;p20"/>
           <p:cNvSpPr txBox="1"/>
           <p:nvPr/>
         </p:nvSpPr>
@@ -13323,7 +15476,7 @@
       </p:sp>
       <p:sp>
         <p:nvSpPr>
-          <p:cNvPr id="134" name="Google Shape;134;p14"/>
+          <p:cNvPr id="148" name="Google Shape;148;p20"/>
           <p:cNvSpPr txBox="1"/>
           <p:nvPr/>
         </p:nvSpPr>
@@ -13373,7 +15526,7 @@
       </p:sp>
       <p:sp>
         <p:nvSpPr>
-          <p:cNvPr id="135" name="Google Shape;135;p14"/>
+          <p:cNvPr id="149" name="Google Shape;149;p20"/>
           <p:cNvSpPr/>
           <p:nvPr/>
         </p:nvSpPr>
@@ -13430,7 +15583,7 @@
       </p:sp>
       <p:sp>
         <p:nvSpPr>
-          <p:cNvPr id="136" name="Google Shape;136;p14"/>
+          <p:cNvPr id="150" name="Google Shape;150;p20"/>
           <p:cNvSpPr/>
           <p:nvPr/>
         </p:nvSpPr>
@@ -13481,7 +15634,7 @@
       </p:sp>
       <p:sp>
         <p:nvSpPr>
-          <p:cNvPr id="137" name="Google Shape;137;p14"/>
+          <p:cNvPr id="151" name="Google Shape;151;p20"/>
           <p:cNvSpPr txBox="1"/>
           <p:nvPr/>
         </p:nvSpPr>
@@ -13543,7 +15696,7 @@
       </p:sp>
       <p:sp>
         <p:nvSpPr>
-          <p:cNvPr id="138" name="Google Shape;138;p14"/>
+          <p:cNvPr id="152" name="Google Shape;152;p20"/>
           <p:cNvSpPr txBox="1"/>
           <p:nvPr/>
         </p:nvSpPr>
@@ -13593,7 +15746,7 @@
       </p:sp>
       <p:sp>
         <p:nvSpPr>
-          <p:cNvPr id="139" name="Google Shape;139;p14"/>
+          <p:cNvPr id="153" name="Google Shape;153;p20"/>
           <p:cNvSpPr txBox="1"/>
           <p:nvPr/>
         </p:nvSpPr>
@@ -13667,7 +15820,7 @@
       </p:sp>
       <p:sp>
         <p:nvSpPr>
-          <p:cNvPr id="140" name="Google Shape;140;p14"/>
+          <p:cNvPr id="154" name="Google Shape;154;p20"/>
           <p:cNvSpPr txBox="1"/>
           <p:nvPr/>
         </p:nvSpPr>
@@ -13717,7 +15870,7 @@
       </p:sp>
       <p:sp>
         <p:nvSpPr>
-          <p:cNvPr id="141" name="Google Shape;141;p14"/>
+          <p:cNvPr id="155" name="Google Shape;155;p20"/>
           <p:cNvSpPr txBox="1"/>
           <p:nvPr/>
         </p:nvSpPr>
@@ -13767,7 +15920,7 @@
       </p:sp>
       <p:sp>
         <p:nvSpPr>
-          <p:cNvPr id="142" name="Google Shape;142;p14"/>
+          <p:cNvPr id="156" name="Google Shape;156;p20"/>
           <p:cNvSpPr txBox="1"/>
           <p:nvPr/>
         </p:nvSpPr>
@@ -13817,7 +15970,7 @@
       </p:sp>
       <p:sp>
         <p:nvSpPr>
-          <p:cNvPr id="143" name="Google Shape;143;p14"/>
+          <p:cNvPr id="157" name="Google Shape;157;p20"/>
           <p:cNvSpPr/>
           <p:nvPr/>
         </p:nvSpPr>
@@ -13868,7 +16021,7 @@
       </p:sp>
       <p:sp>
         <p:nvSpPr>
-          <p:cNvPr id="144" name="Google Shape;144;p14"/>
+          <p:cNvPr id="158" name="Google Shape;158;p20"/>
           <p:cNvSpPr txBox="1"/>
           <p:nvPr/>
         </p:nvSpPr>
@@ -13918,7 +16071,7 @@
       </p:sp>
       <p:sp>
         <p:nvSpPr>
-          <p:cNvPr id="145" name="Google Shape;145;p14"/>
+          <p:cNvPr id="159" name="Google Shape;159;p20"/>
           <p:cNvSpPr txBox="1"/>
           <p:nvPr/>
         </p:nvSpPr>
@@ -13974,7 +16127,7 @@
 </p:sld>
 </file>
 
-<file path=ppt/slides/slide3.xml><?xml version="1.0" encoding="utf-8"?>
+<file path=ppt/slides/slide5.xml><?xml version="1.0" encoding="utf-8"?>
 <p:sld xmlns:a="http://schemas.openxmlformats.org/drawingml/2006/main" xmlns:r="http://schemas.openxmlformats.org/officeDocument/2006/relationships" xmlns:mc="http://schemas.openxmlformats.org/markup-compatibility/2006" xmlns:mv="urn:schemas-microsoft-com:mac:vml" xmlns:p="http://schemas.openxmlformats.org/presentationml/2006/main" xmlns:c="http://schemas.openxmlformats.org/drawingml/2006/chart" xmlns:dgm="http://schemas.openxmlformats.org/drawingml/2006/diagram" xmlns:o="urn:schemas-microsoft-com:office:office" xmlns:v="urn:schemas-microsoft-com:vml" xmlns:pvml="urn:schemas-microsoft-com:office:powerpoint" xmlns:com="http://schemas.openxmlformats.org/drawingml/2006/compatibility" xmlns:p14="http://schemas.microsoft.com/office/powerpoint/2010/main" xmlns:p15="http://schemas.microsoft.com/office/powerpoint/2012/main" xmlns:ahyp="http://schemas.microsoft.com/office/drawing/2018/hyperlinkcolor">
   <p:cSld>
     <p:bg>
@@ -13986,7 +16139,7 @@
     </p:bg>
     <p:spTree>
       <p:nvGrpSpPr>
-        <p:cNvPr id="149" name="Shape 149"/>
+        <p:cNvPr id="163" name="Shape 163"/>
         <p:cNvGrpSpPr/>
         <p:nvPr/>
       </p:nvGrpSpPr>
@@ -14000,7 +16153,7 @@
       </p:grpSpPr>
       <p:sp>
         <p:nvSpPr>
-          <p:cNvPr id="150" name="Google Shape;150;p15"/>
+          <p:cNvPr id="164" name="Google Shape;164;p21"/>
           <p:cNvSpPr txBox="1"/>
           <p:nvPr/>
         </p:nvSpPr>
@@ -14050,7 +16203,7 @@
       </p:sp>
       <p:sp>
         <p:nvSpPr>
-          <p:cNvPr id="151" name="Google Shape;151;p15"/>
+          <p:cNvPr id="165" name="Google Shape;165;p21"/>
           <p:cNvSpPr txBox="1"/>
           <p:nvPr/>
         </p:nvSpPr>
@@ -14120,7 +16273,7 @@
       </p:sp>
       <p:sp>
         <p:nvSpPr>
-          <p:cNvPr id="152" name="Google Shape;152;p15"/>
+          <p:cNvPr id="166" name="Google Shape;166;p21"/>
           <p:cNvSpPr/>
           <p:nvPr/>
         </p:nvSpPr>
@@ -14171,7 +16324,7 @@
       </p:sp>
       <p:sp>
         <p:nvSpPr>
-          <p:cNvPr id="153" name="Google Shape;153;p15"/>
+          <p:cNvPr id="167" name="Google Shape;167;p21"/>
           <p:cNvSpPr txBox="1"/>
           <p:nvPr/>
         </p:nvSpPr>
@@ -14221,14 +16374,14 @@
       </p:sp>
       <p:sp>
         <p:nvSpPr>
-          <p:cNvPr id="154" name="Google Shape;154;p15"/>
+          <p:cNvPr id="168" name="Google Shape;168;p21"/>
           <p:cNvSpPr txBox="1"/>
           <p:nvPr/>
         </p:nvSpPr>
         <p:spPr>
           <a:xfrm>
             <a:off x="685800" y="1554480"/>
-            <a:ext cx="10820095" cy="1097280"/>
+            <a:ext cx="10820100" cy="831300"/>
           </a:xfrm>
           <a:prstGeom prst="rect">
             <a:avLst/>
@@ -14253,6 +16406,30 @@
               </a:spcAft>
               <a:buNone/>
             </a:pPr>
+            <a:r>
+              <a:rPr b="1" lang="en-US" sz="5400">
+                <a:solidFill>
+                  <a:srgbClr val="F4ECE1"/>
+                </a:solidFill>
+                <a:latin typeface="Times New Roman"/>
+                <a:ea typeface="Times New Roman"/>
+                <a:cs typeface="Times New Roman"/>
+                <a:sym typeface="Times New Roman"/>
+              </a:rPr>
+              <a:t>Resona</a:t>
+            </a:r>
+            <a:r>
+              <a:rPr lang="en-US" sz="5400">
+                <a:solidFill>
+                  <a:srgbClr val="F4ECE1"/>
+                </a:solidFill>
+                <a:latin typeface="Times New Roman"/>
+                <a:ea typeface="Times New Roman"/>
+                <a:cs typeface="Times New Roman"/>
+                <a:sym typeface="Times New Roman"/>
+              </a:rPr>
+              <a:t>. </a:t>
+            </a:r>
             <a:r>
               <a:rPr lang="en-US" sz="5400">
                 <a:solidFill>
@@ -14283,7 +16460,7 @@
       </p:sp>
       <p:sp>
         <p:nvSpPr>
-          <p:cNvPr id="155" name="Google Shape;155;p15"/>
+          <p:cNvPr id="169" name="Google Shape;169;p21"/>
           <p:cNvSpPr/>
           <p:nvPr/>
         </p:nvSpPr>
@@ -14340,7 +16517,7 @@
       </p:sp>
       <p:sp>
         <p:nvSpPr>
-          <p:cNvPr id="156" name="Google Shape;156;p15"/>
+          <p:cNvPr id="170" name="Google Shape;170;p21"/>
           <p:cNvSpPr txBox="1"/>
           <p:nvPr/>
         </p:nvSpPr>
@@ -14390,7 +16567,7 @@
       </p:sp>
       <p:sp>
         <p:nvSpPr>
-          <p:cNvPr id="157" name="Google Shape;157;p15"/>
+          <p:cNvPr id="171" name="Google Shape;171;p21"/>
           <p:cNvSpPr txBox="1"/>
           <p:nvPr/>
         </p:nvSpPr>
@@ -14440,7 +16617,7 @@
       </p:sp>
       <p:sp>
         <p:nvSpPr>
-          <p:cNvPr id="158" name="Google Shape;158;p15"/>
+          <p:cNvPr id="172" name="Google Shape;172;p21"/>
           <p:cNvSpPr txBox="1"/>
           <p:nvPr/>
         </p:nvSpPr>
@@ -14490,7 +16667,7 @@
       </p:sp>
       <p:sp>
         <p:nvSpPr>
-          <p:cNvPr id="159" name="Google Shape;159;p15"/>
+          <p:cNvPr id="173" name="Google Shape;173;p21"/>
           <p:cNvSpPr txBox="1"/>
           <p:nvPr/>
         </p:nvSpPr>
@@ -14540,14 +16717,88 @@
       </p:sp>
       <p:sp>
         <p:nvSpPr>
-          <p:cNvPr id="160" name="Google Shape;160;p15"/>
+          <p:cNvPr id="174" name="Google Shape;174;p21"/>
           <p:cNvSpPr txBox="1"/>
           <p:nvPr/>
         </p:nvSpPr>
         <p:spPr>
           <a:xfrm>
-            <a:off x="960120" y="4389110"/>
-            <a:ext cx="2753400" cy="677400"/>
+            <a:off x="959870" y="4232498"/>
+            <a:ext cx="2753400" cy="1015800"/>
+          </a:xfrm>
+          <a:prstGeom prst="rect">
+            <a:avLst/>
+          </a:prstGeom>
+          <a:noFill/>
+          <a:ln>
+            <a:noFill/>
+          </a:ln>
+        </p:spPr>
+        <p:txBody>
+          <a:bodyPr anchorCtr="0" anchor="t" bIns="0" lIns="0" spcFirstLastPara="1" rIns="0" wrap="square" tIns="0">
+            <a:spAutoFit/>
+          </a:bodyPr>
+          <a:lstStyle/>
+          <a:p>
+            <a:pPr indent="0" lvl="0" marL="0" rtl="0" algn="l">
+              <a:spcBef>
+                <a:spcPts val="0"/>
+              </a:spcBef>
+              <a:spcAft>
+                <a:spcPts val="0"/>
+              </a:spcAft>
+              <a:buClr>
+                <a:schemeClr val="dk1"/>
+              </a:buClr>
+              <a:buSzPts val="1100"/>
+              <a:buFont typeface="Arial"/>
+              <a:buNone/>
+            </a:pPr>
+            <a:r>
+              <a:rPr lang="en-US" sz="1100">
+                <a:solidFill>
+                  <a:srgbClr val="B8AC94"/>
+                </a:solidFill>
+              </a:rPr>
+              <a:t>FEV1, FVC, PEF. Forced exhalation analysed from turbulent flow noise. Normalised to Hankinson NHANES III predicted values, ATS/ERS 2019 quality flags.</a:t>
+            </a:r>
+            <a:endParaRPr sz="1100">
+              <a:solidFill>
+                <a:srgbClr val="B8AC94"/>
+              </a:solidFill>
+            </a:endParaRPr>
+          </a:p>
+          <a:p>
+            <a:pPr indent="0" lvl="0" marL="0" marR="0" rtl="0" algn="l">
+              <a:spcBef>
+                <a:spcPts val="0"/>
+              </a:spcBef>
+              <a:spcAft>
+                <a:spcPts val="0"/>
+              </a:spcAft>
+              <a:buNone/>
+            </a:pPr>
+            <a:r>
+              <a:t/>
+            </a:r>
+            <a:endParaRPr sz="1100">
+              <a:solidFill>
+                <a:srgbClr val="B8AC94"/>
+              </a:solidFill>
+            </a:endParaRPr>
+          </a:p>
+        </p:txBody>
+      </p:sp>
+      <p:sp>
+        <p:nvSpPr>
+          <p:cNvPr id="175" name="Google Shape;175;p21"/>
+          <p:cNvSpPr txBox="1"/>
+          <p:nvPr/>
+        </p:nvSpPr>
+        <p:spPr>
+          <a:xfrm>
+            <a:off x="960120" y="5074910"/>
+            <a:ext cx="2753400" cy="277200"/>
           </a:xfrm>
           <a:prstGeom prst="rect">
             <a:avLst/>
@@ -14573,57 +16824,7 @@
               <a:buNone/>
             </a:pPr>
             <a:r>
-              <a:rPr b="0" i="0" lang="en-US" sz="1100">
-                <a:solidFill>
-                  <a:srgbClr val="B8AC94"/>
-                </a:solidFill>
-                <a:latin typeface="Arial"/>
-                <a:ea typeface="Arial"/>
-                <a:cs typeface="Arial"/>
-                <a:sym typeface="Arial"/>
-              </a:rPr>
-              <a:t>FEV1, FVC, PEF. Forced exhalation analysed from turbulent flow noise. Normalised to Hankinson NHANES III predicted values.</a:t>
-            </a:r>
-            <a:endParaRPr/>
-          </a:p>
-        </p:txBody>
-      </p:sp>
-      <p:sp>
-        <p:nvSpPr>
-          <p:cNvPr id="161" name="Google Shape;161;p15"/>
-          <p:cNvSpPr txBox="1"/>
-          <p:nvPr/>
-        </p:nvSpPr>
-        <p:spPr>
-          <a:xfrm>
-            <a:off x="960120" y="5074910"/>
-            <a:ext cx="2753400" cy="138600"/>
-          </a:xfrm>
-          <a:prstGeom prst="rect">
-            <a:avLst/>
-          </a:prstGeom>
-          <a:noFill/>
-          <a:ln>
-            <a:noFill/>
-          </a:ln>
-        </p:spPr>
-        <p:txBody>
-          <a:bodyPr anchorCtr="0" anchor="t" bIns="0" lIns="0" spcFirstLastPara="1" rIns="0" wrap="square" tIns="0">
-            <a:spAutoFit/>
-          </a:bodyPr>
-          <a:lstStyle/>
-          <a:p>
-            <a:pPr indent="0" lvl="0" marL="0" marR="0" rtl="0" algn="l">
-              <a:spcBef>
-                <a:spcPts val="0"/>
-              </a:spcBef>
-              <a:spcAft>
-                <a:spcPts val="0"/>
-              </a:spcAft>
-              <a:buNone/>
-            </a:pPr>
-            <a:r>
-              <a:rPr b="0" i="1" lang="en-US" sz="900">
+              <a:rPr i="1" lang="en-US" sz="900">
                 <a:solidFill>
                   <a:srgbClr val="8A8272"/>
                 </a:solidFill>
@@ -14632,7 +16833,7 @@
                 <a:cs typeface="Times New Roman"/>
                 <a:sym typeface="Times New Roman"/>
               </a:rPr>
-              <a:t>6s blow · 48 kHz PCM · on-device</a:t>
+              <a:t>Goel et al., SpiroSmart, UbiComp 2012 · 6s blow · 48 kHz PCM · on-device</a:t>
             </a:r>
             <a:endParaRPr/>
           </a:p>
@@ -14640,7 +16841,7 @@
       </p:sp>
       <p:sp>
         <p:nvSpPr>
-          <p:cNvPr id="162" name="Google Shape;162;p15"/>
+          <p:cNvPr id="176" name="Google Shape;176;p21"/>
           <p:cNvSpPr/>
           <p:nvPr/>
         </p:nvSpPr>
@@ -14697,7 +16898,7 @@
       </p:sp>
       <p:sp>
         <p:nvSpPr>
-          <p:cNvPr id="163" name="Google Shape;163;p15"/>
+          <p:cNvPr id="177" name="Google Shape;177;p21"/>
           <p:cNvSpPr txBox="1"/>
           <p:nvPr/>
         </p:nvSpPr>
@@ -14747,7 +16948,7 @@
       </p:sp>
       <p:sp>
         <p:nvSpPr>
-          <p:cNvPr id="164" name="Google Shape;164;p15"/>
+          <p:cNvPr id="178" name="Google Shape;178;p21"/>
           <p:cNvSpPr txBox="1"/>
           <p:nvPr/>
         </p:nvSpPr>
@@ -14797,7 +16998,7 @@
       </p:sp>
       <p:sp>
         <p:nvSpPr>
-          <p:cNvPr id="165" name="Google Shape;165;p15"/>
+          <p:cNvPr id="179" name="Google Shape;179;p21"/>
           <p:cNvSpPr txBox="1"/>
           <p:nvPr/>
         </p:nvSpPr>
@@ -14847,7 +17048,7 @@
       </p:sp>
       <p:sp>
         <p:nvSpPr>
-          <p:cNvPr id="166" name="Google Shape;166;p15"/>
+          <p:cNvPr id="180" name="Google Shape;180;p21"/>
           <p:cNvSpPr txBox="1"/>
           <p:nvPr/>
         </p:nvSpPr>
@@ -14897,7 +17098,7 @@
       </p:sp>
       <p:sp>
         <p:nvSpPr>
-          <p:cNvPr id="167" name="Google Shape;167;p15"/>
+          <p:cNvPr id="181" name="Google Shape;181;p21"/>
           <p:cNvSpPr txBox="1"/>
           <p:nvPr/>
         </p:nvSpPr>
@@ -14947,7 +17148,7 @@
       </p:sp>
       <p:sp>
         <p:nvSpPr>
-          <p:cNvPr id="168" name="Google Shape;168;p15"/>
+          <p:cNvPr id="182" name="Google Shape;182;p21"/>
           <p:cNvSpPr txBox="1"/>
           <p:nvPr/>
         </p:nvSpPr>
@@ -14997,7 +17198,7 @@
       </p:sp>
       <p:sp>
         <p:nvSpPr>
-          <p:cNvPr id="169" name="Google Shape;169;p15"/>
+          <p:cNvPr id="183" name="Google Shape;183;p21"/>
           <p:cNvSpPr/>
           <p:nvPr/>
         </p:nvSpPr>
@@ -15054,7 +17255,7 @@
       </p:sp>
       <p:sp>
         <p:nvSpPr>
-          <p:cNvPr id="170" name="Google Shape;170;p15"/>
+          <p:cNvPr id="184" name="Google Shape;184;p21"/>
           <p:cNvSpPr txBox="1"/>
           <p:nvPr/>
         </p:nvSpPr>
@@ -15104,7 +17305,7 @@
       </p:sp>
       <p:sp>
         <p:nvSpPr>
-          <p:cNvPr id="171" name="Google Shape;171;p15"/>
+          <p:cNvPr id="185" name="Google Shape;185;p21"/>
           <p:cNvSpPr txBox="1"/>
           <p:nvPr/>
         </p:nvSpPr>
@@ -15154,7 +17355,7 @@
       </p:sp>
       <p:sp>
         <p:nvSpPr>
-          <p:cNvPr id="172" name="Google Shape;172;p15"/>
+          <p:cNvPr id="186" name="Google Shape;186;p21"/>
           <p:cNvSpPr txBox="1"/>
           <p:nvPr/>
         </p:nvSpPr>
@@ -15204,7 +17405,7 @@
       </p:sp>
       <p:sp>
         <p:nvSpPr>
-          <p:cNvPr id="173" name="Google Shape;173;p15"/>
+          <p:cNvPr id="187" name="Google Shape;187;p21"/>
           <p:cNvSpPr txBox="1"/>
           <p:nvPr/>
         </p:nvSpPr>
@@ -15254,7 +17455,7 @@
       </p:sp>
       <p:sp>
         <p:nvSpPr>
-          <p:cNvPr id="174" name="Google Shape;174;p15"/>
+          <p:cNvPr id="188" name="Google Shape;188;p21"/>
           <p:cNvSpPr txBox="1"/>
           <p:nvPr/>
         </p:nvSpPr>
@@ -15304,7 +17505,7 @@
       </p:sp>
       <p:sp>
         <p:nvSpPr>
-          <p:cNvPr id="175" name="Google Shape;175;p15"/>
+          <p:cNvPr id="189" name="Google Shape;189;p21"/>
           <p:cNvSpPr txBox="1"/>
           <p:nvPr/>
         </p:nvSpPr>
@@ -15354,7 +17555,7 @@
       </p:sp>
       <p:sp>
         <p:nvSpPr>
-          <p:cNvPr id="176" name="Google Shape;176;p15"/>
+          <p:cNvPr id="190" name="Google Shape;190;p21"/>
           <p:cNvSpPr txBox="1"/>
           <p:nvPr/>
         </p:nvSpPr>
@@ -15416,7 +17617,7 @@
       </p:sp>
       <p:sp>
         <p:nvSpPr>
-          <p:cNvPr id="177" name="Google Shape;177;p15"/>
+          <p:cNvPr id="191" name="Google Shape;191;p21"/>
           <p:cNvSpPr/>
           <p:nvPr/>
         </p:nvSpPr>
@@ -15467,7 +17668,7 @@
       </p:sp>
       <p:sp>
         <p:nvSpPr>
-          <p:cNvPr id="178" name="Google Shape;178;p15"/>
+          <p:cNvPr id="192" name="Google Shape;192;p21"/>
           <p:cNvSpPr txBox="1"/>
           <p:nvPr/>
         </p:nvSpPr>
@@ -15517,7 +17718,7 @@
       </p:sp>
       <p:sp>
         <p:nvSpPr>
-          <p:cNvPr id="179" name="Google Shape;179;p15"/>
+          <p:cNvPr id="193" name="Google Shape;193;p21"/>
           <p:cNvSpPr txBox="1"/>
           <p:nvPr/>
         </p:nvSpPr>
@@ -15581,7 +17782,7 @@
 </p:sld>
 </file>
 
-<file path=ppt/slides/slide4.xml><?xml version="1.0" encoding="utf-8"?>
+<file path=ppt/slides/slide6.xml><?xml version="1.0" encoding="utf-8"?>
 <p:sld xmlns:a="http://schemas.openxmlformats.org/drawingml/2006/main" xmlns:r="http://schemas.openxmlformats.org/officeDocument/2006/relationships" xmlns:mc="http://schemas.openxmlformats.org/markup-compatibility/2006" xmlns:mv="urn:schemas-microsoft-com:mac:vml" xmlns:p="http://schemas.openxmlformats.org/presentationml/2006/main" xmlns:c="http://schemas.openxmlformats.org/drawingml/2006/chart" xmlns:dgm="http://schemas.openxmlformats.org/drawingml/2006/diagram" xmlns:o="urn:schemas-microsoft-com:office:office" xmlns:v="urn:schemas-microsoft-com:vml" xmlns:pvml="urn:schemas-microsoft-com:office:powerpoint" xmlns:com="http://schemas.openxmlformats.org/drawingml/2006/compatibility" xmlns:p14="http://schemas.microsoft.com/office/powerpoint/2010/main" xmlns:p15="http://schemas.microsoft.com/office/powerpoint/2012/main" xmlns:ahyp="http://schemas.microsoft.com/office/drawing/2018/hyperlinkcolor">
   <p:cSld>
     <p:bg>
@@ -15593,7 +17794,7 @@
     </p:bg>
     <p:spTree>
       <p:nvGrpSpPr>
-        <p:cNvPr id="183" name="Shape 183"/>
+        <p:cNvPr id="197" name="Shape 197"/>
         <p:cNvGrpSpPr/>
         <p:nvPr/>
       </p:nvGrpSpPr>
@@ -15607,7 +17808,7 @@
       </p:grpSpPr>
       <p:sp>
         <p:nvSpPr>
-          <p:cNvPr id="184" name="Google Shape;184;p16"/>
+          <p:cNvPr id="198" name="Google Shape;198;p22"/>
           <p:cNvSpPr txBox="1"/>
           <p:nvPr/>
         </p:nvSpPr>
@@ -15657,7 +17858,7 @@
       </p:sp>
       <p:sp>
         <p:nvSpPr>
-          <p:cNvPr id="185" name="Google Shape;185;p16"/>
+          <p:cNvPr id="199" name="Google Shape;199;p22"/>
           <p:cNvSpPr txBox="1"/>
           <p:nvPr/>
         </p:nvSpPr>
@@ -15727,7 +17928,7 @@
       </p:sp>
       <p:sp>
         <p:nvSpPr>
-          <p:cNvPr id="186" name="Google Shape;186;p16"/>
+          <p:cNvPr id="200" name="Google Shape;200;p22"/>
           <p:cNvSpPr/>
           <p:nvPr/>
         </p:nvSpPr>
@@ -15778,7 +17979,7 @@
       </p:sp>
       <p:sp>
         <p:nvSpPr>
-          <p:cNvPr id="187" name="Google Shape;187;p16"/>
+          <p:cNvPr id="201" name="Google Shape;201;p22"/>
           <p:cNvSpPr txBox="1"/>
           <p:nvPr/>
         </p:nvSpPr>
@@ -15836,7 +18037,7 @@
       </p:sp>
       <p:sp>
         <p:nvSpPr>
-          <p:cNvPr id="188" name="Google Shape;188;p16"/>
+          <p:cNvPr id="202" name="Google Shape;202;p22"/>
           <p:cNvSpPr txBox="1"/>
           <p:nvPr/>
         </p:nvSpPr>
@@ -15898,7 +18099,7 @@
       </p:sp>
       <p:sp>
         <p:nvSpPr>
-          <p:cNvPr id="189" name="Google Shape;189;p16"/>
+          <p:cNvPr id="203" name="Google Shape;203;p22"/>
           <p:cNvSpPr txBox="1"/>
           <p:nvPr/>
         </p:nvSpPr>
@@ -15948,7 +18149,7 @@
       </p:sp>
       <p:sp>
         <p:nvSpPr>
-          <p:cNvPr id="190" name="Google Shape;190;p16"/>
+          <p:cNvPr id="204" name="Google Shape;204;p22"/>
           <p:cNvSpPr txBox="1"/>
           <p:nvPr/>
         </p:nvSpPr>
@@ -15998,7 +18199,7 @@
       </p:sp>
       <p:sp>
         <p:nvSpPr>
-          <p:cNvPr id="191" name="Google Shape;191;p16"/>
+          <p:cNvPr id="205" name="Google Shape;205;p22"/>
           <p:cNvSpPr txBox="1"/>
           <p:nvPr/>
         </p:nvSpPr>
@@ -16048,7 +18249,7 @@
       </p:sp>
       <p:sp>
         <p:nvSpPr>
-          <p:cNvPr id="192" name="Google Shape;192;p16"/>
+          <p:cNvPr id="206" name="Google Shape;206;p22"/>
           <p:cNvSpPr txBox="1"/>
           <p:nvPr/>
         </p:nvSpPr>
@@ -16098,7 +18299,7 @@
       </p:sp>
       <p:sp>
         <p:nvSpPr>
-          <p:cNvPr id="193" name="Google Shape;193;p16"/>
+          <p:cNvPr id="207" name="Google Shape;207;p22"/>
           <p:cNvSpPr txBox="1"/>
           <p:nvPr/>
         </p:nvSpPr>
@@ -16148,7 +18349,7 @@
       </p:sp>
       <p:sp>
         <p:nvSpPr>
-          <p:cNvPr id="194" name="Google Shape;194;p16"/>
+          <p:cNvPr id="208" name="Google Shape;208;p22"/>
           <p:cNvSpPr txBox="1"/>
           <p:nvPr/>
         </p:nvSpPr>
@@ -16198,7 +18399,7 @@
       </p:sp>
       <p:sp>
         <p:nvSpPr>
-          <p:cNvPr id="195" name="Google Shape;195;p16"/>
+          <p:cNvPr id="209" name="Google Shape;209;p22"/>
           <p:cNvSpPr txBox="1"/>
           <p:nvPr/>
         </p:nvSpPr>
@@ -16248,7 +18449,7 @@
       </p:sp>
       <p:sp>
         <p:nvSpPr>
-          <p:cNvPr id="196" name="Google Shape;196;p16"/>
+          <p:cNvPr id="210" name="Google Shape;210;p22"/>
           <p:cNvSpPr txBox="1"/>
           <p:nvPr/>
         </p:nvSpPr>
@@ -16298,7 +18499,7 @@
       </p:sp>
       <p:sp>
         <p:nvSpPr>
-          <p:cNvPr id="197" name="Google Shape;197;p16"/>
+          <p:cNvPr id="211" name="Google Shape;211;p22"/>
           <p:cNvSpPr/>
           <p:nvPr/>
         </p:nvSpPr>
@@ -16355,7 +18556,7 @@
       </p:sp>
       <p:sp>
         <p:nvSpPr>
-          <p:cNvPr id="198" name="Google Shape;198;p16"/>
+          <p:cNvPr id="212" name="Google Shape;212;p22"/>
           <p:cNvSpPr txBox="1"/>
           <p:nvPr/>
         </p:nvSpPr>
@@ -16405,7 +18606,7 @@
       </p:sp>
       <p:sp>
         <p:nvSpPr>
-          <p:cNvPr id="199" name="Google Shape;199;p16"/>
+          <p:cNvPr id="213" name="Google Shape;213;p22"/>
           <p:cNvSpPr/>
           <p:nvPr/>
         </p:nvSpPr>
@@ -16456,7 +18657,7 @@
       </p:sp>
       <p:pic>
         <p:nvPicPr>
-          <p:cNvPr descr="image.png" id="200" name="Google Shape;200;p16"/>
+          <p:cNvPr descr="image.png" id="214" name="Google Shape;214;p22"/>
           <p:cNvPicPr preferRelativeResize="0"/>
           <p:nvPr/>
         </p:nvPicPr>
@@ -16483,7 +18684,7 @@
       </p:pic>
       <p:sp>
         <p:nvSpPr>
-          <p:cNvPr id="201" name="Google Shape;201;p16"/>
+          <p:cNvPr id="215" name="Google Shape;215;p22"/>
           <p:cNvSpPr txBox="1"/>
           <p:nvPr/>
         </p:nvSpPr>
@@ -16533,7 +18734,7 @@
       </p:sp>
       <p:sp>
         <p:nvSpPr>
-          <p:cNvPr id="202" name="Google Shape;202;p16"/>
+          <p:cNvPr id="216" name="Google Shape;216;p22"/>
           <p:cNvSpPr/>
           <p:nvPr/>
         </p:nvSpPr>
@@ -16584,7 +18785,7 @@
       </p:sp>
       <p:sp>
         <p:nvSpPr>
-          <p:cNvPr id="203" name="Google Shape;203;p16"/>
+          <p:cNvPr id="217" name="Google Shape;217;p22"/>
           <p:cNvSpPr txBox="1"/>
           <p:nvPr/>
         </p:nvSpPr>
@@ -16634,7 +18835,7 @@
       </p:sp>
       <p:sp>
         <p:nvSpPr>
-          <p:cNvPr id="204" name="Google Shape;204;p16"/>
+          <p:cNvPr id="218" name="Google Shape;218;p22"/>
           <p:cNvSpPr txBox="1"/>
           <p:nvPr/>
         </p:nvSpPr>
@@ -16698,7 +18899,590 @@
 </p:sld>
 </file>
 
+<file path=ppt/slides/slide7.xml><?xml version="1.0" encoding="utf-8"?>
+<p:sld xmlns:a="http://schemas.openxmlformats.org/drawingml/2006/main" xmlns:r="http://schemas.openxmlformats.org/officeDocument/2006/relationships" xmlns:mc="http://schemas.openxmlformats.org/markup-compatibility/2006" xmlns:mv="urn:schemas-microsoft-com:mac:vml" xmlns:p="http://schemas.openxmlformats.org/presentationml/2006/main" xmlns:c="http://schemas.openxmlformats.org/drawingml/2006/chart" xmlns:dgm="http://schemas.openxmlformats.org/drawingml/2006/diagram" xmlns:o="urn:schemas-microsoft-com:office:office" xmlns:v="urn:schemas-microsoft-com:vml" xmlns:pvml="urn:schemas-microsoft-com:office:powerpoint" xmlns:com="http://schemas.openxmlformats.org/drawingml/2006/compatibility" xmlns:p14="http://schemas.microsoft.com/office/powerpoint/2010/main" xmlns:p15="http://schemas.microsoft.com/office/powerpoint/2012/main" xmlns:ahyp="http://schemas.microsoft.com/office/drawing/2018/hyperlinkcolor">
+  <p:cSld>
+    <p:spTree>
+      <p:nvGrpSpPr>
+        <p:cNvPr id="222" name="Shape 222"/>
+        <p:cNvGrpSpPr/>
+        <p:nvPr/>
+      </p:nvGrpSpPr>
+      <p:grpSpPr>
+        <a:xfrm>
+          <a:off x="0" y="0"/>
+          <a:ext cx="0" cy="0"/>
+          <a:chOff x="0" y="0"/>
+          <a:chExt cx="0" cy="0"/>
+        </a:xfrm>
+      </p:grpSpPr>
+    </p:spTree>
+  </p:cSld>
+  <p:clrMapOvr>
+    <a:masterClrMapping/>
+  </p:clrMapOvr>
+</p:sld>
+</file>
+
 <file path=ppt/theme/theme1.xml><?xml version="1.0" encoding="utf-8"?>
+<a:theme xmlns:a="http://schemas.openxmlformats.org/drawingml/2006/main" xmlns:r="http://schemas.openxmlformats.org/officeDocument/2006/relationships" name="Office Theme">
+  <a:themeElements>
+    <a:clrScheme name="Office">
+      <a:dk1>
+        <a:srgbClr val="000000"/>
+      </a:dk1>
+      <a:lt1>
+        <a:srgbClr val="FFFFFF"/>
+      </a:lt1>
+      <a:dk2>
+        <a:srgbClr val="1F497D"/>
+      </a:dk2>
+      <a:lt2>
+        <a:srgbClr val="EEECE1"/>
+      </a:lt2>
+      <a:accent1>
+        <a:srgbClr val="4F81BD"/>
+      </a:accent1>
+      <a:accent2>
+        <a:srgbClr val="C0504D"/>
+      </a:accent2>
+      <a:accent3>
+        <a:srgbClr val="9BBB59"/>
+      </a:accent3>
+      <a:accent4>
+        <a:srgbClr val="8064A2"/>
+      </a:accent4>
+      <a:accent5>
+        <a:srgbClr val="4BACC6"/>
+      </a:accent5>
+      <a:accent6>
+        <a:srgbClr val="F79646"/>
+      </a:accent6>
+      <a:hlink>
+        <a:srgbClr val="0000FF"/>
+      </a:hlink>
+      <a:folHlink>
+        <a:srgbClr val="800080"/>
+      </a:folHlink>
+    </a:clrScheme>
+    <a:fontScheme name="Office">
+      <a:majorFont>
+        <a:latin typeface="Arial"/>
+        <a:ea typeface=""/>
+        <a:cs typeface=""/>
+        <a:font script="Jpan" typeface="ＭＳ Ｐゴシック"/>
+        <a:font script="Hang" typeface="맑은 고딕"/>
+        <a:font script="Hans" typeface="宋体"/>
+        <a:font script="Hant" typeface="新細明體"/>
+        <a:font script="Arab" typeface="Times New Roman"/>
+        <a:font script="Hebr" typeface="Times New Roman"/>
+        <a:font script="Thai" typeface="Angsana New"/>
+        <a:font script="Ethi" typeface="Nyala"/>
+        <a:font script="Beng" typeface="Vrinda"/>
+        <a:font script="Gujr" typeface="Shruti"/>
+        <a:font script="Khmr" typeface="MoolBoran"/>
+        <a:font script="Knda" typeface="Tunga"/>
+        <a:font script="Guru" typeface="Raavi"/>
+        <a:font script="Cans" typeface="Euphemia"/>
+        <a:font script="Cher" typeface="Plantagenet Cherokee"/>
+        <a:font script="Yiii" typeface="Microsoft Yi Baiti"/>
+        <a:font script="Tibt" typeface="Microsoft Himalaya"/>
+        <a:font script="Thaa" typeface="MV Boli"/>
+        <a:font script="Deva" typeface="Mangal"/>
+        <a:font script="Telu" typeface="Gautami"/>
+        <a:font script="Taml" typeface="Latha"/>
+        <a:font script="Syrc" typeface="Estrangelo Edessa"/>
+        <a:font script="Orya" typeface="Kalinga"/>
+        <a:font script="Mlym" typeface="Kartika"/>
+        <a:font script="Laoo" typeface="DokChampa"/>
+        <a:font script="Sinh" typeface="Iskoola Pota"/>
+        <a:font script="Mong" typeface="Mongolian Baiti"/>
+        <a:font script="Viet" typeface="Times New Roman"/>
+        <a:font script="Uigh" typeface="Microsoft Uighur"/>
+        <a:font script="Geor" typeface="Sylfaen"/>
+      </a:majorFont>
+      <a:minorFont>
+        <a:latin typeface="Arial"/>
+        <a:ea typeface=""/>
+        <a:cs typeface=""/>
+        <a:font script="Jpan" typeface="ＭＳ Ｐゴシック"/>
+        <a:font script="Hang" typeface="맑은 고딕"/>
+        <a:font script="Hans" typeface="宋体"/>
+        <a:font script="Hant" typeface="新細明體"/>
+        <a:font script="Arab" typeface="Arial"/>
+        <a:font script="Hebr" typeface="Arial"/>
+        <a:font script="Thai" typeface="Cordia New"/>
+        <a:font script="Ethi" typeface="Nyala"/>
+        <a:font script="Beng" typeface="Vrinda"/>
+        <a:font script="Gujr" typeface="Shruti"/>
+        <a:font script="Khmr" typeface="DaunPenh"/>
+        <a:font script="Knda" typeface="Tunga"/>
+        <a:font script="Guru" typeface="Raavi"/>
+        <a:font script="Cans" typeface="Euphemia"/>
+        <a:font script="Cher" typeface="Plantagenet Cherokee"/>
+        <a:font script="Yiii" typeface="Microsoft Yi Baiti"/>
+        <a:font script="Tibt" typeface="Microsoft Himalaya"/>
+        <a:font script="Thaa" typeface="MV Boli"/>
+        <a:font script="Deva" typeface="Mangal"/>
+        <a:font script="Telu" typeface="Gautami"/>
+        <a:font script="Taml" typeface="Latha"/>
+        <a:font script="Syrc" typeface="Estrangelo Edessa"/>
+        <a:font script="Orya" typeface="Kalinga"/>
+        <a:font script="Mlym" typeface="Kartika"/>
+        <a:font script="Laoo" typeface="DokChampa"/>
+        <a:font script="Sinh" typeface="Iskoola Pota"/>
+        <a:font script="Mong" typeface="Mongolian Baiti"/>
+        <a:font script="Viet" typeface="Arial"/>
+        <a:font script="Uigh" typeface="Microsoft Uighur"/>
+        <a:font script="Geor" typeface="Sylfaen"/>
+      </a:minorFont>
+    </a:fontScheme>
+    <a:fmtScheme name="Office">
+      <a:fillStyleLst>
+        <a:solidFill>
+          <a:schemeClr val="phClr"/>
+        </a:solidFill>
+        <a:gradFill rotWithShape="1">
+          <a:gsLst>
+            <a:gs pos="0">
+              <a:schemeClr val="phClr">
+                <a:tint val="50000"/>
+                <a:satMod val="300000"/>
+              </a:schemeClr>
+            </a:gs>
+            <a:gs pos="35000">
+              <a:schemeClr val="phClr">
+                <a:tint val="37000"/>
+                <a:satMod val="300000"/>
+              </a:schemeClr>
+            </a:gs>
+            <a:gs pos="100000">
+              <a:schemeClr val="phClr">
+                <a:tint val="15000"/>
+                <a:satMod val="350000"/>
+              </a:schemeClr>
+            </a:gs>
+          </a:gsLst>
+          <a:lin ang="16200000" scaled="1"/>
+        </a:gradFill>
+        <a:gradFill rotWithShape="1">
+          <a:gsLst>
+            <a:gs pos="0">
+              <a:schemeClr val="phClr">
+                <a:tint val="100000"/>
+                <a:shade val="100000"/>
+                <a:satMod val="130000"/>
+              </a:schemeClr>
+            </a:gs>
+            <a:gs pos="100000">
+              <a:schemeClr val="phClr">
+                <a:tint val="50000"/>
+                <a:shade val="100000"/>
+                <a:satMod val="350000"/>
+              </a:schemeClr>
+            </a:gs>
+          </a:gsLst>
+          <a:lin ang="16200000" scaled="0"/>
+        </a:gradFill>
+      </a:fillStyleLst>
+      <a:lnStyleLst>
+        <a:ln w="9525" cap="flat" cmpd="sng" algn="ctr">
+          <a:solidFill>
+            <a:schemeClr val="phClr">
+              <a:shade val="95000"/>
+              <a:satMod val="105000"/>
+            </a:schemeClr>
+          </a:solidFill>
+          <a:prstDash val="solid"/>
+        </a:ln>
+        <a:ln w="25400" cap="flat" cmpd="sng" algn="ctr">
+          <a:solidFill>
+            <a:schemeClr val="phClr"/>
+          </a:solidFill>
+          <a:prstDash val="solid"/>
+        </a:ln>
+        <a:ln w="38100" cap="flat" cmpd="sng" algn="ctr">
+          <a:solidFill>
+            <a:schemeClr val="phClr"/>
+          </a:solidFill>
+          <a:prstDash val="solid"/>
+        </a:ln>
+      </a:lnStyleLst>
+      <a:effectStyleLst>
+        <a:effectStyle>
+          <a:effectLst>
+            <a:outerShdw blurRad="40000" dist="20000" dir="5400000" rotWithShape="0">
+              <a:srgbClr val="000000">
+                <a:alpha val="38000"/>
+              </a:srgbClr>
+            </a:outerShdw>
+          </a:effectLst>
+        </a:effectStyle>
+        <a:effectStyle>
+          <a:effectLst>
+            <a:outerShdw blurRad="40000" dist="23000" dir="5400000" rotWithShape="0">
+              <a:srgbClr val="000000">
+                <a:alpha val="35000"/>
+              </a:srgbClr>
+            </a:outerShdw>
+          </a:effectLst>
+        </a:effectStyle>
+        <a:effectStyle>
+          <a:effectLst>
+            <a:outerShdw blurRad="40000" dist="23000" dir="5400000" rotWithShape="0">
+              <a:srgbClr val="000000">
+                <a:alpha val="35000"/>
+              </a:srgbClr>
+            </a:outerShdw>
+          </a:effectLst>
+          <a:scene3d>
+            <a:camera prst="orthographicFront">
+              <a:rot lat="0" lon="0" rev="0"/>
+            </a:camera>
+            <a:lightRig rig="threePt" dir="t">
+              <a:rot lat="0" lon="0" rev="1200000"/>
+            </a:lightRig>
+          </a:scene3d>
+          <a:sp3d>
+            <a:bevelT w="63500" h="25400"/>
+          </a:sp3d>
+        </a:effectStyle>
+      </a:effectStyleLst>
+      <a:bgFillStyleLst>
+        <a:solidFill>
+          <a:schemeClr val="phClr"/>
+        </a:solidFill>
+        <a:gradFill rotWithShape="1">
+          <a:gsLst>
+            <a:gs pos="0">
+              <a:schemeClr val="phClr">
+                <a:tint val="40000"/>
+                <a:satMod val="350000"/>
+              </a:schemeClr>
+            </a:gs>
+            <a:gs pos="40000">
+              <a:schemeClr val="phClr">
+                <a:tint val="45000"/>
+                <a:shade val="99000"/>
+                <a:satMod val="350000"/>
+              </a:schemeClr>
+            </a:gs>
+            <a:gs pos="100000">
+              <a:schemeClr val="phClr">
+                <a:shade val="20000"/>
+                <a:satMod val="255000"/>
+              </a:schemeClr>
+            </a:gs>
+          </a:gsLst>
+          <a:path path="circle">
+            <a:fillToRect l="50000" t="-80000" r="50000" b="180000"/>
+          </a:path>
+        </a:gradFill>
+        <a:gradFill rotWithShape="1">
+          <a:gsLst>
+            <a:gs pos="0">
+              <a:schemeClr val="phClr">
+                <a:tint val="80000"/>
+                <a:satMod val="300000"/>
+              </a:schemeClr>
+            </a:gs>
+            <a:gs pos="100000">
+              <a:schemeClr val="phClr">
+                <a:shade val="30000"/>
+                <a:satMod val="200000"/>
+              </a:schemeClr>
+            </a:gs>
+          </a:gsLst>
+          <a:path path="circle">
+            <a:fillToRect l="50000" t="50000" r="50000" b="50000"/>
+          </a:path>
+        </a:gradFill>
+      </a:bgFillStyleLst>
+    </a:fmtScheme>
+  </a:themeElements>
+</a:theme>
+</file>
+
+<file path=ppt/theme/theme2.xml><?xml version="1.0" encoding="utf-8"?>
+<a:theme xmlns:a="http://schemas.openxmlformats.org/drawingml/2006/main" xmlns:r="http://schemas.openxmlformats.org/officeDocument/2006/relationships" name="2_自定义设计方案">
+  <a:themeElements>
+    <a:clrScheme name="Office">
+      <a:dk1>
+        <a:srgbClr val="000000"/>
+      </a:dk1>
+      <a:lt1>
+        <a:srgbClr val="FFFFFF"/>
+      </a:lt1>
+      <a:dk2>
+        <a:srgbClr val="44546A"/>
+      </a:dk2>
+      <a:lt2>
+        <a:srgbClr val="E7E6E6"/>
+      </a:lt2>
+      <a:accent1>
+        <a:srgbClr val="4472C4"/>
+      </a:accent1>
+      <a:accent2>
+        <a:srgbClr val="ED7D31"/>
+      </a:accent2>
+      <a:accent3>
+        <a:srgbClr val="A5A5A5"/>
+      </a:accent3>
+      <a:accent4>
+        <a:srgbClr val="FFC000"/>
+      </a:accent4>
+      <a:accent5>
+        <a:srgbClr val="5B9BD5"/>
+      </a:accent5>
+      <a:accent6>
+        <a:srgbClr val="70AD47"/>
+      </a:accent6>
+      <a:hlink>
+        <a:srgbClr val="0563C1"/>
+      </a:hlink>
+      <a:folHlink>
+        <a:srgbClr val="954F72"/>
+      </a:folHlink>
+    </a:clrScheme>
+    <a:fontScheme name="Office">
+      <a:majorFont>
+        <a:latin typeface="Arial"/>
+        <a:ea typeface=""/>
+        <a:cs typeface=""/>
+        <a:font script="Jpan" typeface="ＭＳ Ｐゴシック"/>
+        <a:font script="Hang" typeface="맑은 고딕"/>
+        <a:font script="Hans" typeface="宋体"/>
+        <a:font script="Hant" typeface="新細明體"/>
+        <a:font script="Arab" typeface="Times New Roman"/>
+        <a:font script="Hebr" typeface="Times New Roman"/>
+        <a:font script="Thai" typeface="Angsana New"/>
+        <a:font script="Ethi" typeface="Nyala"/>
+        <a:font script="Beng" typeface="Vrinda"/>
+        <a:font script="Gujr" typeface="Shruti"/>
+        <a:font script="Khmr" typeface="MoolBoran"/>
+        <a:font script="Knda" typeface="Tunga"/>
+        <a:font script="Guru" typeface="Raavi"/>
+        <a:font script="Cans" typeface="Euphemia"/>
+        <a:font script="Cher" typeface="Plantagenet Cherokee"/>
+        <a:font script="Yiii" typeface="Microsoft Yi Baiti"/>
+        <a:font script="Tibt" typeface="Microsoft Himalaya"/>
+        <a:font script="Thaa" typeface="MV Boli"/>
+        <a:font script="Deva" typeface="Mangal"/>
+        <a:font script="Telu" typeface="Gautami"/>
+        <a:font script="Taml" typeface="Latha"/>
+        <a:font script="Syrc" typeface="Estrangelo Edessa"/>
+        <a:font script="Orya" typeface="Kalinga"/>
+        <a:font script="Mlym" typeface="Kartika"/>
+        <a:font script="Laoo" typeface="DokChampa"/>
+        <a:font script="Sinh" typeface="Iskoola Pota"/>
+        <a:font script="Mong" typeface="Mongolian Baiti"/>
+        <a:font script="Viet" typeface="Times New Roman"/>
+        <a:font script="Uigh" typeface="Microsoft Uighur"/>
+        <a:font script="Geor" typeface="Sylfaen"/>
+      </a:majorFont>
+      <a:minorFont>
+        <a:latin typeface="Arial"/>
+        <a:ea typeface=""/>
+        <a:cs typeface=""/>
+        <a:font script="Jpan" typeface="ＭＳ Ｐゴシック"/>
+        <a:font script="Hang" typeface="맑은 고딕"/>
+        <a:font script="Hans" typeface="宋体"/>
+        <a:font script="Hant" typeface="新細明體"/>
+        <a:font script="Arab" typeface="Arial"/>
+        <a:font script="Hebr" typeface="Arial"/>
+        <a:font script="Thai" typeface="Cordia New"/>
+        <a:font script="Ethi" typeface="Nyala"/>
+        <a:font script="Beng" typeface="Vrinda"/>
+        <a:font script="Gujr" typeface="Shruti"/>
+        <a:font script="Khmr" typeface="DaunPenh"/>
+        <a:font script="Knda" typeface="Tunga"/>
+        <a:font script="Guru" typeface="Raavi"/>
+        <a:font script="Cans" typeface="Euphemia"/>
+        <a:font script="Cher" typeface="Plantagenet Cherokee"/>
+        <a:font script="Yiii" typeface="Microsoft Yi Baiti"/>
+        <a:font script="Tibt" typeface="Microsoft Himalaya"/>
+        <a:font script="Thaa" typeface="MV Boli"/>
+        <a:font script="Deva" typeface="Mangal"/>
+        <a:font script="Telu" typeface="Gautami"/>
+        <a:font script="Taml" typeface="Latha"/>
+        <a:font script="Syrc" typeface="Estrangelo Edessa"/>
+        <a:font script="Orya" typeface="Kalinga"/>
+        <a:font script="Mlym" typeface="Kartika"/>
+        <a:font script="Laoo" typeface="DokChampa"/>
+        <a:font script="Sinh" typeface="Iskoola Pota"/>
+        <a:font script="Mong" typeface="Mongolian Baiti"/>
+        <a:font script="Viet" typeface="Arial"/>
+        <a:font script="Uigh" typeface="Microsoft Uighur"/>
+        <a:font script="Geor" typeface="Sylfaen"/>
+      </a:minorFont>
+    </a:fontScheme>
+    <a:fmtScheme name="Office">
+      <a:fillStyleLst>
+        <a:solidFill>
+          <a:schemeClr val="phClr"/>
+        </a:solidFill>
+        <a:gradFill rotWithShape="1">
+          <a:gsLst>
+            <a:gs pos="0">
+              <a:schemeClr val="phClr">
+                <a:tint val="50000"/>
+                <a:satMod val="300000"/>
+              </a:schemeClr>
+            </a:gs>
+            <a:gs pos="35000">
+              <a:schemeClr val="phClr">
+                <a:tint val="37000"/>
+                <a:satMod val="300000"/>
+              </a:schemeClr>
+            </a:gs>
+            <a:gs pos="100000">
+              <a:schemeClr val="phClr">
+                <a:tint val="15000"/>
+                <a:satMod val="350000"/>
+              </a:schemeClr>
+            </a:gs>
+          </a:gsLst>
+          <a:lin ang="16200000" scaled="1"/>
+        </a:gradFill>
+        <a:gradFill rotWithShape="1">
+          <a:gsLst>
+            <a:gs pos="0">
+              <a:schemeClr val="phClr">
+                <a:tint val="100000"/>
+                <a:shade val="100000"/>
+                <a:satMod val="130000"/>
+              </a:schemeClr>
+            </a:gs>
+            <a:gs pos="100000">
+              <a:schemeClr val="phClr">
+                <a:tint val="50000"/>
+                <a:shade val="100000"/>
+                <a:satMod val="350000"/>
+              </a:schemeClr>
+            </a:gs>
+          </a:gsLst>
+          <a:lin ang="16200000" scaled="0"/>
+        </a:gradFill>
+      </a:fillStyleLst>
+      <a:lnStyleLst>
+        <a:ln w="9525" cap="flat" cmpd="sng" algn="ctr">
+          <a:solidFill>
+            <a:schemeClr val="phClr">
+              <a:shade val="95000"/>
+              <a:satMod val="105000"/>
+            </a:schemeClr>
+          </a:solidFill>
+          <a:prstDash val="solid"/>
+        </a:ln>
+        <a:ln w="25400" cap="flat" cmpd="sng" algn="ctr">
+          <a:solidFill>
+            <a:schemeClr val="phClr"/>
+          </a:solidFill>
+          <a:prstDash val="solid"/>
+        </a:ln>
+        <a:ln w="38100" cap="flat" cmpd="sng" algn="ctr">
+          <a:solidFill>
+            <a:schemeClr val="phClr"/>
+          </a:solidFill>
+          <a:prstDash val="solid"/>
+        </a:ln>
+      </a:lnStyleLst>
+      <a:effectStyleLst>
+        <a:effectStyle>
+          <a:effectLst>
+            <a:outerShdw blurRad="40000" dist="20000" dir="5400000" rotWithShape="0">
+              <a:srgbClr val="000000">
+                <a:alpha val="38000"/>
+              </a:srgbClr>
+            </a:outerShdw>
+          </a:effectLst>
+        </a:effectStyle>
+        <a:effectStyle>
+          <a:effectLst>
+            <a:outerShdw blurRad="40000" dist="23000" dir="5400000" rotWithShape="0">
+              <a:srgbClr val="000000">
+                <a:alpha val="35000"/>
+              </a:srgbClr>
+            </a:outerShdw>
+          </a:effectLst>
+        </a:effectStyle>
+        <a:effectStyle>
+          <a:effectLst>
+            <a:outerShdw blurRad="40000" dist="23000" dir="5400000" rotWithShape="0">
+              <a:srgbClr val="000000">
+                <a:alpha val="35000"/>
+              </a:srgbClr>
+            </a:outerShdw>
+          </a:effectLst>
+          <a:scene3d>
+            <a:camera prst="orthographicFront">
+              <a:rot lat="0" lon="0" rev="0"/>
+            </a:camera>
+            <a:lightRig rig="threePt" dir="t">
+              <a:rot lat="0" lon="0" rev="1200000"/>
+            </a:lightRig>
+          </a:scene3d>
+          <a:sp3d>
+            <a:bevelT w="63500" h="25400"/>
+          </a:sp3d>
+        </a:effectStyle>
+      </a:effectStyleLst>
+      <a:bgFillStyleLst>
+        <a:solidFill>
+          <a:schemeClr val="phClr"/>
+        </a:solidFill>
+        <a:gradFill rotWithShape="1">
+          <a:gsLst>
+            <a:gs pos="0">
+              <a:schemeClr val="phClr">
+                <a:tint val="40000"/>
+                <a:satMod val="350000"/>
+              </a:schemeClr>
+            </a:gs>
+            <a:gs pos="40000">
+              <a:schemeClr val="phClr">
+                <a:tint val="45000"/>
+                <a:shade val="99000"/>
+                <a:satMod val="350000"/>
+              </a:schemeClr>
+            </a:gs>
+            <a:gs pos="100000">
+              <a:schemeClr val="phClr">
+                <a:shade val="20000"/>
+                <a:satMod val="255000"/>
+              </a:schemeClr>
+            </a:gs>
+          </a:gsLst>
+          <a:path path="circle">
+            <a:fillToRect l="50000" t="-80000" r="50000" b="180000"/>
+          </a:path>
+        </a:gradFill>
+        <a:gradFill rotWithShape="1">
+          <a:gsLst>
+            <a:gs pos="0">
+              <a:schemeClr val="phClr">
+                <a:tint val="80000"/>
+                <a:satMod val="300000"/>
+              </a:schemeClr>
+            </a:gs>
+            <a:gs pos="100000">
+              <a:schemeClr val="phClr">
+                <a:shade val="30000"/>
+                <a:satMod val="200000"/>
+              </a:schemeClr>
+            </a:gs>
+          </a:gsLst>
+          <a:path path="circle">
+            <a:fillToRect l="50000" t="50000" r="50000" b="50000"/>
+          </a:path>
+        </a:gradFill>
+      </a:bgFillStyleLst>
+    </a:fmtScheme>
+  </a:themeElements>
+</a:theme>
+</file>
+
+<file path=ppt/theme/theme3.xml><?xml version="1.0" encoding="utf-8"?>
 <a:theme xmlns:a="http://schemas.openxmlformats.org/drawingml/2006/main" xmlns:r="http://schemas.openxmlformats.org/officeDocument/2006/relationships">
   <a:themeElements>
     <a:clrScheme name="Default">
@@ -16977,8 +19761,8 @@
 </a:theme>
 </file>
 
-<file path=ppt/theme/theme2.xml><?xml version="1.0" encoding="utf-8"?>
-<a:theme xmlns:a="http://schemas.openxmlformats.org/drawingml/2006/main" xmlns:r="http://schemas.openxmlformats.org/officeDocument/2006/relationships" name="Office Theme">
+<file path=ppt/theme/theme4.xml><?xml version="1.0" encoding="utf-8"?>
+<a:theme xmlns:a="http://schemas.openxmlformats.org/drawingml/2006/main" xmlns:r="http://schemas.openxmlformats.org/officeDocument/2006/relationships" name="1_自定义设计方案">
   <a:themeElements>
     <a:clrScheme name="Office">
       <a:dk1>
@@ -16988,34 +19772,34 @@
         <a:srgbClr val="FFFFFF"/>
       </a:lt1>
       <a:dk2>
-        <a:srgbClr val="1F497D"/>
+        <a:srgbClr val="44546A"/>
       </a:dk2>
       <a:lt2>
-        <a:srgbClr val="EEECE1"/>
+        <a:srgbClr val="E7E6E6"/>
       </a:lt2>
       <a:accent1>
-        <a:srgbClr val="4F81BD"/>
+        <a:srgbClr val="4472C4"/>
       </a:accent1>
       <a:accent2>
-        <a:srgbClr val="C0504D"/>
+        <a:srgbClr val="ED7D31"/>
       </a:accent2>
       <a:accent3>
-        <a:srgbClr val="9BBB59"/>
+        <a:srgbClr val="A5A5A5"/>
       </a:accent3>
       <a:accent4>
-        <a:srgbClr val="8064A2"/>
+        <a:srgbClr val="FFC000"/>
       </a:accent4>
       <a:accent5>
-        <a:srgbClr val="4BACC6"/>
+        <a:srgbClr val="5B9BD5"/>
       </a:accent5>
       <a:accent6>
-        <a:srgbClr val="F79646"/>
+        <a:srgbClr val="70AD47"/>
       </a:accent6>
       <a:hlink>
-        <a:srgbClr val="0000FF"/>
+        <a:srgbClr val="0563C1"/>
       </a:hlink>
       <a:folHlink>
-        <a:srgbClr val="800080"/>
+        <a:srgbClr val="954F72"/>
       </a:folHlink>
     </a:clrScheme>
     <a:fontScheme name="Office">

</xml_diff>